<commit_message>
Re-scope deck to Stage 1 (DB-focused, 9 slides)
Replace the three analysis-result slides with a single 'analysis plan' slide
(2단계 예고) so the deck matches Stage 1's scope: topic, data, DB design, data
input. Conclusion reframed as Stage 1 completion.

Co-Authored-By: Claude Opus 4.8 <noreply@anthropic.com>
Claude-Session: https://claude.ai/code/session_01A4Eo5QUsuZLdygCXtGqGtG
</commit_message>
<xml_diff>
--- a/diabetes_project_stage1.pptx
+++ b/diabetes_project_stage1.pptx
@@ -14,11 +14,9 @@
     <p:sldId id="262" r:id="rId8"/>
     <p:sldId id="263" r:id="rId9"/>
     <p:sldId id="264" r:id="rId10"/>
-    <p:sldId id="265" r:id="rId11"/>
-    <p:sldId id="266" r:id="rId12"/>
   </p:sldIdLst>
   <p:notesMasterIdLst>
-    <p:notesMasterId r:id="rId13"/>
+    <p:notesMasterId r:id="rId11"/>
   </p:notesMasterIdLst>
   <p:sldSz cx="12161520" cy="6858000"/>
   <p:notesSz cx="6858000" cy="12161520"/>
@@ -536,182 +534,6 @@
             <a:fld id="{F7021451-1387-4CA6-816F-3879F97B5CBC}" type="slidenum">
               <a:rPr lang="en-US"/>
               <a:t>1</a:t>
-            </a:fld>
-            <a:endParaRPr lang="en-US"/>
-          </a:p>
-        </p:txBody>
-      </p:sp>
-    </p:spTree>
-    <p:extLst>
-      <p:ext uri="{BB962C8B-B14F-4D97-AF65-F5344CB8AC3E}">
-        <p14:creationId xmlns:p14="http://schemas.microsoft.com/office/powerpoint/2010/main" val="1024086991"/>
-      </p:ext>
-    </p:extLst>
-  </p:cSld>
-  <p:clrMapOvr>
-    <a:masterClrMapping/>
-  </p:clrMapOvr>
-</p:notes>
-</file>
-
-<file path=ppt/notesSlides/notesSlide10.xml><?xml version="1.0" encoding="utf-8"?>
-<p:notes xmlns:a="http://schemas.openxmlformats.org/drawingml/2006/main" xmlns:r="http://schemas.openxmlformats.org/officeDocument/2006/relationships" xmlns:p="http://schemas.openxmlformats.org/presentationml/2006/main">
-  <p:cSld>
-    <p:spTree>
-      <p:nvGrpSpPr>
-        <p:cNvPr id="1" name=""/>
-        <p:cNvGrpSpPr/>
-        <p:nvPr/>
-      </p:nvGrpSpPr>
-      <p:grpSpPr>
-        <a:xfrm>
-          <a:off x="0" y="0"/>
-          <a:ext cx="0" cy="0"/>
-          <a:chOff x="0" y="0"/>
-          <a:chExt cx="0" cy="0"/>
-        </a:xfrm>
-      </p:grpSpPr>
-      <p:sp>
-        <p:nvSpPr>
-          <p:cNvPr id="2" name="Slide Image Placeholder 1"/>
-          <p:cNvSpPr>
-            <a:spLocks noGrp="1" noRot="1" noChangeAspect="1"/>
-          </p:cNvSpPr>
-          <p:nvPr>
-            <p:ph type="sldImg"/>
-          </p:nvPr>
-        </p:nvSpPr>
-        <p:spPr/>
-      </p:sp>
-      <p:sp>
-        <p:nvSpPr>
-          <p:cNvPr id="3" name="Notes Placeholder 2"/>
-          <p:cNvSpPr>
-            <a:spLocks noGrp="1"/>
-          </p:cNvSpPr>
-          <p:nvPr>
-            <p:ph type="body" idx="1"/>
-          </p:nvPr>
-        </p:nvSpPr>
-        <p:spPr/>
-        <p:txBody>
-          <a:bodyPr/>
-          <a:lstStyle/>
-          <a:p>
-            <a:r>
-              <a:rPr lang="en-US" dirty="0"/>
-              <a:t/>
-            </a:r>
-            <a:endParaRPr lang="en-US" dirty="0"/>
-          </a:p>
-        </p:txBody>
-      </p:sp>
-      <p:sp>
-        <p:nvSpPr>
-          <p:cNvPr id="4" name="Slide Number Placeholder 3"/>
-          <p:cNvSpPr>
-            <a:spLocks noGrp="1"/>
-          </p:cNvSpPr>
-          <p:nvPr>
-            <p:ph type="sldNum" sz="quarter" idx="10"/>
-          </p:nvPr>
-        </p:nvSpPr>
-        <p:spPr/>
-        <p:txBody>
-          <a:bodyPr/>
-          <a:lstStyle/>
-          <a:p>
-            <a:fld id="{F7021451-1387-4CA6-816F-3879F97B5CBC}" type="slidenum">
-              <a:rPr lang="en-US"/>
-              <a:t>10</a:t>
-            </a:fld>
-            <a:endParaRPr lang="en-US"/>
-          </a:p>
-        </p:txBody>
-      </p:sp>
-    </p:spTree>
-    <p:extLst>
-      <p:ext uri="{BB962C8B-B14F-4D97-AF65-F5344CB8AC3E}">
-        <p14:creationId xmlns:p14="http://schemas.microsoft.com/office/powerpoint/2010/main" val="1024086991"/>
-      </p:ext>
-    </p:extLst>
-  </p:cSld>
-  <p:clrMapOvr>
-    <a:masterClrMapping/>
-  </p:clrMapOvr>
-</p:notes>
-</file>
-
-<file path=ppt/notesSlides/notesSlide11.xml><?xml version="1.0" encoding="utf-8"?>
-<p:notes xmlns:a="http://schemas.openxmlformats.org/drawingml/2006/main" xmlns:r="http://schemas.openxmlformats.org/officeDocument/2006/relationships" xmlns:p="http://schemas.openxmlformats.org/presentationml/2006/main">
-  <p:cSld>
-    <p:spTree>
-      <p:nvGrpSpPr>
-        <p:cNvPr id="1" name=""/>
-        <p:cNvGrpSpPr/>
-        <p:nvPr/>
-      </p:nvGrpSpPr>
-      <p:grpSpPr>
-        <a:xfrm>
-          <a:off x="0" y="0"/>
-          <a:ext cx="0" cy="0"/>
-          <a:chOff x="0" y="0"/>
-          <a:chExt cx="0" cy="0"/>
-        </a:xfrm>
-      </p:grpSpPr>
-      <p:sp>
-        <p:nvSpPr>
-          <p:cNvPr id="2" name="Slide Image Placeholder 1"/>
-          <p:cNvSpPr>
-            <a:spLocks noGrp="1" noRot="1" noChangeAspect="1"/>
-          </p:cNvSpPr>
-          <p:nvPr>
-            <p:ph type="sldImg"/>
-          </p:nvPr>
-        </p:nvSpPr>
-        <p:spPr/>
-      </p:sp>
-      <p:sp>
-        <p:nvSpPr>
-          <p:cNvPr id="3" name="Notes Placeholder 2"/>
-          <p:cNvSpPr>
-            <a:spLocks noGrp="1"/>
-          </p:cNvSpPr>
-          <p:nvPr>
-            <p:ph type="body" idx="1"/>
-          </p:nvPr>
-        </p:nvSpPr>
-        <p:spPr/>
-        <p:txBody>
-          <a:bodyPr/>
-          <a:lstStyle/>
-          <a:p>
-            <a:r>
-              <a:rPr lang="en-US" dirty="0"/>
-              <a:t/>
-            </a:r>
-            <a:endParaRPr lang="en-US" dirty="0"/>
-          </a:p>
-        </p:txBody>
-      </p:sp>
-      <p:sp>
-        <p:nvSpPr>
-          <p:cNvPr id="4" name="Slide Number Placeholder 3"/>
-          <p:cNvSpPr>
-            <a:spLocks noGrp="1"/>
-          </p:cNvSpPr>
-          <p:nvPr>
-            <p:ph type="sldNum" sz="quarter" idx="10"/>
-          </p:nvPr>
-        </p:nvSpPr>
-        <p:spPr/>
-        <p:txBody>
-          <a:bodyPr/>
-          <a:lstStyle/>
-          <a:p>
-            <a:fld id="{F7021451-1387-4CA6-816F-3879F97B5CBC}" type="slidenum">
-              <a:rPr lang="en-US"/>
-              <a:t>11</a:t>
             </a:fld>
             <a:endParaRPr lang="en-US"/>
           </a:p>
@@ -2005,1056 +1827,6 @@
 </p:sld>
 </file>
 
-<file path=ppt/slides/slide10.xml><?xml version="1.0" encoding="utf-8"?>
-<p:sld xmlns:a="http://schemas.openxmlformats.org/drawingml/2006/main" xmlns:r="http://schemas.openxmlformats.org/officeDocument/2006/relationships" xmlns:p="http://schemas.openxmlformats.org/presentationml/2006/main">
-  <p:cSld name="Slide 10">
-    <p:bg>
-      <p:bgPr>
-        <a:solidFill>
-          <a:srgbClr val="FFFFFF"/>
-        </a:solidFill>
-      </p:bgPr>
-    </p:bg>
-    <p:spTree>
-      <p:nvGrpSpPr>
-        <p:cNvPr id="1" name=""/>
-        <p:cNvGrpSpPr/>
-        <p:nvPr/>
-      </p:nvGrpSpPr>
-      <p:grpSpPr>
-        <a:xfrm>
-          <a:off x="0" y="0"/>
-          <a:ext cx="0" cy="0"/>
-          <a:chOff x="0" y="0"/>
-          <a:chExt cx="0" cy="0"/>
-        </a:xfrm>
-      </p:grpSpPr>
-      <p:sp>
-        <p:nvSpPr>
-          <p:cNvPr id="2" name="Text 0"/>
-          <p:cNvSpPr txBox="1"/>
-          <p:nvPr/>
-        </p:nvSpPr>
-        <p:spPr>
-          <a:xfrm>
-            <a:off x="731520" y="566928"/>
-            <a:ext cx="10058400" cy="274320"/>
-          </a:xfrm>
-          <a:prstGeom prst="rect">
-            <a:avLst/>
-          </a:prstGeom>
-          <a:noFill/>
-          <a:ln/>
-        </p:spPr>
-        <p:txBody>
-          <a:bodyPr wrap="square" lIns="0" tIns="0" rIns="0" bIns="0" rtlCol="0" anchor="ctr"/>
-          <a:lstStyle/>
-          <a:p>
-            <a:pPr indent="0" marL="0">
-              <a:buNone/>
-            </a:pPr>
-            <a:r>
-              <a:rPr lang="en-US" sz="1100" b="1" spc="300" kern="0" dirty="0">
-                <a:solidFill>
-                  <a:srgbClr val="0E7C74"/>
-                </a:solidFill>
-                <a:latin typeface="Malgun Gothic" pitchFamily="34" charset="0"/>
-                <a:ea typeface="Malgun Gothic" pitchFamily="34" charset="-122"/>
-                <a:cs typeface="Malgun Gothic" pitchFamily="34" charset="-120"/>
-              </a:rPr>
-              <a:t>분석 결과 ②</a:t>
-            </a:r>
-            <a:endParaRPr lang="en-US" sz="1100" dirty="0"/>
-          </a:p>
-        </p:txBody>
-      </p:sp>
-      <p:sp>
-        <p:nvSpPr>
-          <p:cNvPr id="3" name="Text 1"/>
-          <p:cNvSpPr txBox="1"/>
-          <p:nvPr/>
-        </p:nvSpPr>
-        <p:spPr>
-          <a:xfrm>
-            <a:off x="731520" y="868680"/>
-            <a:ext cx="10698480" cy="640080"/>
-          </a:xfrm>
-          <a:prstGeom prst="rect">
-            <a:avLst/>
-          </a:prstGeom>
-          <a:noFill/>
-          <a:ln/>
-        </p:spPr>
-        <p:txBody>
-          <a:bodyPr wrap="square" lIns="0" tIns="0" rIns="0" bIns="0" rtlCol="0" anchor="ctr"/>
-          <a:lstStyle/>
-          <a:p>
-            <a:pPr indent="0" marL="0">
-              <a:buNone/>
-            </a:pPr>
-            <a:r>
-              <a:rPr lang="en-US" sz="2700" b="1" dirty="0">
-                <a:solidFill>
-                  <a:srgbClr val="17211F"/>
-                </a:solidFill>
-                <a:latin typeface="Malgun Gothic" pitchFamily="34" charset="0"/>
-                <a:ea typeface="Malgun Gothic" pitchFamily="34" charset="-122"/>
-                <a:cs typeface="Malgun Gothic" pitchFamily="34" charset="-120"/>
-              </a:rPr>
-              <a:t>사회요인 · 보호요인 · 조합효과</a:t>
-            </a:r>
-            <a:endParaRPr lang="en-US" sz="2700" dirty="0"/>
-          </a:p>
-        </p:txBody>
-      </p:sp>
-      <p:pic>
-        <p:nvPicPr>
-          <p:cNvPr id="4" name="Image 0" descr="/home/user/diabetes/fig_social.png">    </p:cNvPr>
-          <p:cNvPicPr>
-            <a:picLocks noChangeAspect="1"/>
-          </p:cNvPicPr>
-          <p:nvPr/>
-        </p:nvPicPr>
-        <p:blipFill>
-          <a:blip r:embed="rId1"/>
-          <a:stretch>
-            <a:fillRect/>
-          </a:stretch>
-        </p:blipFill>
-        <p:spPr>
-          <a:xfrm>
-            <a:off x="731520" y="1874520"/>
-            <a:ext cx="10698480" cy="3383280"/>
-          </a:xfrm>
-          <a:prstGeom prst="rect">
-            <a:avLst/>
-          </a:prstGeom>
-        </p:spPr>
-      </p:pic>
-      <p:sp>
-        <p:nvSpPr>
-          <p:cNvPr id="5" name="Shape 2"/>
-          <p:cNvSpPr/>
-          <p:nvPr/>
-        </p:nvSpPr>
-        <p:spPr>
-          <a:xfrm>
-            <a:off x="731520" y="5532120"/>
-            <a:ext cx="10698480" cy="0"/>
-          </a:xfrm>
-          <a:prstGeom prst="line">
-            <a:avLst/>
-          </a:prstGeom>
-          <a:noFill/>
-          <a:ln w="12700">
-            <a:solidFill>
-              <a:srgbClr val="DBE4E1"/>
-            </a:solidFill>
-            <a:prstDash val="solid"/>
-          </a:ln>
-        </p:spPr>
-      </p:sp>
-      <p:sp>
-        <p:nvSpPr>
-          <p:cNvPr id="6" name="Text 3"/>
-          <p:cNvSpPr txBox="1"/>
-          <p:nvPr/>
-        </p:nvSpPr>
-        <p:spPr>
-          <a:xfrm>
-            <a:off x="731520" y="5715000"/>
-            <a:ext cx="10698480" cy="457200"/>
-          </a:xfrm>
-          <a:prstGeom prst="rect">
-            <a:avLst/>
-          </a:prstGeom>
-          <a:noFill/>
-          <a:ln/>
-        </p:spPr>
-        <p:txBody>
-          <a:bodyPr wrap="square" lIns="0" tIns="0" rIns="0" bIns="0" rtlCol="0" anchor="ctr"/>
-          <a:lstStyle/>
-          <a:p>
-            <a:pPr indent="0" marL="0">
-              <a:buNone/>
-            </a:pPr>
-            <a:r>
-              <a:rPr lang="en-US" sz="1350" b="1" dirty="0">
-                <a:solidFill>
-                  <a:srgbClr val="17211F"/>
-                </a:solidFill>
-                <a:latin typeface="Malgun Gothic" pitchFamily="34" charset="0"/>
-                <a:ea typeface="Malgun Gothic" pitchFamily="34" charset="-122"/>
-                <a:cs typeface="Malgun Gothic" pitchFamily="34" charset="-120"/>
-              </a:rPr>
-              <a:t>소득·학력↓ </a:t>
-            </a:r>
-            <a:pPr indent="0" marL="0">
-              <a:buNone/>
-            </a:pPr>
-            <a:r>
-              <a:rPr lang="en-US" sz="1350" dirty="0">
-                <a:solidFill>
-                  <a:srgbClr val="7C8A87"/>
-                </a:solidFill>
-                <a:latin typeface="Malgun Gothic" pitchFamily="34" charset="0"/>
-                <a:ea typeface="Malgun Gothic" pitchFamily="34" charset="-122"/>
-                <a:cs typeface="Malgun Gothic" pitchFamily="34" charset="-120"/>
-              </a:rPr>
-              <a:t>위험↑    </a:t>
-            </a:r>
-            <a:pPr indent="0" marL="0">
-              <a:buNone/>
-            </a:pPr>
-            <a:r>
-              <a:rPr lang="en-US" sz="1350" b="1" dirty="0">
-                <a:solidFill>
-                  <a:srgbClr val="17211F"/>
-                </a:solidFill>
-                <a:latin typeface="Malgun Gothic" pitchFamily="34" charset="0"/>
-                <a:ea typeface="Malgun Gothic" pitchFamily="34" charset="-122"/>
-                <a:cs typeface="Malgun Gothic" pitchFamily="34" charset="-120"/>
-              </a:rPr>
-              <a:t>운동 </a:t>
-            </a:r>
-            <a:pPr indent="0" marL="0">
-              <a:buNone/>
-            </a:pPr>
-            <a:r>
-              <a:rPr lang="en-US" sz="1350" dirty="0">
-                <a:solidFill>
-                  <a:srgbClr val="7C8A87"/>
-                </a:solidFill>
-                <a:latin typeface="Malgun Gothic" pitchFamily="34" charset="0"/>
-                <a:ea typeface="Malgun Gothic" pitchFamily="34" charset="-122"/>
-                <a:cs typeface="Malgun Gothic" pitchFamily="34" charset="-120"/>
-              </a:rPr>
-              <a:t>위험 절반↓    </a:t>
-            </a:r>
-            <a:pPr indent="0" marL="0">
-              <a:buNone/>
-            </a:pPr>
-            <a:r>
-              <a:rPr lang="en-US" sz="1350" b="1" dirty="0">
-                <a:solidFill>
-                  <a:srgbClr val="17211F"/>
-                </a:solidFill>
-                <a:latin typeface="Malgun Gothic" pitchFamily="34" charset="0"/>
-                <a:ea typeface="Malgun Gothic" pitchFamily="34" charset="-122"/>
-                <a:cs typeface="Malgun Gothic" pitchFamily="34" charset="-120"/>
-              </a:rPr>
-              <a:t>고혈압+비만 </a:t>
-            </a:r>
-            <a:pPr indent="0" marL="0">
-              <a:buNone/>
-            </a:pPr>
-            <a:r>
-              <a:rPr lang="en-US" sz="1350" b="1" dirty="0">
-                <a:solidFill>
-                  <a:srgbClr val="DD6B4D"/>
-                </a:solidFill>
-                <a:latin typeface="Malgun Gothic" pitchFamily="34" charset="0"/>
-                <a:ea typeface="Malgun Gothic" pitchFamily="34" charset="-122"/>
-                <a:cs typeface="Malgun Gothic" pitchFamily="34" charset="-120"/>
-              </a:rPr>
-              <a:t>4.6% → 31.3%</a:t>
-            </a:r>
-            <a:endParaRPr lang="en-US" sz="1350" dirty="0"/>
-          </a:p>
-        </p:txBody>
-      </p:sp>
-      <p:sp>
-        <p:nvSpPr>
-          <p:cNvPr id="7" name="Text 4"/>
-          <p:cNvSpPr txBox="1"/>
-          <p:nvPr/>
-        </p:nvSpPr>
-        <p:spPr>
-          <a:xfrm>
-            <a:off x="10332720" y="6382512"/>
-            <a:ext cx="1371600" cy="274320"/>
-          </a:xfrm>
-          <a:prstGeom prst="rect">
-            <a:avLst/>
-          </a:prstGeom>
-          <a:noFill/>
-          <a:ln/>
-        </p:spPr>
-        <p:txBody>
-          <a:bodyPr wrap="square" lIns="0" tIns="0" rIns="0" bIns="0" rtlCol="0" anchor="ctr"/>
-          <a:lstStyle/>
-          <a:p>
-            <a:pPr algn="r" indent="0" marL="0">
-              <a:buNone/>
-            </a:pPr>
-            <a:r>
-              <a:rPr lang="en-US" sz="900" spc="100" kern="0" dirty="0">
-                <a:solidFill>
-                  <a:srgbClr val="7C8A87"/>
-                </a:solidFill>
-                <a:latin typeface="Malgun Gothic" pitchFamily="34" charset="0"/>
-                <a:ea typeface="Malgun Gothic" pitchFamily="34" charset="-122"/>
-                <a:cs typeface="Malgun Gothic" pitchFamily="34" charset="-120"/>
-              </a:rPr>
-              <a:t>10  /  11</a:t>
-            </a:r>
-            <a:endParaRPr lang="en-US" sz="900" dirty="0"/>
-          </a:p>
-        </p:txBody>
-      </p:sp>
-    </p:spTree>
-  </p:cSld>
-  <p:clrMapOvr>
-    <a:masterClrMapping/>
-  </p:clrMapOvr>
-</p:sld>
-</file>
-
-<file path=ppt/slides/slide11.xml><?xml version="1.0" encoding="utf-8"?>
-<p:sld xmlns:a="http://schemas.openxmlformats.org/drawingml/2006/main" xmlns:r="http://schemas.openxmlformats.org/officeDocument/2006/relationships" xmlns:p="http://schemas.openxmlformats.org/presentationml/2006/main">
-  <p:cSld name="Slide 11">
-    <p:bg>
-      <p:bgPr>
-        <a:solidFill>
-          <a:srgbClr val="FFFFFF"/>
-        </a:solidFill>
-      </p:bgPr>
-    </p:bg>
-    <p:spTree>
-      <p:nvGrpSpPr>
-        <p:cNvPr id="1" name=""/>
-        <p:cNvGrpSpPr/>
-        <p:nvPr/>
-      </p:nvGrpSpPr>
-      <p:grpSpPr>
-        <a:xfrm>
-          <a:off x="0" y="0"/>
-          <a:ext cx="0" cy="0"/>
-          <a:chOff x="0" y="0"/>
-          <a:chExt cx="0" cy="0"/>
-        </a:xfrm>
-      </p:grpSpPr>
-      <p:sp>
-        <p:nvSpPr>
-          <p:cNvPr id="2" name="Text 0"/>
-          <p:cNvSpPr txBox="1"/>
-          <p:nvPr/>
-        </p:nvSpPr>
-        <p:spPr>
-          <a:xfrm>
-            <a:off x="731520" y="566928"/>
-            <a:ext cx="10058400" cy="274320"/>
-          </a:xfrm>
-          <a:prstGeom prst="rect">
-            <a:avLst/>
-          </a:prstGeom>
-          <a:noFill/>
-          <a:ln/>
-        </p:spPr>
-        <p:txBody>
-          <a:bodyPr wrap="square" lIns="0" tIns="0" rIns="0" bIns="0" rtlCol="0" anchor="ctr"/>
-          <a:lstStyle/>
-          <a:p>
-            <a:pPr indent="0" marL="0">
-              <a:buNone/>
-            </a:pPr>
-            <a:r>
-              <a:rPr lang="en-US" sz="1100" b="1" spc="300" kern="0" dirty="0">
-                <a:solidFill>
-                  <a:srgbClr val="0E7C74"/>
-                </a:solidFill>
-                <a:latin typeface="Malgun Gothic" pitchFamily="34" charset="0"/>
-                <a:ea typeface="Malgun Gothic" pitchFamily="34" charset="-122"/>
-                <a:cs typeface="Malgun Gothic" pitchFamily="34" charset="-120"/>
-              </a:rPr>
-              <a:t>결론</a:t>
-            </a:r>
-            <a:endParaRPr lang="en-US" sz="1100" dirty="0"/>
-          </a:p>
-        </p:txBody>
-      </p:sp>
-      <p:sp>
-        <p:nvSpPr>
-          <p:cNvPr id="3" name="Text 1"/>
-          <p:cNvSpPr txBox="1"/>
-          <p:nvPr/>
-        </p:nvSpPr>
-        <p:spPr>
-          <a:xfrm>
-            <a:off x="731520" y="1051560"/>
-            <a:ext cx="10332720" cy="1280160"/>
-          </a:xfrm>
-          <a:prstGeom prst="rect">
-            <a:avLst/>
-          </a:prstGeom>
-          <a:noFill/>
-          <a:ln/>
-        </p:spPr>
-        <p:txBody>
-          <a:bodyPr wrap="square" lIns="0" tIns="0" rIns="0" bIns="0" rtlCol="0" anchor="ctr"/>
-          <a:lstStyle/>
-          <a:p>
-            <a:pPr indent="0" marL="0">
-              <a:lnSpc>
-                <a:spcPct val="118000"/>
-              </a:lnSpc>
-              <a:buNone/>
-            </a:pPr>
-            <a:r>
-              <a:rPr lang="en-US" sz="2500" b="1" dirty="0">
-                <a:solidFill>
-                  <a:srgbClr val="0E7C74"/>
-                </a:solidFill>
-                <a:latin typeface="Malgun Gothic" pitchFamily="34" charset="0"/>
-                <a:ea typeface="Malgun Gothic" pitchFamily="34" charset="-122"/>
-                <a:cs typeface="Malgun Gothic" pitchFamily="34" charset="-120"/>
-              </a:rPr>
-              <a:t>고혈압·비만·고령</a:t>
-            </a:r>
-            <a:pPr indent="0" marL="0">
-              <a:lnSpc>
-                <a:spcPct val="118000"/>
-              </a:lnSpc>
-              <a:buNone/>
-            </a:pPr>
-            <a:r>
-              <a:rPr lang="en-US" sz="2500" b="1" dirty="0">
-                <a:solidFill>
-                  <a:srgbClr val="17211F"/>
-                </a:solidFill>
-                <a:latin typeface="Malgun Gothic" pitchFamily="34" charset="0"/>
-                <a:ea typeface="Malgun Gothic" pitchFamily="34" charset="-122"/>
-                <a:cs typeface="Malgun Gothic" pitchFamily="34" charset="-120"/>
-              </a:rPr>
-              <a:t>이 핵심 위험요인이며,
-</a:t>
-            </a:r>
-            <a:pPr indent="0" marL="0">
-              <a:lnSpc>
-                <a:spcPct val="118000"/>
-              </a:lnSpc>
-              <a:buNone/>
-            </a:pPr>
-            <a:r>
-              <a:rPr lang="en-US" sz="2500" b="1" dirty="0">
-                <a:solidFill>
-                  <a:srgbClr val="0E7C74"/>
-                </a:solidFill>
-                <a:latin typeface="Malgun Gothic" pitchFamily="34" charset="0"/>
-                <a:ea typeface="Malgun Gothic" pitchFamily="34" charset="-122"/>
-                <a:cs typeface="Malgun Gothic" pitchFamily="34" charset="-120"/>
-              </a:rPr>
-              <a:t>운동과 사회적 여건</a:t>
-            </a:r>
-            <a:pPr indent="0" marL="0">
-              <a:lnSpc>
-                <a:spcPct val="118000"/>
-              </a:lnSpc>
-              <a:buNone/>
-            </a:pPr>
-            <a:r>
-              <a:rPr lang="en-US" sz="2500" b="1" dirty="0">
-                <a:solidFill>
-                  <a:srgbClr val="17211F"/>
-                </a:solidFill>
-                <a:latin typeface="Malgun Gothic" pitchFamily="34" charset="0"/>
-                <a:ea typeface="Malgun Gothic" pitchFamily="34" charset="-122"/>
-                <a:cs typeface="Malgun Gothic" pitchFamily="34" charset="-120"/>
-              </a:rPr>
-              <a:t>이 이를 완화합니다.</a:t>
-            </a:r>
-            <a:endParaRPr lang="en-US" sz="2500" dirty="0"/>
-          </a:p>
-        </p:txBody>
-      </p:sp>
-      <p:sp>
-        <p:nvSpPr>
-          <p:cNvPr id="4" name="Shape 2"/>
-          <p:cNvSpPr/>
-          <p:nvPr/>
-        </p:nvSpPr>
-        <p:spPr>
-          <a:xfrm>
-            <a:off x="731520" y="2788920"/>
-            <a:ext cx="10698480" cy="0"/>
-          </a:xfrm>
-          <a:prstGeom prst="line">
-            <a:avLst/>
-          </a:prstGeom>
-          <a:noFill/>
-          <a:ln w="12700">
-            <a:solidFill>
-              <a:srgbClr val="DBE4E1"/>
-            </a:solidFill>
-            <a:prstDash val="solid"/>
-          </a:ln>
-        </p:spPr>
-      </p:sp>
-      <p:sp>
-        <p:nvSpPr>
-          <p:cNvPr id="5" name="Text 3"/>
-          <p:cNvSpPr txBox="1"/>
-          <p:nvPr/>
-        </p:nvSpPr>
-        <p:spPr>
-          <a:xfrm>
-            <a:off x="731520" y="3017520"/>
-            <a:ext cx="4572000" cy="320040"/>
-          </a:xfrm>
-          <a:prstGeom prst="rect">
-            <a:avLst/>
-          </a:prstGeom>
-          <a:noFill/>
-          <a:ln/>
-        </p:spPr>
-        <p:txBody>
-          <a:bodyPr wrap="square" lIns="0" tIns="0" rIns="0" bIns="0" rtlCol="0" anchor="ctr"/>
-          <a:lstStyle/>
-          <a:p>
-            <a:pPr indent="0" marL="0">
-              <a:buNone/>
-            </a:pPr>
-            <a:r>
-              <a:rPr lang="en-US" sz="1200" b="1" spc="200" kern="0" dirty="0">
-                <a:solidFill>
-                  <a:srgbClr val="0E7C74"/>
-                </a:solidFill>
-                <a:latin typeface="Malgun Gothic" pitchFamily="34" charset="0"/>
-                <a:ea typeface="Malgun Gothic" pitchFamily="34" charset="-122"/>
-                <a:cs typeface="Malgun Gothic" pitchFamily="34" charset="-120"/>
-              </a:rPr>
-              <a:t>역할 분담</a:t>
-            </a:r>
-            <a:endParaRPr lang="en-US" sz="1200" dirty="0"/>
-          </a:p>
-        </p:txBody>
-      </p:sp>
-      <p:sp>
-        <p:nvSpPr>
-          <p:cNvPr id="6" name="Text 4"/>
-          <p:cNvSpPr txBox="1"/>
-          <p:nvPr/>
-        </p:nvSpPr>
-        <p:spPr>
-          <a:xfrm>
-            <a:off x="731520" y="3429000"/>
-            <a:ext cx="3840480" cy="457200"/>
-          </a:xfrm>
-          <a:prstGeom prst="rect">
-            <a:avLst/>
-          </a:prstGeom>
-          <a:noFill/>
-          <a:ln/>
-        </p:spPr>
-        <p:txBody>
-          <a:bodyPr wrap="square" lIns="0" tIns="0" rIns="0" bIns="0" rtlCol="0" anchor="ctr"/>
-          <a:lstStyle/>
-          <a:p>
-            <a:pPr indent="0" marL="0">
-              <a:buNone/>
-            </a:pPr>
-            <a:r>
-              <a:rPr lang="en-US" sz="1400" dirty="0">
-                <a:solidFill>
-                  <a:srgbClr val="17211F"/>
-                </a:solidFill>
-                <a:latin typeface="Malgun Gothic" pitchFamily="34" charset="0"/>
-                <a:ea typeface="Malgun Gothic" pitchFamily="34" charset="-122"/>
-                <a:cs typeface="Malgun Gothic" pitchFamily="34" charset="-120"/>
-              </a:rPr>
-              <a:t>주제·데이터</a:t>
-            </a:r>
-            <a:endParaRPr lang="en-US" sz="1400" dirty="0"/>
-          </a:p>
-        </p:txBody>
-      </p:sp>
-      <p:sp>
-        <p:nvSpPr>
-          <p:cNvPr id="7" name="Text 5"/>
-          <p:cNvSpPr txBox="1"/>
-          <p:nvPr/>
-        </p:nvSpPr>
-        <p:spPr>
-          <a:xfrm>
-            <a:off x="4572000" y="3429000"/>
-            <a:ext cx="1463040" cy="457200"/>
-          </a:xfrm>
-          <a:prstGeom prst="rect">
-            <a:avLst/>
-          </a:prstGeom>
-          <a:noFill/>
-          <a:ln/>
-        </p:spPr>
-        <p:txBody>
-          <a:bodyPr wrap="square" lIns="0" tIns="0" rIns="0" bIns="0" rtlCol="0" anchor="ctr"/>
-          <a:lstStyle/>
-          <a:p>
-            <a:pPr indent="0" marL="0">
-              <a:buNone/>
-            </a:pPr>
-            <a:r>
-              <a:rPr lang="en-US" sz="1400" b="1" dirty="0">
-                <a:solidFill>
-                  <a:srgbClr val="7C8A87"/>
-                </a:solidFill>
-                <a:latin typeface="Malgun Gothic" pitchFamily="34" charset="0"/>
-                <a:ea typeface="Malgun Gothic" pitchFamily="34" charset="-122"/>
-                <a:cs typeface="Malgun Gothic" pitchFamily="34" charset="-120"/>
-              </a:rPr>
-              <a:t>OOO</a:t>
-            </a:r>
-            <a:endParaRPr lang="en-US" sz="1400" dirty="0"/>
-          </a:p>
-        </p:txBody>
-      </p:sp>
-      <p:sp>
-        <p:nvSpPr>
-          <p:cNvPr id="8" name="Shape 6"/>
-          <p:cNvSpPr/>
-          <p:nvPr/>
-        </p:nvSpPr>
-        <p:spPr>
-          <a:xfrm>
-            <a:off x="731520" y="3931920"/>
-            <a:ext cx="5303520" cy="0"/>
-          </a:xfrm>
-          <a:prstGeom prst="line">
-            <a:avLst/>
-          </a:prstGeom>
-          <a:noFill/>
-          <a:ln w="12700">
-            <a:solidFill>
-              <a:srgbClr val="DBE4E1"/>
-            </a:solidFill>
-            <a:prstDash val="solid"/>
-          </a:ln>
-        </p:spPr>
-      </p:sp>
-      <p:sp>
-        <p:nvSpPr>
-          <p:cNvPr id="9" name="Text 7"/>
-          <p:cNvSpPr txBox="1"/>
-          <p:nvPr/>
-        </p:nvSpPr>
-        <p:spPr>
-          <a:xfrm>
-            <a:off x="731520" y="3995928"/>
-            <a:ext cx="3840480" cy="457200"/>
-          </a:xfrm>
-          <a:prstGeom prst="rect">
-            <a:avLst/>
-          </a:prstGeom>
-          <a:noFill/>
-          <a:ln/>
-        </p:spPr>
-        <p:txBody>
-          <a:bodyPr wrap="square" lIns="0" tIns="0" rIns="0" bIns="0" rtlCol="0" anchor="ctr"/>
-          <a:lstStyle/>
-          <a:p>
-            <a:pPr indent="0" marL="0">
-              <a:buNone/>
-            </a:pPr>
-            <a:r>
-              <a:rPr lang="en-US" sz="1400" dirty="0">
-                <a:solidFill>
-                  <a:srgbClr val="17211F"/>
-                </a:solidFill>
-                <a:latin typeface="Malgun Gothic" pitchFamily="34" charset="0"/>
-                <a:ea typeface="Malgun Gothic" pitchFamily="34" charset="-122"/>
-                <a:cs typeface="Malgun Gothic" pitchFamily="34" charset="-120"/>
-              </a:rPr>
-              <a:t>DB 설계·ER</a:t>
-            </a:r>
-            <a:endParaRPr lang="en-US" sz="1400" dirty="0"/>
-          </a:p>
-        </p:txBody>
-      </p:sp>
-      <p:sp>
-        <p:nvSpPr>
-          <p:cNvPr id="10" name="Text 8"/>
-          <p:cNvSpPr txBox="1"/>
-          <p:nvPr/>
-        </p:nvSpPr>
-        <p:spPr>
-          <a:xfrm>
-            <a:off x="4572000" y="3995928"/>
-            <a:ext cx="1463040" cy="457200"/>
-          </a:xfrm>
-          <a:prstGeom prst="rect">
-            <a:avLst/>
-          </a:prstGeom>
-          <a:noFill/>
-          <a:ln/>
-        </p:spPr>
-        <p:txBody>
-          <a:bodyPr wrap="square" lIns="0" tIns="0" rIns="0" bIns="0" rtlCol="0" anchor="ctr"/>
-          <a:lstStyle/>
-          <a:p>
-            <a:pPr indent="0" marL="0">
-              <a:buNone/>
-            </a:pPr>
-            <a:r>
-              <a:rPr lang="en-US" sz="1400" b="1" dirty="0">
-                <a:solidFill>
-                  <a:srgbClr val="7C8A87"/>
-                </a:solidFill>
-                <a:latin typeface="Malgun Gothic" pitchFamily="34" charset="0"/>
-                <a:ea typeface="Malgun Gothic" pitchFamily="34" charset="-122"/>
-                <a:cs typeface="Malgun Gothic" pitchFamily="34" charset="-120"/>
-              </a:rPr>
-              <a:t>OOO</a:t>
-            </a:r>
-            <a:endParaRPr lang="en-US" sz="1400" dirty="0"/>
-          </a:p>
-        </p:txBody>
-      </p:sp>
-      <p:sp>
-        <p:nvSpPr>
-          <p:cNvPr id="11" name="Shape 9"/>
-          <p:cNvSpPr/>
-          <p:nvPr/>
-        </p:nvSpPr>
-        <p:spPr>
-          <a:xfrm>
-            <a:off x="731520" y="4498848"/>
-            <a:ext cx="5303520" cy="0"/>
-          </a:xfrm>
-          <a:prstGeom prst="line">
-            <a:avLst/>
-          </a:prstGeom>
-          <a:noFill/>
-          <a:ln w="12700">
-            <a:solidFill>
-              <a:srgbClr val="DBE4E1"/>
-            </a:solidFill>
-            <a:prstDash val="solid"/>
-          </a:ln>
-        </p:spPr>
-      </p:sp>
-      <p:sp>
-        <p:nvSpPr>
-          <p:cNvPr id="12" name="Text 10"/>
-          <p:cNvSpPr txBox="1"/>
-          <p:nvPr/>
-        </p:nvSpPr>
-        <p:spPr>
-          <a:xfrm>
-            <a:off x="731520" y="4562856"/>
-            <a:ext cx="3840480" cy="457200"/>
-          </a:xfrm>
-          <a:prstGeom prst="rect">
-            <a:avLst/>
-          </a:prstGeom>
-          <a:noFill/>
-          <a:ln/>
-        </p:spPr>
-        <p:txBody>
-          <a:bodyPr wrap="square" lIns="0" tIns="0" rIns="0" bIns="0" rtlCol="0" anchor="ctr"/>
-          <a:lstStyle/>
-          <a:p>
-            <a:pPr indent="0" marL="0">
-              <a:buNone/>
-            </a:pPr>
-            <a:r>
-              <a:rPr lang="en-US" sz="1400" dirty="0">
-                <a:solidFill>
-                  <a:srgbClr val="17211F"/>
-                </a:solidFill>
-                <a:latin typeface="Malgun Gothic" pitchFamily="34" charset="0"/>
-                <a:ea typeface="Malgun Gothic" pitchFamily="34" charset="-122"/>
-                <a:cs typeface="Malgun Gothic" pitchFamily="34" charset="-120"/>
-              </a:rPr>
-              <a:t>DB 구현·입력</a:t>
-            </a:r>
-            <a:endParaRPr lang="en-US" sz="1400" dirty="0"/>
-          </a:p>
-        </p:txBody>
-      </p:sp>
-      <p:sp>
-        <p:nvSpPr>
-          <p:cNvPr id="13" name="Text 11"/>
-          <p:cNvSpPr txBox="1"/>
-          <p:nvPr/>
-        </p:nvSpPr>
-        <p:spPr>
-          <a:xfrm>
-            <a:off x="4572000" y="4562856"/>
-            <a:ext cx="1463040" cy="457200"/>
-          </a:xfrm>
-          <a:prstGeom prst="rect">
-            <a:avLst/>
-          </a:prstGeom>
-          <a:noFill/>
-          <a:ln/>
-        </p:spPr>
-        <p:txBody>
-          <a:bodyPr wrap="square" lIns="0" tIns="0" rIns="0" bIns="0" rtlCol="0" anchor="ctr"/>
-          <a:lstStyle/>
-          <a:p>
-            <a:pPr indent="0" marL="0">
-              <a:buNone/>
-            </a:pPr>
-            <a:r>
-              <a:rPr lang="en-US" sz="1400" b="1" dirty="0">
-                <a:solidFill>
-                  <a:srgbClr val="7C8A87"/>
-                </a:solidFill>
-                <a:latin typeface="Malgun Gothic" pitchFamily="34" charset="0"/>
-                <a:ea typeface="Malgun Gothic" pitchFamily="34" charset="-122"/>
-                <a:cs typeface="Malgun Gothic" pitchFamily="34" charset="-120"/>
-              </a:rPr>
-              <a:t>OOO</a:t>
-            </a:r>
-            <a:endParaRPr lang="en-US" sz="1400" dirty="0"/>
-          </a:p>
-        </p:txBody>
-      </p:sp>
-      <p:sp>
-        <p:nvSpPr>
-          <p:cNvPr id="14" name="Shape 12"/>
-          <p:cNvSpPr/>
-          <p:nvPr/>
-        </p:nvSpPr>
-        <p:spPr>
-          <a:xfrm>
-            <a:off x="731520" y="5065776"/>
-            <a:ext cx="5303520" cy="0"/>
-          </a:xfrm>
-          <a:prstGeom prst="line">
-            <a:avLst/>
-          </a:prstGeom>
-          <a:noFill/>
-          <a:ln w="12700">
-            <a:solidFill>
-              <a:srgbClr val="DBE4E1"/>
-            </a:solidFill>
-            <a:prstDash val="solid"/>
-          </a:ln>
-        </p:spPr>
-      </p:sp>
-      <p:sp>
-        <p:nvSpPr>
-          <p:cNvPr id="15" name="Text 13"/>
-          <p:cNvSpPr txBox="1"/>
-          <p:nvPr/>
-        </p:nvSpPr>
-        <p:spPr>
-          <a:xfrm>
-            <a:off x="731520" y="5129784"/>
-            <a:ext cx="3840480" cy="457200"/>
-          </a:xfrm>
-          <a:prstGeom prst="rect">
-            <a:avLst/>
-          </a:prstGeom>
-          <a:noFill/>
-          <a:ln/>
-        </p:spPr>
-        <p:txBody>
-          <a:bodyPr wrap="square" lIns="0" tIns="0" rIns="0" bIns="0" rtlCol="0" anchor="ctr"/>
-          <a:lstStyle/>
-          <a:p>
-            <a:pPr indent="0" marL="0">
-              <a:buNone/>
-            </a:pPr>
-            <a:r>
-              <a:rPr lang="en-US" sz="1400" dirty="0">
-                <a:solidFill>
-                  <a:srgbClr val="17211F"/>
-                </a:solidFill>
-                <a:latin typeface="Malgun Gothic" pitchFamily="34" charset="0"/>
-                <a:ea typeface="Malgun Gothic" pitchFamily="34" charset="-122"/>
-                <a:cs typeface="Malgun Gothic" pitchFamily="34" charset="-120"/>
-              </a:rPr>
-              <a:t>SQL 분석·발표</a:t>
-            </a:r>
-            <a:endParaRPr lang="en-US" sz="1400" dirty="0"/>
-          </a:p>
-        </p:txBody>
-      </p:sp>
-      <p:sp>
-        <p:nvSpPr>
-          <p:cNvPr id="16" name="Text 14"/>
-          <p:cNvSpPr txBox="1"/>
-          <p:nvPr/>
-        </p:nvSpPr>
-        <p:spPr>
-          <a:xfrm>
-            <a:off x="4572000" y="5129784"/>
-            <a:ext cx="1463040" cy="457200"/>
-          </a:xfrm>
-          <a:prstGeom prst="rect">
-            <a:avLst/>
-          </a:prstGeom>
-          <a:noFill/>
-          <a:ln/>
-        </p:spPr>
-        <p:txBody>
-          <a:bodyPr wrap="square" lIns="0" tIns="0" rIns="0" bIns="0" rtlCol="0" anchor="ctr"/>
-          <a:lstStyle/>
-          <a:p>
-            <a:pPr indent="0" marL="0">
-              <a:buNone/>
-            </a:pPr>
-            <a:r>
-              <a:rPr lang="en-US" sz="1400" b="1" dirty="0">
-                <a:solidFill>
-                  <a:srgbClr val="7C8A87"/>
-                </a:solidFill>
-                <a:latin typeface="Malgun Gothic" pitchFamily="34" charset="0"/>
-                <a:ea typeface="Malgun Gothic" pitchFamily="34" charset="-122"/>
-                <a:cs typeface="Malgun Gothic" pitchFamily="34" charset="-120"/>
-              </a:rPr>
-              <a:t>OOO</a:t>
-            </a:r>
-            <a:endParaRPr lang="en-US" sz="1400" dirty="0"/>
-          </a:p>
-        </p:txBody>
-      </p:sp>
-      <p:sp>
-        <p:nvSpPr>
-          <p:cNvPr id="17" name="Shape 15"/>
-          <p:cNvSpPr/>
-          <p:nvPr/>
-        </p:nvSpPr>
-        <p:spPr>
-          <a:xfrm>
-            <a:off x="6675120" y="3429000"/>
-            <a:ext cx="4754880" cy="2331720"/>
-          </a:xfrm>
-          <a:prstGeom prst="rect">
-            <a:avLst/>
-          </a:prstGeom>
-          <a:solidFill>
-            <a:srgbClr val="EDF1F0"/>
-          </a:solidFill>
-          <a:ln/>
-        </p:spPr>
-      </p:sp>
-      <p:sp>
-        <p:nvSpPr>
-          <p:cNvPr id="18" name="Text 16"/>
-          <p:cNvSpPr txBox="1"/>
-          <p:nvPr/>
-        </p:nvSpPr>
-        <p:spPr>
-          <a:xfrm>
-            <a:off x="6949440" y="3657600"/>
-            <a:ext cx="3657600" cy="320040"/>
-          </a:xfrm>
-          <a:prstGeom prst="rect">
-            <a:avLst/>
-          </a:prstGeom>
-          <a:noFill/>
-          <a:ln/>
-        </p:spPr>
-        <p:txBody>
-          <a:bodyPr wrap="square" lIns="0" tIns="0" rIns="0" bIns="0" rtlCol="0" anchor="ctr"/>
-          <a:lstStyle/>
-          <a:p>
-            <a:pPr indent="0" marL="0">
-              <a:buNone/>
-            </a:pPr>
-            <a:r>
-              <a:rPr lang="en-US" sz="1200" b="1" spc="200" kern="0" dirty="0">
-                <a:solidFill>
-                  <a:srgbClr val="0E7C74"/>
-                </a:solidFill>
-                <a:latin typeface="Malgun Gothic" pitchFamily="34" charset="0"/>
-                <a:ea typeface="Malgun Gothic" pitchFamily="34" charset="-122"/>
-                <a:cs typeface="Malgun Gothic" pitchFamily="34" charset="-120"/>
-              </a:rPr>
-              <a:t>조원 소감</a:t>
-            </a:r>
-            <a:endParaRPr lang="en-US" sz="1200" dirty="0"/>
-          </a:p>
-        </p:txBody>
-      </p:sp>
-      <p:sp>
-        <p:nvSpPr>
-          <p:cNvPr id="19" name="Text 17"/>
-          <p:cNvSpPr txBox="1"/>
-          <p:nvPr/>
-        </p:nvSpPr>
-        <p:spPr>
-          <a:xfrm>
-            <a:off x="6949440" y="4069080"/>
-            <a:ext cx="4206240" cy="457200"/>
-          </a:xfrm>
-          <a:prstGeom prst="rect">
-            <a:avLst/>
-          </a:prstGeom>
-          <a:noFill/>
-          <a:ln/>
-        </p:spPr>
-        <p:txBody>
-          <a:bodyPr wrap="square" lIns="0" tIns="0" rIns="0" bIns="0" rtlCol="0" anchor="ctr"/>
-          <a:lstStyle/>
-          <a:p>
-            <a:pPr indent="0" marL="0">
-              <a:buNone/>
-            </a:pPr>
-            <a:r>
-              <a:rPr lang="en-US" sz="1300" dirty="0">
-                <a:solidFill>
-                  <a:srgbClr val="7C8A87"/>
-                </a:solidFill>
-                <a:latin typeface="Malgun Gothic" pitchFamily="34" charset="0"/>
-                <a:ea typeface="Malgun Gothic" pitchFamily="34" charset="-122"/>
-                <a:cs typeface="Malgun Gothic" pitchFamily="34" charset="-120"/>
-              </a:rPr>
-              <a:t>조원별로 한 줄씩 소감을 작성해 주세요.</a:t>
-            </a:r>
-            <a:endParaRPr lang="en-US" sz="1300" dirty="0"/>
-          </a:p>
-        </p:txBody>
-      </p:sp>
-      <p:sp>
-        <p:nvSpPr>
-          <p:cNvPr id="20" name="Text 18"/>
-          <p:cNvSpPr txBox="1"/>
-          <p:nvPr/>
-        </p:nvSpPr>
-        <p:spPr>
-          <a:xfrm>
-            <a:off x="10332720" y="6382512"/>
-            <a:ext cx="1371600" cy="274320"/>
-          </a:xfrm>
-          <a:prstGeom prst="rect">
-            <a:avLst/>
-          </a:prstGeom>
-          <a:noFill/>
-          <a:ln/>
-        </p:spPr>
-        <p:txBody>
-          <a:bodyPr wrap="square" lIns="0" tIns="0" rIns="0" bIns="0" rtlCol="0" anchor="ctr"/>
-          <a:lstStyle/>
-          <a:p>
-            <a:pPr algn="r" indent="0" marL="0">
-              <a:buNone/>
-            </a:pPr>
-            <a:r>
-              <a:rPr lang="en-US" sz="900" spc="100" kern="0" dirty="0">
-                <a:solidFill>
-                  <a:srgbClr val="7C8A87"/>
-                </a:solidFill>
-                <a:latin typeface="Malgun Gothic" pitchFamily="34" charset="0"/>
-                <a:ea typeface="Malgun Gothic" pitchFamily="34" charset="-122"/>
-                <a:cs typeface="Malgun Gothic" pitchFamily="34" charset="-120"/>
-              </a:rPr>
-              <a:t>11  /  11</a:t>
-            </a:r>
-            <a:endParaRPr lang="en-US" sz="900" dirty="0"/>
-          </a:p>
-        </p:txBody>
-      </p:sp>
-    </p:spTree>
-  </p:cSld>
-  <p:clrMapOvr>
-    <a:masterClrMapping/>
-  </p:clrMapOvr>
-</p:sld>
-</file>
-
 <file path=ppt/slides/slide2.xml><?xml version="1.0" encoding="utf-8"?>
 <p:sld xmlns:a="http://schemas.openxmlformats.org/drawingml/2006/main" xmlns:r="http://schemas.openxmlformats.org/officeDocument/2006/relationships" xmlns:p="http://schemas.openxmlformats.org/presentationml/2006/main">
   <p:cSld name="Slide 2">
@@ -3601,7 +2373,7 @@
                 <a:ea typeface="Malgun Gothic" pitchFamily="34" charset="-122"/>
                 <a:cs typeface="Malgun Gothic" pitchFamily="34" charset="-120"/>
               </a:rPr>
-              <a:t>02  /  11</a:t>
+              <a:t>02  /  09</a:t>
             </a:r>
             <a:endParaRPr lang="en-US" sz="900" dirty="0"/>
           </a:p>
@@ -4209,7 +2981,7 @@
                 <a:ea typeface="Malgun Gothic" pitchFamily="34" charset="-122"/>
                 <a:cs typeface="Malgun Gothic" pitchFamily="34" charset="-120"/>
               </a:rPr>
-              <a:t>03  /  11</a:t>
+              <a:t>03  /  09</a:t>
             </a:r>
             <a:endParaRPr lang="en-US" sz="900" dirty="0"/>
           </a:p>
@@ -4778,7 +3550,7 @@
                 <a:ea typeface="Malgun Gothic" pitchFamily="34" charset="-122"/>
                 <a:cs typeface="Malgun Gothic" pitchFamily="34" charset="-120"/>
               </a:rPr>
-              <a:t>04  /  11</a:t>
+              <a:t>04  /  09</a:t>
             </a:r>
             <a:endParaRPr lang="en-US" sz="900" dirty="0"/>
           </a:p>
@@ -5743,7 +4515,7 @@
                 <a:ea typeface="Malgun Gothic" pitchFamily="34" charset="-122"/>
                 <a:cs typeface="Malgun Gothic" pitchFamily="34" charset="-120"/>
               </a:rPr>
-              <a:t>05  /  11</a:t>
+              <a:t>05  /  09</a:t>
             </a:r>
             <a:endParaRPr lang="en-US" sz="900" dirty="0"/>
           </a:p>
@@ -6452,7 +5224,7 @@
                 <a:ea typeface="Malgun Gothic" pitchFamily="34" charset="-122"/>
                 <a:cs typeface="Malgun Gothic" pitchFamily="34" charset="-120"/>
               </a:rPr>
-              <a:t>06  /  11</a:t>
+              <a:t>06  /  09</a:t>
             </a:r>
             <a:endParaRPr lang="en-US" sz="900" dirty="0"/>
           </a:p>
@@ -7274,7 +6046,7 @@
                 <a:ea typeface="Malgun Gothic" pitchFamily="34" charset="-122"/>
                 <a:cs typeface="Malgun Gothic" pitchFamily="34" charset="-120"/>
               </a:rPr>
-              <a:t>07  /  11</a:t>
+              <a:t>07  /  09</a:t>
             </a:r>
             <a:endParaRPr lang="en-US" sz="900" dirty="0"/>
           </a:p>
@@ -7294,7 +6066,7 @@
     <p:bg>
       <p:bgPr>
         <a:solidFill>
-          <a:srgbClr val="0A413D"/>
+          <a:srgbClr val="FFFFFF"/>
         </a:solidFill>
       </p:bgPr>
     </p:bg>
@@ -7339,13 +6111,13 @@
             <a:r>
               <a:rPr lang="en-US" sz="1100" b="1" spc="300" kern="0" dirty="0">
                 <a:solidFill>
-                  <a:srgbClr val="9FC6C1"/>
-                </a:solidFill>
-                <a:latin typeface="Malgun Gothic" pitchFamily="34" charset="0"/>
-                <a:ea typeface="Malgun Gothic" pitchFamily="34" charset="-122"/>
-                <a:cs typeface="Malgun Gothic" pitchFamily="34" charset="-120"/>
-              </a:rPr>
-              <a:t>핵심 발견</a:t>
+                  <a:srgbClr val="0E7C74"/>
+                </a:solidFill>
+                <a:latin typeface="Malgun Gothic" pitchFamily="34" charset="0"/>
+                <a:ea typeface="Malgun Gothic" pitchFamily="34" charset="-122"/>
+                <a:cs typeface="Malgun Gothic" pitchFamily="34" charset="-120"/>
+              </a:rPr>
+              <a:t>분석 계획</a:t>
             </a:r>
             <a:endParaRPr lang="en-US" sz="1100" dirty="0"/>
           </a:p>
@@ -7359,57 +6131,34 @@
         </p:nvSpPr>
         <p:spPr>
           <a:xfrm>
-            <a:off x="731520" y="1097280"/>
-            <a:ext cx="6583680" cy="1554480"/>
-          </a:xfrm>
-          <a:prstGeom prst="rect">
-            <a:avLst/>
-          </a:prstGeom>
-          <a:noFill/>
-          <a:ln/>
-        </p:spPr>
-        <p:txBody>
-          <a:bodyPr wrap="square" lIns="0" tIns="0" rIns="0" bIns="0" rtlCol="0" anchor="ctr"/>
-          <a:lstStyle/>
-          <a:p>
-            <a:pPr indent="0" marL="0">
-              <a:lnSpc>
-                <a:spcPct val="115000"/>
-              </a:lnSpc>
-              <a:buNone/>
-            </a:pPr>
-            <a:r>
-              <a:rPr lang="en-US" sz="3000" b="1" dirty="0">
-                <a:solidFill>
-                  <a:srgbClr val="FFFFFF"/>
-                </a:solidFill>
-                <a:latin typeface="Malgun Gothic" pitchFamily="34" charset="0"/>
-                <a:ea typeface="Malgun Gothic" pitchFamily="34" charset="-122"/>
-                <a:cs typeface="Malgun Gothic" pitchFamily="34" charset="-120"/>
-              </a:rPr>
-              <a:t>위험요인이 겹칠수록</a:t>
-            </a:r>
-            <a:endParaRPr lang="en-US" sz="3000" dirty="0"/>
-          </a:p>
-          <a:p>
-            <a:pPr indent="0" marL="0">
-              <a:lnSpc>
-                <a:spcPct val="115000"/>
-              </a:lnSpc>
-              <a:buNone/>
-            </a:pPr>
-            <a:r>
-              <a:rPr lang="en-US" sz="3000" b="1" dirty="0">
-                <a:solidFill>
-                  <a:srgbClr val="FFFFFF"/>
-                </a:solidFill>
-                <a:latin typeface="Malgun Gothic" pitchFamily="34" charset="0"/>
-                <a:ea typeface="Malgun Gothic" pitchFamily="34" charset="-122"/>
-                <a:cs typeface="Malgun Gothic" pitchFamily="34" charset="-120"/>
-              </a:rPr>
-              <a:t>위험은 급격히 커집니다</a:t>
-            </a:r>
-            <a:endParaRPr lang="en-US" sz="3000" dirty="0"/>
+            <a:off x="731520" y="868680"/>
+            <a:ext cx="10698480" cy="640080"/>
+          </a:xfrm>
+          <a:prstGeom prst="rect">
+            <a:avLst/>
+          </a:prstGeom>
+          <a:noFill/>
+          <a:ln/>
+        </p:spPr>
+        <p:txBody>
+          <a:bodyPr wrap="square" lIns="0" tIns="0" rIns="0" bIns="0" rtlCol="0" anchor="ctr"/>
+          <a:lstStyle/>
+          <a:p>
+            <a:pPr indent="0" marL="0">
+              <a:buNone/>
+            </a:pPr>
+            <a:r>
+              <a:rPr lang="en-US" sz="2700" b="1" dirty="0">
+                <a:solidFill>
+                  <a:srgbClr val="17211F"/>
+                </a:solidFill>
+                <a:latin typeface="Malgun Gothic" pitchFamily="34" charset="0"/>
+                <a:ea typeface="Malgun Gothic" pitchFamily="34" charset="-122"/>
+                <a:cs typeface="Malgun Gothic" pitchFamily="34" charset="-120"/>
+              </a:rPr>
+              <a:t>2단계에서 수행할 분석</a:t>
+            </a:r>
+            <a:endParaRPr lang="en-US" sz="2700" dirty="0"/>
           </a:p>
         </p:txBody>
       </p:sp>
@@ -7421,61 +6170,148 @@
         </p:nvSpPr>
         <p:spPr>
           <a:xfrm>
-            <a:off x="731520" y="3200400"/>
-            <a:ext cx="2743200" cy="914400"/>
-          </a:xfrm>
-          <a:prstGeom prst="rect">
-            <a:avLst/>
-          </a:prstGeom>
-          <a:noFill/>
-          <a:ln/>
-        </p:spPr>
-        <p:txBody>
-          <a:bodyPr wrap="square" lIns="0" tIns="0" rIns="0" bIns="0" rtlCol="0" anchor="ctr"/>
-          <a:lstStyle/>
-          <a:p>
-            <a:pPr indent="0" marL="0">
-              <a:buNone/>
-            </a:pPr>
-            <a:r>
-              <a:rPr lang="en-US" sz="5000" b="1" dirty="0">
-                <a:solidFill>
-                  <a:srgbClr val="9FC6C1"/>
-                </a:solidFill>
-                <a:latin typeface="Malgun Gothic" pitchFamily="34" charset="0"/>
-                <a:ea typeface="Malgun Gothic" pitchFamily="34" charset="-122"/>
-                <a:cs typeface="Malgun Gothic" pitchFamily="34" charset="-120"/>
-              </a:rPr>
-              <a:t>2.6</a:t>
-            </a:r>
-            <a:pPr indent="0" marL="0">
-              <a:buNone/>
-            </a:pPr>
-            <a:r>
-              <a:rPr lang="en-US" sz="2200" b="1" dirty="0">
-                <a:solidFill>
-                  <a:srgbClr val="9FC6C1"/>
-                </a:solidFill>
-                <a:latin typeface="Malgun Gothic" pitchFamily="34" charset="0"/>
-                <a:ea typeface="Malgun Gothic" pitchFamily="34" charset="-122"/>
-                <a:cs typeface="Malgun Gothic" pitchFamily="34" charset="-120"/>
-              </a:rPr>
-              <a:t>%</a:t>
-            </a:r>
-            <a:endParaRPr lang="en-US" sz="5000" dirty="0"/>
-          </a:p>
-        </p:txBody>
-      </p:sp>
-      <p:sp>
-        <p:nvSpPr>
-          <p:cNvPr id="5" name="Text 3"/>
-          <p:cNvSpPr txBox="1"/>
-          <p:nvPr/>
-        </p:nvSpPr>
-        <p:spPr>
-          <a:xfrm>
-            <a:off x="731520" y="4160520"/>
-            <a:ext cx="2743200" cy="320040"/>
+            <a:off x="731520" y="1600200"/>
+            <a:ext cx="10332720" cy="457200"/>
+          </a:xfrm>
+          <a:prstGeom prst="rect">
+            <a:avLst/>
+          </a:prstGeom>
+          <a:noFill/>
+          <a:ln/>
+        </p:spPr>
+        <p:txBody>
+          <a:bodyPr wrap="square" lIns="0" tIns="0" rIns="0" bIns="0" rtlCol="0" anchor="ctr"/>
+          <a:lstStyle/>
+          <a:p>
+            <a:pPr indent="0" marL="0">
+              <a:buNone/>
+            </a:pPr>
+            <a:r>
+              <a:rPr lang="en-US" sz="1450" dirty="0">
+                <a:solidFill>
+                  <a:srgbClr val="7C8A87"/>
+                </a:solidFill>
+                <a:latin typeface="Malgun Gothic" pitchFamily="34" charset="0"/>
+                <a:ea typeface="Malgun Gothic" pitchFamily="34" charset="-122"/>
+                <a:cs typeface="Malgun Gothic" pitchFamily="34" charset="-120"/>
+              </a:rPr>
+              <a:t>정규화된 DB를 SQL로 질의해 위험요인을 규명하고, 그 결과를 ANALYSIS_RESULT 테이블에 저장합니다.</a:t>
+            </a:r>
+            <a:endParaRPr lang="en-US" sz="1450" dirty="0"/>
+          </a:p>
+        </p:txBody>
+      </p:sp>
+      <p:sp>
+        <p:nvSpPr>
+          <p:cNvPr id="5" name="Shape 3"/>
+          <p:cNvSpPr/>
+          <p:nvPr/>
+        </p:nvSpPr>
+        <p:spPr>
+          <a:xfrm>
+            <a:off x="731520" y="2286000"/>
+            <a:ext cx="10698480" cy="0"/>
+          </a:xfrm>
+          <a:prstGeom prst="line">
+            <a:avLst/>
+          </a:prstGeom>
+          <a:noFill/>
+          <a:ln w="12700">
+            <a:solidFill>
+              <a:srgbClr val="DBE4E1"/>
+            </a:solidFill>
+            <a:prstDash val="solid"/>
+          </a:ln>
+        </p:spPr>
+      </p:sp>
+      <p:sp>
+        <p:nvSpPr>
+          <p:cNvPr id="6" name="Text 4"/>
+          <p:cNvSpPr txBox="1"/>
+          <p:nvPr/>
+        </p:nvSpPr>
+        <p:spPr>
+          <a:xfrm>
+            <a:off x="731520" y="2514600"/>
+            <a:ext cx="822960" cy="777240"/>
+          </a:xfrm>
+          <a:prstGeom prst="rect">
+            <a:avLst/>
+          </a:prstGeom>
+          <a:noFill/>
+          <a:ln/>
+        </p:spPr>
+        <p:txBody>
+          <a:bodyPr wrap="square" lIns="0" tIns="0" rIns="0" bIns="0" rtlCol="0" anchor="ctr"/>
+          <a:lstStyle/>
+          <a:p>
+            <a:pPr indent="0" marL="0">
+              <a:buNone/>
+            </a:pPr>
+            <a:r>
+              <a:rPr lang="en-US" sz="2400" b="1" dirty="0">
+                <a:solidFill>
+                  <a:srgbClr val="EDF1F0"/>
+                </a:solidFill>
+                <a:latin typeface="Malgun Gothic" pitchFamily="34" charset="0"/>
+                <a:ea typeface="Malgun Gothic" pitchFamily="34" charset="-122"/>
+                <a:cs typeface="Malgun Gothic" pitchFamily="34" charset="-120"/>
+              </a:rPr>
+              <a:t>01</a:t>
+            </a:r>
+            <a:endParaRPr lang="en-US" sz="2400" dirty="0"/>
+          </a:p>
+        </p:txBody>
+      </p:sp>
+      <p:sp>
+        <p:nvSpPr>
+          <p:cNvPr id="7" name="Text 5"/>
+          <p:cNvSpPr txBox="1"/>
+          <p:nvPr/>
+        </p:nvSpPr>
+        <p:spPr>
+          <a:xfrm>
+            <a:off x="1691640" y="2514600"/>
+            <a:ext cx="3291840" cy="777240"/>
+          </a:xfrm>
+          <a:prstGeom prst="rect">
+            <a:avLst/>
+          </a:prstGeom>
+          <a:noFill/>
+          <a:ln/>
+        </p:spPr>
+        <p:txBody>
+          <a:bodyPr wrap="square" lIns="0" tIns="0" rIns="0" bIns="0" rtlCol="0" anchor="ctr"/>
+          <a:lstStyle/>
+          <a:p>
+            <a:pPr indent="0" marL="0">
+              <a:buNone/>
+            </a:pPr>
+            <a:r>
+              <a:rPr lang="en-US" sz="1550" b="1" dirty="0">
+                <a:solidFill>
+                  <a:srgbClr val="17211F"/>
+                </a:solidFill>
+                <a:latin typeface="Malgun Gothic" pitchFamily="34" charset="0"/>
+                <a:ea typeface="Malgun Gothic" pitchFamily="34" charset="-122"/>
+                <a:cs typeface="Malgun Gothic" pitchFamily="34" charset="-120"/>
+              </a:rPr>
+              <a:t>기술 통계 분석</a:t>
+            </a:r>
+            <a:endParaRPr lang="en-US" sz="1550" dirty="0"/>
+          </a:p>
+        </p:txBody>
+      </p:sp>
+      <p:sp>
+        <p:nvSpPr>
+          <p:cNvPr id="8" name="Text 6"/>
+          <p:cNvSpPr txBox="1"/>
+          <p:nvPr/>
+        </p:nvSpPr>
+        <p:spPr>
+          <a:xfrm>
+            <a:off x="5074920" y="2514600"/>
+            <a:ext cx="4754880" cy="777240"/>
           </a:xfrm>
           <a:prstGeom prst="rect">
             <a:avLst/>
@@ -7493,13 +6329,13 @@
             <a:r>
               <a:rPr lang="en-US" sz="1300" dirty="0">
                 <a:solidFill>
-                  <a:srgbClr val="9FC6C1"/>
-                </a:solidFill>
-                <a:latin typeface="Malgun Gothic" pitchFamily="34" charset="0"/>
-                <a:ea typeface="Malgun Gothic" pitchFamily="34" charset="-122"/>
-                <a:cs typeface="Malgun Gothic" pitchFamily="34" charset="-120"/>
-              </a:rPr>
-              <a:t>위험요인 0개</a:t>
+                  <a:srgbClr val="7C8A87"/>
+                </a:solidFill>
+                <a:latin typeface="Malgun Gothic" pitchFamily="34" charset="0"/>
+                <a:ea typeface="Malgun Gothic" pitchFamily="34" charset="-122"/>
+                <a:cs typeface="Malgun Gothic" pitchFamily="34" charset="-120"/>
+              </a:rPr>
+              <a:t>연령·성별·BMI·소득·학력별 당뇨병 비율</a:t>
             </a:r>
             <a:endParaRPr lang="en-US" sz="1300" dirty="0"/>
           </a:p>
@@ -7507,30 +6343,170 @@
       </p:sp>
       <p:sp>
         <p:nvSpPr>
-          <p:cNvPr id="6" name="Text 4"/>
-          <p:cNvSpPr txBox="1"/>
-          <p:nvPr/>
-        </p:nvSpPr>
-        <p:spPr>
-          <a:xfrm>
-            <a:off x="3200400" y="3246120"/>
-            <a:ext cx="822960" cy="822960"/>
-          </a:xfrm>
-          <a:prstGeom prst="rect">
-            <a:avLst/>
-          </a:prstGeom>
-          <a:noFill/>
-          <a:ln/>
-        </p:spPr>
-        <p:txBody>
-          <a:bodyPr wrap="square" lIns="0" tIns="0" rIns="0" bIns="0" rtlCol="0" anchor="ctr"/>
-          <a:lstStyle/>
-          <a:p>
-            <a:pPr algn="ctr" indent="0" marL="0">
-              <a:buNone/>
-            </a:pPr>
-            <a:r>
-              <a:rPr lang="en-US" sz="3000" dirty="0">
+          <p:cNvPr id="9" name="Text 7"/>
+          <p:cNvSpPr txBox="1"/>
+          <p:nvPr/>
+        </p:nvSpPr>
+        <p:spPr>
+          <a:xfrm>
+            <a:off x="9875520" y="2514600"/>
+            <a:ext cx="1554480" cy="777240"/>
+          </a:xfrm>
+          <a:prstGeom prst="rect">
+            <a:avLst/>
+          </a:prstGeom>
+          <a:noFill/>
+          <a:ln/>
+        </p:spPr>
+        <p:txBody>
+          <a:bodyPr wrap="square" lIns="0" tIns="0" rIns="0" bIns="0" rtlCol="0" anchor="ctr"/>
+          <a:lstStyle/>
+          <a:p>
+            <a:pPr indent="0" marL="0">
+              <a:buNone/>
+            </a:pPr>
+            <a:r>
+              <a:rPr lang="en-US" sz="1050" dirty="0">
+                <a:solidFill>
+                  <a:srgbClr val="0E7C74"/>
+                </a:solidFill>
+                <a:latin typeface="Malgun Gothic" pitchFamily="34" charset="0"/>
+                <a:ea typeface="Malgun Gothic" pitchFamily="34" charset="-122"/>
+                <a:cs typeface="Malgun Gothic" pitchFamily="34" charset="-120"/>
+              </a:rPr>
+              <a:t>GROUP BY · CASE · AVG</a:t>
+            </a:r>
+            <a:endParaRPr lang="en-US" sz="1050" dirty="0"/>
+          </a:p>
+        </p:txBody>
+      </p:sp>
+      <p:sp>
+        <p:nvSpPr>
+          <p:cNvPr id="10" name="Shape 8"/>
+          <p:cNvSpPr/>
+          <p:nvPr/>
+        </p:nvSpPr>
+        <p:spPr>
+          <a:xfrm>
+            <a:off x="731520" y="3319272"/>
+            <a:ext cx="10698480" cy="0"/>
+          </a:xfrm>
+          <a:prstGeom prst="line">
+            <a:avLst/>
+          </a:prstGeom>
+          <a:noFill/>
+          <a:ln w="12700">
+            <a:solidFill>
+              <a:srgbClr val="DBE4E1"/>
+            </a:solidFill>
+            <a:prstDash val="solid"/>
+          </a:ln>
+        </p:spPr>
+      </p:sp>
+      <p:sp>
+        <p:nvSpPr>
+          <p:cNvPr id="11" name="Text 9"/>
+          <p:cNvSpPr txBox="1"/>
+          <p:nvPr/>
+        </p:nvSpPr>
+        <p:spPr>
+          <a:xfrm>
+            <a:off x="731520" y="3410712"/>
+            <a:ext cx="822960" cy="777240"/>
+          </a:xfrm>
+          <a:prstGeom prst="rect">
+            <a:avLst/>
+          </a:prstGeom>
+          <a:noFill/>
+          <a:ln/>
+        </p:spPr>
+        <p:txBody>
+          <a:bodyPr wrap="square" lIns="0" tIns="0" rIns="0" bIns="0" rtlCol="0" anchor="ctr"/>
+          <a:lstStyle/>
+          <a:p>
+            <a:pPr indent="0" marL="0">
+              <a:buNone/>
+            </a:pPr>
+            <a:r>
+              <a:rPr lang="en-US" sz="2400" b="1" dirty="0">
+                <a:solidFill>
+                  <a:srgbClr val="EDF1F0"/>
+                </a:solidFill>
+                <a:latin typeface="Malgun Gothic" pitchFamily="34" charset="0"/>
+                <a:ea typeface="Malgun Gothic" pitchFamily="34" charset="-122"/>
+                <a:cs typeface="Malgun Gothic" pitchFamily="34" charset="-120"/>
+              </a:rPr>
+              <a:t>02</a:t>
+            </a:r>
+            <a:endParaRPr lang="en-US" sz="2400" dirty="0"/>
+          </a:p>
+        </p:txBody>
+      </p:sp>
+      <p:sp>
+        <p:nvSpPr>
+          <p:cNvPr id="12" name="Text 10"/>
+          <p:cNvSpPr txBox="1"/>
+          <p:nvPr/>
+        </p:nvSpPr>
+        <p:spPr>
+          <a:xfrm>
+            <a:off x="1691640" y="3410712"/>
+            <a:ext cx="3291840" cy="777240"/>
+          </a:xfrm>
+          <a:prstGeom prst="rect">
+            <a:avLst/>
+          </a:prstGeom>
+          <a:noFill/>
+          <a:ln/>
+        </p:spPr>
+        <p:txBody>
+          <a:bodyPr wrap="square" lIns="0" tIns="0" rIns="0" bIns="0" rtlCol="0" anchor="ctr"/>
+          <a:lstStyle/>
+          <a:p>
+            <a:pPr indent="0" marL="0">
+              <a:buNone/>
+            </a:pPr>
+            <a:r>
+              <a:rPr lang="en-US" sz="1550" b="1" dirty="0">
+                <a:solidFill>
+                  <a:srgbClr val="17211F"/>
+                </a:solidFill>
+                <a:latin typeface="Malgun Gothic" pitchFamily="34" charset="0"/>
+                <a:ea typeface="Malgun Gothic" pitchFamily="34" charset="-122"/>
+                <a:cs typeface="Malgun Gothic" pitchFamily="34" charset="-120"/>
+              </a:rPr>
+              <a:t>조합 · 상호작용</a:t>
+            </a:r>
+            <a:endParaRPr lang="en-US" sz="1550" dirty="0"/>
+          </a:p>
+        </p:txBody>
+      </p:sp>
+      <p:sp>
+        <p:nvSpPr>
+          <p:cNvPr id="13" name="Text 11"/>
+          <p:cNvSpPr txBox="1"/>
+          <p:nvPr/>
+        </p:nvSpPr>
+        <p:spPr>
+          <a:xfrm>
+            <a:off x="5074920" y="3410712"/>
+            <a:ext cx="4754880" cy="777240"/>
+          </a:xfrm>
+          <a:prstGeom prst="rect">
+            <a:avLst/>
+          </a:prstGeom>
+          <a:noFill/>
+          <a:ln/>
+        </p:spPr>
+        <p:txBody>
+          <a:bodyPr wrap="square" lIns="0" tIns="0" rIns="0" bIns="0" rtlCol="0" anchor="ctr"/>
+          <a:lstStyle/>
+          <a:p>
+            <a:pPr indent="0" marL="0">
+              <a:buNone/>
+            </a:pPr>
+            <a:r>
+              <a:rPr lang="en-US" sz="1300" dirty="0">
                 <a:solidFill>
                   <a:srgbClr val="7C8A87"/>
                 </a:solidFill>
@@ -7538,75 +6514,162 @@
                 <a:ea typeface="Malgun Gothic" pitchFamily="34" charset="-122"/>
                 <a:cs typeface="Malgun Gothic" pitchFamily="34" charset="-120"/>
               </a:rPr>
-              <a:t>→</a:t>
-            </a:r>
-            <a:endParaRPr lang="en-US" sz="3000" dirty="0"/>
-          </a:p>
-        </p:txBody>
-      </p:sp>
-      <p:sp>
-        <p:nvSpPr>
-          <p:cNvPr id="7" name="Text 5"/>
-          <p:cNvSpPr txBox="1"/>
-          <p:nvPr/>
-        </p:nvSpPr>
-        <p:spPr>
-          <a:xfrm>
-            <a:off x="4114800" y="3200400"/>
-            <a:ext cx="2377440" cy="914400"/>
-          </a:xfrm>
-          <a:prstGeom prst="rect">
-            <a:avLst/>
-          </a:prstGeom>
-          <a:noFill/>
-          <a:ln/>
-        </p:spPr>
-        <p:txBody>
-          <a:bodyPr wrap="square" lIns="0" tIns="0" rIns="0" bIns="0" rtlCol="0" anchor="ctr"/>
-          <a:lstStyle/>
-          <a:p>
-            <a:pPr indent="0" marL="0">
-              <a:buNone/>
-            </a:pPr>
-            <a:r>
-              <a:rPr lang="en-US" sz="5000" b="1" dirty="0">
-                <a:solidFill>
-                  <a:srgbClr val="DD6B4D"/>
-                </a:solidFill>
-                <a:latin typeface="Malgun Gothic" pitchFamily="34" charset="0"/>
-                <a:ea typeface="Malgun Gothic" pitchFamily="34" charset="-122"/>
-                <a:cs typeface="Malgun Gothic" pitchFamily="34" charset="-120"/>
-              </a:rPr>
-              <a:t>46.4</a:t>
-            </a:r>
-            <a:pPr indent="0" marL="0">
-              <a:buNone/>
-            </a:pPr>
-            <a:r>
-              <a:rPr lang="en-US" sz="2200" b="1" dirty="0">
-                <a:solidFill>
-                  <a:srgbClr val="DD6B4D"/>
-                </a:solidFill>
-                <a:latin typeface="Malgun Gothic" pitchFamily="34" charset="0"/>
-                <a:ea typeface="Malgun Gothic" pitchFamily="34" charset="-122"/>
-                <a:cs typeface="Malgun Gothic" pitchFamily="34" charset="-120"/>
-              </a:rPr>
-              <a:t>%</a:t>
-            </a:r>
-            <a:endParaRPr lang="en-US" sz="5000" dirty="0"/>
-          </a:p>
-        </p:txBody>
-      </p:sp>
-      <p:sp>
-        <p:nvSpPr>
-          <p:cNvPr id="8" name="Text 6"/>
-          <p:cNvSpPr txBox="1"/>
-          <p:nvPr/>
-        </p:nvSpPr>
-        <p:spPr>
-          <a:xfrm>
-            <a:off x="4114800" y="4160520"/>
-            <a:ext cx="2743200" cy="320040"/>
+              <a:t>위험요인 개수, 고혈압 × 비만 등 복합 위험</a:t>
+            </a:r>
+            <a:endParaRPr lang="en-US" sz="1300" dirty="0"/>
+          </a:p>
+        </p:txBody>
+      </p:sp>
+      <p:sp>
+        <p:nvSpPr>
+          <p:cNvPr id="14" name="Text 12"/>
+          <p:cNvSpPr txBox="1"/>
+          <p:nvPr/>
+        </p:nvSpPr>
+        <p:spPr>
+          <a:xfrm>
+            <a:off x="9875520" y="3410712"/>
+            <a:ext cx="1554480" cy="777240"/>
+          </a:xfrm>
+          <a:prstGeom prst="rect">
+            <a:avLst/>
+          </a:prstGeom>
+          <a:noFill/>
+          <a:ln/>
+        </p:spPr>
+        <p:txBody>
+          <a:bodyPr wrap="square" lIns="0" tIns="0" rIns="0" bIns="0" rtlCol="0" anchor="ctr"/>
+          <a:lstStyle/>
+          <a:p>
+            <a:pPr indent="0" marL="0">
+              <a:buNone/>
+            </a:pPr>
+            <a:r>
+              <a:rPr lang="en-US" sz="1050" dirty="0">
+                <a:solidFill>
+                  <a:srgbClr val="0E7C74"/>
+                </a:solidFill>
+                <a:latin typeface="Malgun Gothic" pitchFamily="34" charset="0"/>
+                <a:ea typeface="Malgun Gothic" pitchFamily="34" charset="-122"/>
+                <a:cs typeface="Malgun Gothic" pitchFamily="34" charset="-120"/>
+              </a:rPr>
+              <a:t>다중 조건 집계</a:t>
+            </a:r>
+            <a:endParaRPr lang="en-US" sz="1050" dirty="0"/>
+          </a:p>
+        </p:txBody>
+      </p:sp>
+      <p:sp>
+        <p:nvSpPr>
+          <p:cNvPr id="15" name="Shape 13"/>
+          <p:cNvSpPr/>
+          <p:nvPr/>
+        </p:nvSpPr>
+        <p:spPr>
+          <a:xfrm>
+            <a:off x="731520" y="4215384"/>
+            <a:ext cx="10698480" cy="0"/>
+          </a:xfrm>
+          <a:prstGeom prst="line">
+            <a:avLst/>
+          </a:prstGeom>
+          <a:noFill/>
+          <a:ln w="12700">
+            <a:solidFill>
+              <a:srgbClr val="DBE4E1"/>
+            </a:solidFill>
+            <a:prstDash val="solid"/>
+          </a:ln>
+        </p:spPr>
+      </p:sp>
+      <p:sp>
+        <p:nvSpPr>
+          <p:cNvPr id="16" name="Text 14"/>
+          <p:cNvSpPr txBox="1"/>
+          <p:nvPr/>
+        </p:nvSpPr>
+        <p:spPr>
+          <a:xfrm>
+            <a:off x="731520" y="4306824"/>
+            <a:ext cx="822960" cy="777240"/>
+          </a:xfrm>
+          <a:prstGeom prst="rect">
+            <a:avLst/>
+          </a:prstGeom>
+          <a:noFill/>
+          <a:ln/>
+        </p:spPr>
+        <p:txBody>
+          <a:bodyPr wrap="square" lIns="0" tIns="0" rIns="0" bIns="0" rtlCol="0" anchor="ctr"/>
+          <a:lstStyle/>
+          <a:p>
+            <a:pPr indent="0" marL="0">
+              <a:buNone/>
+            </a:pPr>
+            <a:r>
+              <a:rPr lang="en-US" sz="2400" b="1" dirty="0">
+                <a:solidFill>
+                  <a:srgbClr val="EDF1F0"/>
+                </a:solidFill>
+                <a:latin typeface="Malgun Gothic" pitchFamily="34" charset="0"/>
+                <a:ea typeface="Malgun Gothic" pitchFamily="34" charset="-122"/>
+                <a:cs typeface="Malgun Gothic" pitchFamily="34" charset="-120"/>
+              </a:rPr>
+              <a:t>03</a:t>
+            </a:r>
+            <a:endParaRPr lang="en-US" sz="2400" dirty="0"/>
+          </a:p>
+        </p:txBody>
+      </p:sp>
+      <p:sp>
+        <p:nvSpPr>
+          <p:cNvPr id="17" name="Text 15"/>
+          <p:cNvSpPr txBox="1"/>
+          <p:nvPr/>
+        </p:nvSpPr>
+        <p:spPr>
+          <a:xfrm>
+            <a:off x="1691640" y="4306824"/>
+            <a:ext cx="3291840" cy="777240"/>
+          </a:xfrm>
+          <a:prstGeom prst="rect">
+            <a:avLst/>
+          </a:prstGeom>
+          <a:noFill/>
+          <a:ln/>
+        </p:spPr>
+        <p:txBody>
+          <a:bodyPr wrap="square" lIns="0" tIns="0" rIns="0" bIns="0" rtlCol="0" anchor="ctr"/>
+          <a:lstStyle/>
+          <a:p>
+            <a:pPr indent="0" marL="0">
+              <a:buNone/>
+            </a:pPr>
+            <a:r>
+              <a:rPr lang="en-US" sz="1550" b="1" dirty="0">
+                <a:solidFill>
+                  <a:srgbClr val="17211F"/>
+                </a:solidFill>
+                <a:latin typeface="Malgun Gothic" pitchFamily="34" charset="0"/>
+                <a:ea typeface="Malgun Gothic" pitchFamily="34" charset="-122"/>
+                <a:cs typeface="Malgun Gothic" pitchFamily="34" charset="-120"/>
+              </a:rPr>
+              <a:t>통계 검정</a:t>
+            </a:r>
+            <a:endParaRPr lang="en-US" sz="1550" dirty="0"/>
+          </a:p>
+        </p:txBody>
+      </p:sp>
+      <p:sp>
+        <p:nvSpPr>
+          <p:cNvPr id="18" name="Text 16"/>
+          <p:cNvSpPr txBox="1"/>
+          <p:nvPr/>
+        </p:nvSpPr>
+        <p:spPr>
+          <a:xfrm>
+            <a:off x="5074920" y="4306824"/>
+            <a:ext cx="4754880" cy="777240"/>
           </a:xfrm>
           <a:prstGeom prst="rect">
             <a:avLst/>
@@ -7624,76 +6687,231 @@
             <a:r>
               <a:rPr lang="en-US" sz="1300" dirty="0">
                 <a:solidFill>
-                  <a:srgbClr val="F1C9B8"/>
-                </a:solidFill>
-                <a:latin typeface="Malgun Gothic" pitchFamily="34" charset="0"/>
-                <a:ea typeface="Malgun Gothic" pitchFamily="34" charset="-122"/>
-                <a:cs typeface="Malgun Gothic" pitchFamily="34" charset="-120"/>
-              </a:rPr>
-              <a:t>위험요인 5개 — 약 18배</a:t>
+                  <a:srgbClr val="7C8A87"/>
+                </a:solidFill>
+                <a:latin typeface="Malgun Gothic" pitchFamily="34" charset="0"/>
+                <a:ea typeface="Malgun Gothic" pitchFamily="34" charset="-122"/>
+                <a:cs typeface="Malgun Gothic" pitchFamily="34" charset="-120"/>
+              </a:rPr>
+              <a:t>요인별 오즈비(Odds Ratio) · 카이제곱 검정</a:t>
             </a:r>
             <a:endParaRPr lang="en-US" sz="1300" dirty="0"/>
           </a:p>
         </p:txBody>
       </p:sp>
-      <p:pic>
-        <p:nvPicPr>
-          <p:cNvPr id="9" name="Image 0" descr="/home/user/diabetes/fig_risk.png">    </p:cNvPr>
-          <p:cNvPicPr>
-            <a:picLocks noChangeAspect="1"/>
-          </p:cNvPicPr>
-          <p:nvPr/>
-        </p:nvPicPr>
-        <p:blipFill>
-          <a:blip r:embed="rId1"/>
-          <a:stretch>
-            <a:fillRect/>
-          </a:stretch>
-        </p:blipFill>
-        <p:spPr>
-          <a:xfrm>
-            <a:off x="7040880" y="1600200"/>
-            <a:ext cx="4572000" cy="2788920"/>
-          </a:xfrm>
-          <a:prstGeom prst="rect">
-            <a:avLst/>
-          </a:prstGeom>
-        </p:spPr>
-      </p:pic>
-      <p:sp>
-        <p:nvSpPr>
-          <p:cNvPr id="10" name="Text 7"/>
-          <p:cNvSpPr txBox="1"/>
-          <p:nvPr/>
-        </p:nvSpPr>
-        <p:spPr>
-          <a:xfrm>
-            <a:off x="7040880" y="4434840"/>
-            <a:ext cx="4572000" cy="548640"/>
-          </a:xfrm>
-          <a:prstGeom prst="rect">
-            <a:avLst/>
-          </a:prstGeom>
-          <a:noFill/>
-          <a:ln/>
-        </p:spPr>
-        <p:txBody>
-          <a:bodyPr wrap="square" lIns="0" tIns="0" rIns="0" bIns="0" rtlCol="0" anchor="ctr"/>
-          <a:lstStyle/>
-          <a:p>
-            <a:pPr algn="ctr" indent="0" marL="0">
+      <p:sp>
+        <p:nvSpPr>
+          <p:cNvPr id="19" name="Text 17"/>
+          <p:cNvSpPr txBox="1"/>
+          <p:nvPr/>
+        </p:nvSpPr>
+        <p:spPr>
+          <a:xfrm>
+            <a:off x="9875520" y="4306824"/>
+            <a:ext cx="1554480" cy="777240"/>
+          </a:xfrm>
+          <a:prstGeom prst="rect">
+            <a:avLst/>
+          </a:prstGeom>
+          <a:noFill/>
+          <a:ln/>
+        </p:spPr>
+        <p:txBody>
+          <a:bodyPr wrap="square" lIns="0" tIns="0" rIns="0" bIns="0" rtlCol="0" anchor="ctr"/>
+          <a:lstStyle/>
+          <a:p>
+            <a:pPr indent="0" marL="0">
               <a:buNone/>
             </a:pPr>
             <a:r>
               <a:rPr lang="en-US" sz="1050" dirty="0">
                 <a:solidFill>
+                  <a:srgbClr val="0E7C74"/>
+                </a:solidFill>
+                <a:latin typeface="Malgun Gothic" pitchFamily="34" charset="0"/>
+                <a:ea typeface="Malgun Gothic" pitchFamily="34" charset="-122"/>
+                <a:cs typeface="Malgun Gothic" pitchFamily="34" charset="-120"/>
+              </a:rPr>
+              <a:t>이진 데이터에 적합</a:t>
+            </a:r>
+            <a:endParaRPr lang="en-US" sz="1050" dirty="0"/>
+          </a:p>
+        </p:txBody>
+      </p:sp>
+      <p:sp>
+        <p:nvSpPr>
+          <p:cNvPr id="20" name="Shape 18"/>
+          <p:cNvSpPr/>
+          <p:nvPr/>
+        </p:nvSpPr>
+        <p:spPr>
+          <a:xfrm>
+            <a:off x="731520" y="5111496"/>
+            <a:ext cx="10698480" cy="0"/>
+          </a:xfrm>
+          <a:prstGeom prst="line">
+            <a:avLst/>
+          </a:prstGeom>
+          <a:noFill/>
+          <a:ln w="12700">
+            <a:solidFill>
+              <a:srgbClr val="DBE4E1"/>
+            </a:solidFill>
+            <a:prstDash val="solid"/>
+          </a:ln>
+        </p:spPr>
+      </p:sp>
+      <p:sp>
+        <p:nvSpPr>
+          <p:cNvPr id="21" name="Text 19"/>
+          <p:cNvSpPr txBox="1"/>
+          <p:nvPr/>
+        </p:nvSpPr>
+        <p:spPr>
+          <a:xfrm>
+            <a:off x="731520" y="5202936"/>
+            <a:ext cx="822960" cy="777240"/>
+          </a:xfrm>
+          <a:prstGeom prst="rect">
+            <a:avLst/>
+          </a:prstGeom>
+          <a:noFill/>
+          <a:ln/>
+        </p:spPr>
+        <p:txBody>
+          <a:bodyPr wrap="square" lIns="0" tIns="0" rIns="0" bIns="0" rtlCol="0" anchor="ctr"/>
+          <a:lstStyle/>
+          <a:p>
+            <a:pPr indent="0" marL="0">
+              <a:buNone/>
+            </a:pPr>
+            <a:r>
+              <a:rPr lang="en-US" sz="2400" b="1" dirty="0">
+                <a:solidFill>
+                  <a:srgbClr val="EDF1F0"/>
+                </a:solidFill>
+                <a:latin typeface="Malgun Gothic" pitchFamily="34" charset="0"/>
+                <a:ea typeface="Malgun Gothic" pitchFamily="34" charset="-122"/>
+                <a:cs typeface="Malgun Gothic" pitchFamily="34" charset="-120"/>
+              </a:rPr>
+              <a:t>04</a:t>
+            </a:r>
+            <a:endParaRPr lang="en-US" sz="2400" dirty="0"/>
+          </a:p>
+        </p:txBody>
+      </p:sp>
+      <p:sp>
+        <p:nvSpPr>
+          <p:cNvPr id="22" name="Text 20"/>
+          <p:cNvSpPr txBox="1"/>
+          <p:nvPr/>
+        </p:nvSpPr>
+        <p:spPr>
+          <a:xfrm>
+            <a:off x="1691640" y="5202936"/>
+            <a:ext cx="3291840" cy="777240"/>
+          </a:xfrm>
+          <a:prstGeom prst="rect">
+            <a:avLst/>
+          </a:prstGeom>
+          <a:noFill/>
+          <a:ln/>
+        </p:spPr>
+        <p:txBody>
+          <a:bodyPr wrap="square" lIns="0" tIns="0" rIns="0" bIns="0" rtlCol="0" anchor="ctr"/>
+          <a:lstStyle/>
+          <a:p>
+            <a:pPr indent="0" marL="0">
+              <a:buNone/>
+            </a:pPr>
+            <a:r>
+              <a:rPr lang="en-US" sz="1550" b="1" dirty="0">
+                <a:solidFill>
+                  <a:srgbClr val="17211F"/>
+                </a:solidFill>
+                <a:latin typeface="Malgun Gothic" pitchFamily="34" charset="0"/>
+                <a:ea typeface="Malgun Gothic" pitchFamily="34" charset="-122"/>
+                <a:cs typeface="Malgun Gothic" pitchFamily="34" charset="-120"/>
+              </a:rPr>
+              <a:t>예측 모델링</a:t>
+            </a:r>
+            <a:endParaRPr lang="en-US" sz="1550" dirty="0"/>
+          </a:p>
+        </p:txBody>
+      </p:sp>
+      <p:sp>
+        <p:nvSpPr>
+          <p:cNvPr id="23" name="Text 21"/>
+          <p:cNvSpPr txBox="1"/>
+          <p:nvPr/>
+        </p:nvSpPr>
+        <p:spPr>
+          <a:xfrm>
+            <a:off x="5074920" y="5202936"/>
+            <a:ext cx="4754880" cy="777240"/>
+          </a:xfrm>
+          <a:prstGeom prst="rect">
+            <a:avLst/>
+          </a:prstGeom>
+          <a:noFill/>
+          <a:ln/>
+        </p:spPr>
+        <p:txBody>
+          <a:bodyPr wrap="square" lIns="0" tIns="0" rIns="0" bIns="0" rtlCol="0" anchor="ctr"/>
+          <a:lstStyle/>
+          <a:p>
+            <a:pPr indent="0" marL="0">
+              <a:buNone/>
+            </a:pPr>
+            <a:r>
+              <a:rPr lang="en-US" sz="1300" dirty="0">
+                <a:solidFill>
                   <a:srgbClr val="7C8A87"/>
                 </a:solidFill>
                 <a:latin typeface="Malgun Gothic" pitchFamily="34" charset="0"/>
                 <a:ea typeface="Malgun Gothic" pitchFamily="34" charset="-122"/>
                 <a:cs typeface="Malgun Gothic" pitchFamily="34" charset="-120"/>
               </a:rPr>
-              <a:t>위험요인 개수별 당뇨병 비율 — 고혈압·고콜레스테롤·흡연·운동부족·비만</a:t>
+              <a:t>로지스틱 회귀로 위험요인 기여도 추정</a:t>
+            </a:r>
+            <a:endParaRPr lang="en-US" sz="1300" dirty="0"/>
+          </a:p>
+        </p:txBody>
+      </p:sp>
+      <p:sp>
+        <p:nvSpPr>
+          <p:cNvPr id="24" name="Text 22"/>
+          <p:cNvSpPr txBox="1"/>
+          <p:nvPr/>
+        </p:nvSpPr>
+        <p:spPr>
+          <a:xfrm>
+            <a:off x="9875520" y="5202936"/>
+            <a:ext cx="1554480" cy="777240"/>
+          </a:xfrm>
+          <a:prstGeom prst="rect">
+            <a:avLst/>
+          </a:prstGeom>
+          <a:noFill/>
+          <a:ln/>
+        </p:spPr>
+        <p:txBody>
+          <a:bodyPr wrap="square" lIns="0" tIns="0" rIns="0" bIns="0" rtlCol="0" anchor="ctr"/>
+          <a:lstStyle/>
+          <a:p>
+            <a:pPr indent="0" marL="0">
+              <a:buNone/>
+            </a:pPr>
+            <a:r>
+              <a:rPr lang="en-US" sz="1050" dirty="0">
+                <a:solidFill>
+                  <a:srgbClr val="0E7C74"/>
+                </a:solidFill>
+                <a:latin typeface="Malgun Gothic" pitchFamily="34" charset="0"/>
+                <a:ea typeface="Malgun Gothic" pitchFamily="34" charset="-122"/>
+                <a:cs typeface="Malgun Gothic" pitchFamily="34" charset="-120"/>
+              </a:rPr>
+              <a:t>2 · 3단계 진행</a:t>
             </a:r>
             <a:endParaRPr lang="en-US" sz="1050" dirty="0"/>
           </a:p>
@@ -7701,7 +6919,46 @@
       </p:sp>
       <p:sp>
         <p:nvSpPr>
-          <p:cNvPr id="11" name="Text 8"/>
+          <p:cNvPr id="25" name="Text 23"/>
+          <p:cNvSpPr txBox="1"/>
+          <p:nvPr/>
+        </p:nvSpPr>
+        <p:spPr>
+          <a:xfrm>
+            <a:off x="731520" y="6172200"/>
+            <a:ext cx="10698480" cy="320040"/>
+          </a:xfrm>
+          <a:prstGeom prst="rect">
+            <a:avLst/>
+          </a:prstGeom>
+          <a:noFill/>
+          <a:ln/>
+        </p:spPr>
+        <p:txBody>
+          <a:bodyPr wrap="square" lIns="0" tIns="0" rIns="0" bIns="0" rtlCol="0" anchor="ctr"/>
+          <a:lstStyle/>
+          <a:p>
+            <a:pPr indent="0" marL="0">
+              <a:buNone/>
+            </a:pPr>
+            <a:r>
+              <a:rPr lang="en-US" sz="1200" i="1" dirty="0">
+                <a:solidFill>
+                  <a:srgbClr val="0E7C74"/>
+                </a:solidFill>
+                <a:latin typeface="Malgun Gothic" pitchFamily="34" charset="0"/>
+                <a:ea typeface="Malgun Gothic" pitchFamily="34" charset="-122"/>
+                <a:cs typeface="Malgun Gothic" pitchFamily="34" charset="-120"/>
+              </a:rPr>
+              <a:t>분석 결과 저장 테이블(ANALYSIS_RESULT)까지 1단계에서 설계 완료 → 2단계에서 채웁니다.</a:t>
+            </a:r>
+            <a:endParaRPr lang="en-US" sz="1200" dirty="0"/>
+          </a:p>
+        </p:txBody>
+      </p:sp>
+      <p:sp>
+        <p:nvSpPr>
+          <p:cNvPr id="26" name="Text 24"/>
           <p:cNvSpPr txBox="1"/>
           <p:nvPr/>
         </p:nvSpPr>
@@ -7726,13 +6983,13 @@
             <a:r>
               <a:rPr lang="en-US" sz="900" spc="100" kern="0" dirty="0">
                 <a:solidFill>
-                  <a:srgbClr val="9FC6C1"/>
-                </a:solidFill>
-                <a:latin typeface="Malgun Gothic" pitchFamily="34" charset="0"/>
-                <a:ea typeface="Malgun Gothic" pitchFamily="34" charset="-122"/>
-                <a:cs typeface="Malgun Gothic" pitchFamily="34" charset="-120"/>
-              </a:rPr>
-              <a:t>08  /  11</a:t>
+                  <a:srgbClr val="7C8A87"/>
+                </a:solidFill>
+                <a:latin typeface="Malgun Gothic" pitchFamily="34" charset="0"/>
+                <a:ea typeface="Malgun Gothic" pitchFamily="34" charset="-122"/>
+                <a:cs typeface="Malgun Gothic" pitchFamily="34" charset="-120"/>
+              </a:rPr>
+              <a:t>08  /  09</a:t>
             </a:r>
             <a:endParaRPr lang="en-US" sz="900" dirty="0"/>
           </a:p>
@@ -7803,7 +7060,7 @@
                 <a:ea typeface="Malgun Gothic" pitchFamily="34" charset="-122"/>
                 <a:cs typeface="Malgun Gothic" pitchFamily="34" charset="-120"/>
               </a:rPr>
-              <a:t>분석 결과 ①</a:t>
+              <a:t>1단계 마무리</a:t>
             </a:r>
             <a:endParaRPr lang="en-US" sz="1100" dirty="0"/>
           </a:p>
@@ -7817,24 +7074,44 @@
         </p:nvSpPr>
         <p:spPr>
           <a:xfrm>
-            <a:off x="731520" y="868680"/>
-            <a:ext cx="10698480" cy="640080"/>
-          </a:xfrm>
-          <a:prstGeom prst="rect">
-            <a:avLst/>
-          </a:prstGeom>
-          <a:noFill/>
-          <a:ln/>
-        </p:spPr>
-        <p:txBody>
-          <a:bodyPr wrap="square" lIns="0" tIns="0" rIns="0" bIns="0" rtlCol="0" anchor="ctr"/>
-          <a:lstStyle/>
-          <a:p>
-            <a:pPr indent="0" marL="0">
-              <a:buNone/>
-            </a:pPr>
-            <a:r>
-              <a:rPr lang="en-US" sz="2700" b="1" dirty="0">
+            <a:off x="731520" y="1051560"/>
+            <a:ext cx="10332720" cy="1280160"/>
+          </a:xfrm>
+          <a:prstGeom prst="rect">
+            <a:avLst/>
+          </a:prstGeom>
+          <a:noFill/>
+          <a:ln/>
+        </p:spPr>
+        <p:txBody>
+          <a:bodyPr wrap="square" lIns="0" tIns="0" rIns="0" bIns="0" rtlCol="0" anchor="ctr"/>
+          <a:lstStyle/>
+          <a:p>
+            <a:pPr indent="0" marL="0">
+              <a:lnSpc>
+                <a:spcPct val="118000"/>
+              </a:lnSpc>
+              <a:buNone/>
+            </a:pPr>
+            <a:r>
+              <a:rPr lang="en-US" sz="2500" b="1" dirty="0">
+                <a:solidFill>
+                  <a:srgbClr val="0E7C74"/>
+                </a:solidFill>
+                <a:latin typeface="Malgun Gothic" pitchFamily="34" charset="0"/>
+                <a:ea typeface="Malgun Gothic" pitchFamily="34" charset="-122"/>
+                <a:cs typeface="Malgun Gothic" pitchFamily="34" charset="-120"/>
+              </a:rPr>
+              <a:t>주제 · 데이터 · DB 설계 · 데이터 입력</a:t>
+            </a:r>
+            <a:pPr indent="0" marL="0">
+              <a:lnSpc>
+                <a:spcPct val="118000"/>
+              </a:lnSpc>
+              <a:buNone/>
+            </a:pPr>
+            <a:r>
+              <a:rPr lang="en-US" sz="2500" b="1" dirty="0">
                 <a:solidFill>
                   <a:srgbClr val="17211F"/>
                 </a:solidFill>
@@ -7842,62 +7119,19 @@
                 <a:ea typeface="Malgun Gothic" pitchFamily="34" charset="-122"/>
                 <a:cs typeface="Malgun Gothic" pitchFamily="34" charset="-120"/>
               </a:rPr>
-              <a:t>연령과 체중이 미치는 영향</a:t>
-            </a:r>
-            <a:endParaRPr lang="en-US" sz="2700" dirty="0"/>
-          </a:p>
-        </p:txBody>
-      </p:sp>
-      <p:pic>
-        <p:nvPicPr>
-          <p:cNvPr id="4" name="Image 0" descr="/home/user/diabetes/fig_age_bmi.png">    </p:cNvPr>
-          <p:cNvPicPr>
-            <a:picLocks noChangeAspect="1"/>
-          </p:cNvPicPr>
-          <p:nvPr/>
-        </p:nvPicPr>
-        <p:blipFill>
-          <a:blip r:embed="rId1"/>
-          <a:stretch>
-            <a:fillRect/>
-          </a:stretch>
-        </p:blipFill>
-        <p:spPr>
-          <a:xfrm>
-            <a:off x="1051560" y="1828800"/>
-            <a:ext cx="10058400" cy="3895344"/>
-          </a:xfrm>
-          <a:prstGeom prst="rect">
-            <a:avLst/>
-          </a:prstGeom>
-        </p:spPr>
-      </p:pic>
-      <p:sp>
-        <p:nvSpPr>
-          <p:cNvPr id="5" name="Text 2"/>
-          <p:cNvSpPr txBox="1"/>
-          <p:nvPr/>
-        </p:nvSpPr>
-        <p:spPr>
-          <a:xfrm>
-            <a:off x="731520" y="5989320"/>
-            <a:ext cx="10698480" cy="365760"/>
-          </a:xfrm>
-          <a:prstGeom prst="rect">
-            <a:avLst/>
-          </a:prstGeom>
-          <a:noFill/>
-          <a:ln/>
-        </p:spPr>
-        <p:txBody>
-          <a:bodyPr wrap="square" lIns="0" tIns="0" rIns="0" bIns="0" rtlCol="0" anchor="ctr"/>
-          <a:lstStyle/>
-          <a:p>
-            <a:pPr indent="0" marL="0">
-              <a:buNone/>
-            </a:pPr>
-            <a:r>
-              <a:rPr lang="en-US" sz="1350" dirty="0">
+              <a:t>까지</a:t>
+            </a:r>
+            <a:endParaRPr lang="en-US" sz="2500" dirty="0"/>
+          </a:p>
+          <a:p>
+            <a:pPr indent="0" marL="0">
+              <a:lnSpc>
+                <a:spcPct val="118000"/>
+              </a:lnSpc>
+              <a:buNone/>
+            </a:pPr>
+            <a:r>
+              <a:rPr lang="en-US" sz="2500" b="1" dirty="0">
                 <a:solidFill>
                   <a:srgbClr val="17211F"/>
                 </a:solidFill>
@@ -7905,15 +7139,556 @@
                 <a:ea typeface="Malgun Gothic" pitchFamily="34" charset="-122"/>
                 <a:cs typeface="Malgun Gothic" pitchFamily="34" charset="-120"/>
               </a:rPr>
-              <a:t>나이가 많을수록, BMI가 높을수록 당뇨병 비율이 뚜렷하게 증가합니다.</a:t>
-            </a:r>
-            <a:endParaRPr lang="en-US" sz="1350" dirty="0"/>
-          </a:p>
-        </p:txBody>
-      </p:sp>
-      <p:sp>
-        <p:nvSpPr>
-          <p:cNvPr id="6" name="Text 3"/>
+              <a:t>1단계를 완료했습니다.</a:t>
+            </a:r>
+            <a:endParaRPr lang="en-US" sz="2500" dirty="0"/>
+          </a:p>
+        </p:txBody>
+      </p:sp>
+      <p:sp>
+        <p:nvSpPr>
+          <p:cNvPr id="4" name="Shape 2"/>
+          <p:cNvSpPr/>
+          <p:nvPr/>
+        </p:nvSpPr>
+        <p:spPr>
+          <a:xfrm>
+            <a:off x="731520" y="2788920"/>
+            <a:ext cx="10698480" cy="0"/>
+          </a:xfrm>
+          <a:prstGeom prst="line">
+            <a:avLst/>
+          </a:prstGeom>
+          <a:noFill/>
+          <a:ln w="12700">
+            <a:solidFill>
+              <a:srgbClr val="DBE4E1"/>
+            </a:solidFill>
+            <a:prstDash val="solid"/>
+          </a:ln>
+        </p:spPr>
+      </p:sp>
+      <p:sp>
+        <p:nvSpPr>
+          <p:cNvPr id="5" name="Text 3"/>
+          <p:cNvSpPr txBox="1"/>
+          <p:nvPr/>
+        </p:nvSpPr>
+        <p:spPr>
+          <a:xfrm>
+            <a:off x="731520" y="3017520"/>
+            <a:ext cx="4572000" cy="320040"/>
+          </a:xfrm>
+          <a:prstGeom prst="rect">
+            <a:avLst/>
+          </a:prstGeom>
+          <a:noFill/>
+          <a:ln/>
+        </p:spPr>
+        <p:txBody>
+          <a:bodyPr wrap="square" lIns="0" tIns="0" rIns="0" bIns="0" rtlCol="0" anchor="ctr"/>
+          <a:lstStyle/>
+          <a:p>
+            <a:pPr indent="0" marL="0">
+              <a:buNone/>
+            </a:pPr>
+            <a:r>
+              <a:rPr lang="en-US" sz="1200" b="1" spc="200" kern="0" dirty="0">
+                <a:solidFill>
+                  <a:srgbClr val="0E7C74"/>
+                </a:solidFill>
+                <a:latin typeface="Malgun Gothic" pitchFamily="34" charset="0"/>
+                <a:ea typeface="Malgun Gothic" pitchFamily="34" charset="-122"/>
+                <a:cs typeface="Malgun Gothic" pitchFamily="34" charset="-120"/>
+              </a:rPr>
+              <a:t>역할 분담</a:t>
+            </a:r>
+            <a:endParaRPr lang="en-US" sz="1200" dirty="0"/>
+          </a:p>
+        </p:txBody>
+      </p:sp>
+      <p:sp>
+        <p:nvSpPr>
+          <p:cNvPr id="6" name="Text 4"/>
+          <p:cNvSpPr txBox="1"/>
+          <p:nvPr/>
+        </p:nvSpPr>
+        <p:spPr>
+          <a:xfrm>
+            <a:off x="731520" y="3429000"/>
+            <a:ext cx="3840480" cy="457200"/>
+          </a:xfrm>
+          <a:prstGeom prst="rect">
+            <a:avLst/>
+          </a:prstGeom>
+          <a:noFill/>
+          <a:ln/>
+        </p:spPr>
+        <p:txBody>
+          <a:bodyPr wrap="square" lIns="0" tIns="0" rIns="0" bIns="0" rtlCol="0" anchor="ctr"/>
+          <a:lstStyle/>
+          <a:p>
+            <a:pPr indent="0" marL="0">
+              <a:buNone/>
+            </a:pPr>
+            <a:r>
+              <a:rPr lang="en-US" sz="1400" dirty="0">
+                <a:solidFill>
+                  <a:srgbClr val="17211F"/>
+                </a:solidFill>
+                <a:latin typeface="Malgun Gothic" pitchFamily="34" charset="0"/>
+                <a:ea typeface="Malgun Gothic" pitchFamily="34" charset="-122"/>
+                <a:cs typeface="Malgun Gothic" pitchFamily="34" charset="-120"/>
+              </a:rPr>
+              <a:t>주제·데이터</a:t>
+            </a:r>
+            <a:endParaRPr lang="en-US" sz="1400" dirty="0"/>
+          </a:p>
+        </p:txBody>
+      </p:sp>
+      <p:sp>
+        <p:nvSpPr>
+          <p:cNvPr id="7" name="Text 5"/>
+          <p:cNvSpPr txBox="1"/>
+          <p:nvPr/>
+        </p:nvSpPr>
+        <p:spPr>
+          <a:xfrm>
+            <a:off x="4572000" y="3429000"/>
+            <a:ext cx="1463040" cy="457200"/>
+          </a:xfrm>
+          <a:prstGeom prst="rect">
+            <a:avLst/>
+          </a:prstGeom>
+          <a:noFill/>
+          <a:ln/>
+        </p:spPr>
+        <p:txBody>
+          <a:bodyPr wrap="square" lIns="0" tIns="0" rIns="0" bIns="0" rtlCol="0" anchor="ctr"/>
+          <a:lstStyle/>
+          <a:p>
+            <a:pPr indent="0" marL="0">
+              <a:buNone/>
+            </a:pPr>
+            <a:r>
+              <a:rPr lang="en-US" sz="1400" b="1" dirty="0">
+                <a:solidFill>
+                  <a:srgbClr val="7C8A87"/>
+                </a:solidFill>
+                <a:latin typeface="Malgun Gothic" pitchFamily="34" charset="0"/>
+                <a:ea typeface="Malgun Gothic" pitchFamily="34" charset="-122"/>
+                <a:cs typeface="Malgun Gothic" pitchFamily="34" charset="-120"/>
+              </a:rPr>
+              <a:t>OOO</a:t>
+            </a:r>
+            <a:endParaRPr lang="en-US" sz="1400" dirty="0"/>
+          </a:p>
+        </p:txBody>
+      </p:sp>
+      <p:sp>
+        <p:nvSpPr>
+          <p:cNvPr id="8" name="Shape 6"/>
+          <p:cNvSpPr/>
+          <p:nvPr/>
+        </p:nvSpPr>
+        <p:spPr>
+          <a:xfrm>
+            <a:off x="731520" y="3931920"/>
+            <a:ext cx="5303520" cy="0"/>
+          </a:xfrm>
+          <a:prstGeom prst="line">
+            <a:avLst/>
+          </a:prstGeom>
+          <a:noFill/>
+          <a:ln w="12700">
+            <a:solidFill>
+              <a:srgbClr val="DBE4E1"/>
+            </a:solidFill>
+            <a:prstDash val="solid"/>
+          </a:ln>
+        </p:spPr>
+      </p:sp>
+      <p:sp>
+        <p:nvSpPr>
+          <p:cNvPr id="9" name="Text 7"/>
+          <p:cNvSpPr txBox="1"/>
+          <p:nvPr/>
+        </p:nvSpPr>
+        <p:spPr>
+          <a:xfrm>
+            <a:off x="731520" y="3995928"/>
+            <a:ext cx="3840480" cy="457200"/>
+          </a:xfrm>
+          <a:prstGeom prst="rect">
+            <a:avLst/>
+          </a:prstGeom>
+          <a:noFill/>
+          <a:ln/>
+        </p:spPr>
+        <p:txBody>
+          <a:bodyPr wrap="square" lIns="0" tIns="0" rIns="0" bIns="0" rtlCol="0" anchor="ctr"/>
+          <a:lstStyle/>
+          <a:p>
+            <a:pPr indent="0" marL="0">
+              <a:buNone/>
+            </a:pPr>
+            <a:r>
+              <a:rPr lang="en-US" sz="1400" dirty="0">
+                <a:solidFill>
+                  <a:srgbClr val="17211F"/>
+                </a:solidFill>
+                <a:latin typeface="Malgun Gothic" pitchFamily="34" charset="0"/>
+                <a:ea typeface="Malgun Gothic" pitchFamily="34" charset="-122"/>
+                <a:cs typeface="Malgun Gothic" pitchFamily="34" charset="-120"/>
+              </a:rPr>
+              <a:t>DB 설계·ER</a:t>
+            </a:r>
+            <a:endParaRPr lang="en-US" sz="1400" dirty="0"/>
+          </a:p>
+        </p:txBody>
+      </p:sp>
+      <p:sp>
+        <p:nvSpPr>
+          <p:cNvPr id="10" name="Text 8"/>
+          <p:cNvSpPr txBox="1"/>
+          <p:nvPr/>
+        </p:nvSpPr>
+        <p:spPr>
+          <a:xfrm>
+            <a:off x="4572000" y="3995928"/>
+            <a:ext cx="1463040" cy="457200"/>
+          </a:xfrm>
+          <a:prstGeom prst="rect">
+            <a:avLst/>
+          </a:prstGeom>
+          <a:noFill/>
+          <a:ln/>
+        </p:spPr>
+        <p:txBody>
+          <a:bodyPr wrap="square" lIns="0" tIns="0" rIns="0" bIns="0" rtlCol="0" anchor="ctr"/>
+          <a:lstStyle/>
+          <a:p>
+            <a:pPr indent="0" marL="0">
+              <a:buNone/>
+            </a:pPr>
+            <a:r>
+              <a:rPr lang="en-US" sz="1400" b="1" dirty="0">
+                <a:solidFill>
+                  <a:srgbClr val="7C8A87"/>
+                </a:solidFill>
+                <a:latin typeface="Malgun Gothic" pitchFamily="34" charset="0"/>
+                <a:ea typeface="Malgun Gothic" pitchFamily="34" charset="-122"/>
+                <a:cs typeface="Malgun Gothic" pitchFamily="34" charset="-120"/>
+              </a:rPr>
+              <a:t>OOO</a:t>
+            </a:r>
+            <a:endParaRPr lang="en-US" sz="1400" dirty="0"/>
+          </a:p>
+        </p:txBody>
+      </p:sp>
+      <p:sp>
+        <p:nvSpPr>
+          <p:cNvPr id="11" name="Shape 9"/>
+          <p:cNvSpPr/>
+          <p:nvPr/>
+        </p:nvSpPr>
+        <p:spPr>
+          <a:xfrm>
+            <a:off x="731520" y="4498848"/>
+            <a:ext cx="5303520" cy="0"/>
+          </a:xfrm>
+          <a:prstGeom prst="line">
+            <a:avLst/>
+          </a:prstGeom>
+          <a:noFill/>
+          <a:ln w="12700">
+            <a:solidFill>
+              <a:srgbClr val="DBE4E1"/>
+            </a:solidFill>
+            <a:prstDash val="solid"/>
+          </a:ln>
+        </p:spPr>
+      </p:sp>
+      <p:sp>
+        <p:nvSpPr>
+          <p:cNvPr id="12" name="Text 10"/>
+          <p:cNvSpPr txBox="1"/>
+          <p:nvPr/>
+        </p:nvSpPr>
+        <p:spPr>
+          <a:xfrm>
+            <a:off x="731520" y="4562856"/>
+            <a:ext cx="3840480" cy="457200"/>
+          </a:xfrm>
+          <a:prstGeom prst="rect">
+            <a:avLst/>
+          </a:prstGeom>
+          <a:noFill/>
+          <a:ln/>
+        </p:spPr>
+        <p:txBody>
+          <a:bodyPr wrap="square" lIns="0" tIns="0" rIns="0" bIns="0" rtlCol="0" anchor="ctr"/>
+          <a:lstStyle/>
+          <a:p>
+            <a:pPr indent="0" marL="0">
+              <a:buNone/>
+            </a:pPr>
+            <a:r>
+              <a:rPr lang="en-US" sz="1400" dirty="0">
+                <a:solidFill>
+                  <a:srgbClr val="17211F"/>
+                </a:solidFill>
+                <a:latin typeface="Malgun Gothic" pitchFamily="34" charset="0"/>
+                <a:ea typeface="Malgun Gothic" pitchFamily="34" charset="-122"/>
+                <a:cs typeface="Malgun Gothic" pitchFamily="34" charset="-120"/>
+              </a:rPr>
+              <a:t>DB 구현·입력</a:t>
+            </a:r>
+            <a:endParaRPr lang="en-US" sz="1400" dirty="0"/>
+          </a:p>
+        </p:txBody>
+      </p:sp>
+      <p:sp>
+        <p:nvSpPr>
+          <p:cNvPr id="13" name="Text 11"/>
+          <p:cNvSpPr txBox="1"/>
+          <p:nvPr/>
+        </p:nvSpPr>
+        <p:spPr>
+          <a:xfrm>
+            <a:off x="4572000" y="4562856"/>
+            <a:ext cx="1463040" cy="457200"/>
+          </a:xfrm>
+          <a:prstGeom prst="rect">
+            <a:avLst/>
+          </a:prstGeom>
+          <a:noFill/>
+          <a:ln/>
+        </p:spPr>
+        <p:txBody>
+          <a:bodyPr wrap="square" lIns="0" tIns="0" rIns="0" bIns="0" rtlCol="0" anchor="ctr"/>
+          <a:lstStyle/>
+          <a:p>
+            <a:pPr indent="0" marL="0">
+              <a:buNone/>
+            </a:pPr>
+            <a:r>
+              <a:rPr lang="en-US" sz="1400" b="1" dirty="0">
+                <a:solidFill>
+                  <a:srgbClr val="7C8A87"/>
+                </a:solidFill>
+                <a:latin typeface="Malgun Gothic" pitchFamily="34" charset="0"/>
+                <a:ea typeface="Malgun Gothic" pitchFamily="34" charset="-122"/>
+                <a:cs typeface="Malgun Gothic" pitchFamily="34" charset="-120"/>
+              </a:rPr>
+              <a:t>OOO</a:t>
+            </a:r>
+            <a:endParaRPr lang="en-US" sz="1400" dirty="0"/>
+          </a:p>
+        </p:txBody>
+      </p:sp>
+      <p:sp>
+        <p:nvSpPr>
+          <p:cNvPr id="14" name="Shape 12"/>
+          <p:cNvSpPr/>
+          <p:nvPr/>
+        </p:nvSpPr>
+        <p:spPr>
+          <a:xfrm>
+            <a:off x="731520" y="5065776"/>
+            <a:ext cx="5303520" cy="0"/>
+          </a:xfrm>
+          <a:prstGeom prst="line">
+            <a:avLst/>
+          </a:prstGeom>
+          <a:noFill/>
+          <a:ln w="12700">
+            <a:solidFill>
+              <a:srgbClr val="DBE4E1"/>
+            </a:solidFill>
+            <a:prstDash val="solid"/>
+          </a:ln>
+        </p:spPr>
+      </p:sp>
+      <p:sp>
+        <p:nvSpPr>
+          <p:cNvPr id="15" name="Text 13"/>
+          <p:cNvSpPr txBox="1"/>
+          <p:nvPr/>
+        </p:nvSpPr>
+        <p:spPr>
+          <a:xfrm>
+            <a:off x="731520" y="5129784"/>
+            <a:ext cx="3840480" cy="457200"/>
+          </a:xfrm>
+          <a:prstGeom prst="rect">
+            <a:avLst/>
+          </a:prstGeom>
+          <a:noFill/>
+          <a:ln/>
+        </p:spPr>
+        <p:txBody>
+          <a:bodyPr wrap="square" lIns="0" tIns="0" rIns="0" bIns="0" rtlCol="0" anchor="ctr"/>
+          <a:lstStyle/>
+          <a:p>
+            <a:pPr indent="0" marL="0">
+              <a:buNone/>
+            </a:pPr>
+            <a:r>
+              <a:rPr lang="en-US" sz="1400" dirty="0">
+                <a:solidFill>
+                  <a:srgbClr val="17211F"/>
+                </a:solidFill>
+                <a:latin typeface="Malgun Gothic" pitchFamily="34" charset="0"/>
+                <a:ea typeface="Malgun Gothic" pitchFamily="34" charset="-122"/>
+                <a:cs typeface="Malgun Gothic" pitchFamily="34" charset="-120"/>
+              </a:rPr>
+              <a:t>SQL 분석·발표</a:t>
+            </a:r>
+            <a:endParaRPr lang="en-US" sz="1400" dirty="0"/>
+          </a:p>
+        </p:txBody>
+      </p:sp>
+      <p:sp>
+        <p:nvSpPr>
+          <p:cNvPr id="16" name="Text 14"/>
+          <p:cNvSpPr txBox="1"/>
+          <p:nvPr/>
+        </p:nvSpPr>
+        <p:spPr>
+          <a:xfrm>
+            <a:off x="4572000" y="5129784"/>
+            <a:ext cx="1463040" cy="457200"/>
+          </a:xfrm>
+          <a:prstGeom prst="rect">
+            <a:avLst/>
+          </a:prstGeom>
+          <a:noFill/>
+          <a:ln/>
+        </p:spPr>
+        <p:txBody>
+          <a:bodyPr wrap="square" lIns="0" tIns="0" rIns="0" bIns="0" rtlCol="0" anchor="ctr"/>
+          <a:lstStyle/>
+          <a:p>
+            <a:pPr indent="0" marL="0">
+              <a:buNone/>
+            </a:pPr>
+            <a:r>
+              <a:rPr lang="en-US" sz="1400" b="1" dirty="0">
+                <a:solidFill>
+                  <a:srgbClr val="7C8A87"/>
+                </a:solidFill>
+                <a:latin typeface="Malgun Gothic" pitchFamily="34" charset="0"/>
+                <a:ea typeface="Malgun Gothic" pitchFamily="34" charset="-122"/>
+                <a:cs typeface="Malgun Gothic" pitchFamily="34" charset="-120"/>
+              </a:rPr>
+              <a:t>OOO</a:t>
+            </a:r>
+            <a:endParaRPr lang="en-US" sz="1400" dirty="0"/>
+          </a:p>
+        </p:txBody>
+      </p:sp>
+      <p:sp>
+        <p:nvSpPr>
+          <p:cNvPr id="17" name="Shape 15"/>
+          <p:cNvSpPr/>
+          <p:nvPr/>
+        </p:nvSpPr>
+        <p:spPr>
+          <a:xfrm>
+            <a:off x="6675120" y="3429000"/>
+            <a:ext cx="4754880" cy="2331720"/>
+          </a:xfrm>
+          <a:prstGeom prst="rect">
+            <a:avLst/>
+          </a:prstGeom>
+          <a:solidFill>
+            <a:srgbClr val="EDF1F0"/>
+          </a:solidFill>
+          <a:ln/>
+        </p:spPr>
+      </p:sp>
+      <p:sp>
+        <p:nvSpPr>
+          <p:cNvPr id="18" name="Text 16"/>
+          <p:cNvSpPr txBox="1"/>
+          <p:nvPr/>
+        </p:nvSpPr>
+        <p:spPr>
+          <a:xfrm>
+            <a:off x="6949440" y="3657600"/>
+            <a:ext cx="3657600" cy="320040"/>
+          </a:xfrm>
+          <a:prstGeom prst="rect">
+            <a:avLst/>
+          </a:prstGeom>
+          <a:noFill/>
+          <a:ln/>
+        </p:spPr>
+        <p:txBody>
+          <a:bodyPr wrap="square" lIns="0" tIns="0" rIns="0" bIns="0" rtlCol="0" anchor="ctr"/>
+          <a:lstStyle/>
+          <a:p>
+            <a:pPr indent="0" marL="0">
+              <a:buNone/>
+            </a:pPr>
+            <a:r>
+              <a:rPr lang="en-US" sz="1200" b="1" spc="200" kern="0" dirty="0">
+                <a:solidFill>
+                  <a:srgbClr val="0E7C74"/>
+                </a:solidFill>
+                <a:latin typeface="Malgun Gothic" pitchFamily="34" charset="0"/>
+                <a:ea typeface="Malgun Gothic" pitchFamily="34" charset="-122"/>
+                <a:cs typeface="Malgun Gothic" pitchFamily="34" charset="-120"/>
+              </a:rPr>
+              <a:t>조원 소감</a:t>
+            </a:r>
+            <a:endParaRPr lang="en-US" sz="1200" dirty="0"/>
+          </a:p>
+        </p:txBody>
+      </p:sp>
+      <p:sp>
+        <p:nvSpPr>
+          <p:cNvPr id="19" name="Text 17"/>
+          <p:cNvSpPr txBox="1"/>
+          <p:nvPr/>
+        </p:nvSpPr>
+        <p:spPr>
+          <a:xfrm>
+            <a:off x="6949440" y="4069080"/>
+            <a:ext cx="4206240" cy="457200"/>
+          </a:xfrm>
+          <a:prstGeom prst="rect">
+            <a:avLst/>
+          </a:prstGeom>
+          <a:noFill/>
+          <a:ln/>
+        </p:spPr>
+        <p:txBody>
+          <a:bodyPr wrap="square" lIns="0" tIns="0" rIns="0" bIns="0" rtlCol="0" anchor="ctr"/>
+          <a:lstStyle/>
+          <a:p>
+            <a:pPr indent="0" marL="0">
+              <a:buNone/>
+            </a:pPr>
+            <a:r>
+              <a:rPr lang="en-US" sz="1300" dirty="0">
+                <a:solidFill>
+                  <a:srgbClr val="7C8A87"/>
+                </a:solidFill>
+                <a:latin typeface="Malgun Gothic" pitchFamily="34" charset="0"/>
+                <a:ea typeface="Malgun Gothic" pitchFamily="34" charset="-122"/>
+                <a:cs typeface="Malgun Gothic" pitchFamily="34" charset="-120"/>
+              </a:rPr>
+              <a:t>조원별로 한 줄씩 소감을 작성해 주세요.</a:t>
+            </a:r>
+            <a:endParaRPr lang="en-US" sz="1300" dirty="0"/>
+          </a:p>
+        </p:txBody>
+      </p:sp>
+      <p:sp>
+        <p:nvSpPr>
+          <p:cNvPr id="20" name="Text 18"/>
           <p:cNvSpPr txBox="1"/>
           <p:nvPr/>
         </p:nvSpPr>
@@ -7944,7 +7719,7 @@
                 <a:ea typeface="Malgun Gothic" pitchFamily="34" charset="-122"/>
                 <a:cs typeface="Malgun Gothic" pitchFamily="34" charset="-120"/>
               </a:rPr>
-              <a:t>09  /  11</a:t>
+              <a:t>09  /  09</a:t>
             </a:r>
             <a:endParaRPr lang="en-US" sz="900" dirty="0"/>
           </a:p>

</xml_diff>

<commit_message>
Add SQL Developer evidence slide (DDL success + SELECT result)
New slide 8 shows real screenshots of table/sequence creation and a SELECT
result as proof of DB implementation and data verification. Deck now 10 slides.

Co-Authored-By: Claude Opus 4.8 <noreply@anthropic.com>
Claude-Session: https://claude.ai/code/session_01A4Eo5QUsuZLdygCXtGqGtG
</commit_message>
<xml_diff>
--- a/diabetes_project_stage1.pptx
+++ b/diabetes_project_stage1.pptx
@@ -14,9 +14,10 @@
     <p:sldId id="262" r:id="rId8"/>
     <p:sldId id="263" r:id="rId9"/>
     <p:sldId id="264" r:id="rId10"/>
+    <p:sldId id="265" r:id="rId11"/>
   </p:sldIdLst>
   <p:notesMasterIdLst>
-    <p:notesMasterId r:id="rId11"/>
+    <p:notesMasterId r:id="rId12"/>
   </p:notesMasterIdLst>
   <p:sldSz cx="12161520" cy="6858000"/>
   <p:notesSz cx="6858000" cy="12161520"/>
@@ -534,6 +535,94 @@
             <a:fld id="{F7021451-1387-4CA6-816F-3879F97B5CBC}" type="slidenum">
               <a:rPr lang="en-US"/>
               <a:t>1</a:t>
+            </a:fld>
+            <a:endParaRPr lang="en-US"/>
+          </a:p>
+        </p:txBody>
+      </p:sp>
+    </p:spTree>
+    <p:extLst>
+      <p:ext uri="{BB962C8B-B14F-4D97-AF65-F5344CB8AC3E}">
+        <p14:creationId xmlns:p14="http://schemas.microsoft.com/office/powerpoint/2010/main" val="1024086991"/>
+      </p:ext>
+    </p:extLst>
+  </p:cSld>
+  <p:clrMapOvr>
+    <a:masterClrMapping/>
+  </p:clrMapOvr>
+</p:notes>
+</file>
+
+<file path=ppt/notesSlides/notesSlide10.xml><?xml version="1.0" encoding="utf-8"?>
+<p:notes xmlns:a="http://schemas.openxmlformats.org/drawingml/2006/main" xmlns:r="http://schemas.openxmlformats.org/officeDocument/2006/relationships" xmlns:p="http://schemas.openxmlformats.org/presentationml/2006/main">
+  <p:cSld>
+    <p:spTree>
+      <p:nvGrpSpPr>
+        <p:cNvPr id="1" name=""/>
+        <p:cNvGrpSpPr/>
+        <p:nvPr/>
+      </p:nvGrpSpPr>
+      <p:grpSpPr>
+        <a:xfrm>
+          <a:off x="0" y="0"/>
+          <a:ext cx="0" cy="0"/>
+          <a:chOff x="0" y="0"/>
+          <a:chExt cx="0" cy="0"/>
+        </a:xfrm>
+      </p:grpSpPr>
+      <p:sp>
+        <p:nvSpPr>
+          <p:cNvPr id="2" name="Slide Image Placeholder 1"/>
+          <p:cNvSpPr>
+            <a:spLocks noGrp="1" noRot="1" noChangeAspect="1"/>
+          </p:cNvSpPr>
+          <p:nvPr>
+            <p:ph type="sldImg"/>
+          </p:nvPr>
+        </p:nvSpPr>
+        <p:spPr/>
+      </p:sp>
+      <p:sp>
+        <p:nvSpPr>
+          <p:cNvPr id="3" name="Notes Placeholder 2"/>
+          <p:cNvSpPr>
+            <a:spLocks noGrp="1"/>
+          </p:cNvSpPr>
+          <p:nvPr>
+            <p:ph type="body" idx="1"/>
+          </p:nvPr>
+        </p:nvSpPr>
+        <p:spPr/>
+        <p:txBody>
+          <a:bodyPr/>
+          <a:lstStyle/>
+          <a:p>
+            <a:r>
+              <a:rPr lang="en-US" dirty="0"/>
+              <a:t/>
+            </a:r>
+            <a:endParaRPr lang="en-US" dirty="0"/>
+          </a:p>
+        </p:txBody>
+      </p:sp>
+      <p:sp>
+        <p:nvSpPr>
+          <p:cNvPr id="4" name="Slide Number Placeholder 3"/>
+          <p:cNvSpPr>
+            <a:spLocks noGrp="1"/>
+          </p:cNvSpPr>
+          <p:nvPr>
+            <p:ph type="sldNum" sz="quarter" idx="10"/>
+          </p:nvPr>
+        </p:nvSpPr>
+        <p:spPr/>
+        <p:txBody>
+          <a:bodyPr/>
+          <a:lstStyle/>
+          <a:p>
+            <a:fld id="{F7021451-1387-4CA6-816F-3879F97B5CBC}" type="slidenum">
+              <a:rPr lang="en-US"/>
+              <a:t>10</a:t>
             </a:fld>
             <a:endParaRPr lang="en-US"/>
           </a:p>
@@ -1827,6 +1916,736 @@
 </p:sld>
 </file>
 
+<file path=ppt/slides/slide10.xml><?xml version="1.0" encoding="utf-8"?>
+<p:sld xmlns:a="http://schemas.openxmlformats.org/drawingml/2006/main" xmlns:r="http://schemas.openxmlformats.org/officeDocument/2006/relationships" xmlns:p="http://schemas.openxmlformats.org/presentationml/2006/main">
+  <p:cSld name="Slide 10">
+    <p:bg>
+      <p:bgPr>
+        <a:solidFill>
+          <a:srgbClr val="FFFFFF"/>
+        </a:solidFill>
+      </p:bgPr>
+    </p:bg>
+    <p:spTree>
+      <p:nvGrpSpPr>
+        <p:cNvPr id="1" name=""/>
+        <p:cNvGrpSpPr/>
+        <p:nvPr/>
+      </p:nvGrpSpPr>
+      <p:grpSpPr>
+        <a:xfrm>
+          <a:off x="0" y="0"/>
+          <a:ext cx="0" cy="0"/>
+          <a:chOff x="0" y="0"/>
+          <a:chExt cx="0" cy="0"/>
+        </a:xfrm>
+      </p:grpSpPr>
+      <p:sp>
+        <p:nvSpPr>
+          <p:cNvPr id="2" name="Text 0"/>
+          <p:cNvSpPr txBox="1"/>
+          <p:nvPr/>
+        </p:nvSpPr>
+        <p:spPr>
+          <a:xfrm>
+            <a:off x="731520" y="566928"/>
+            <a:ext cx="10058400" cy="274320"/>
+          </a:xfrm>
+          <a:prstGeom prst="rect">
+            <a:avLst/>
+          </a:prstGeom>
+          <a:noFill/>
+          <a:ln/>
+        </p:spPr>
+        <p:txBody>
+          <a:bodyPr wrap="square" lIns="0" tIns="0" rIns="0" bIns="0" rtlCol="0" anchor="ctr"/>
+          <a:lstStyle/>
+          <a:p>
+            <a:pPr indent="0" marL="0">
+              <a:buNone/>
+            </a:pPr>
+            <a:r>
+              <a:rPr lang="en-US" sz="1100" b="1" spc="300" kern="0" dirty="0">
+                <a:solidFill>
+                  <a:srgbClr val="0E7C74"/>
+                </a:solidFill>
+                <a:latin typeface="Malgun Gothic" pitchFamily="34" charset="0"/>
+                <a:ea typeface="Malgun Gothic" pitchFamily="34" charset="-122"/>
+                <a:cs typeface="Malgun Gothic" pitchFamily="34" charset="-120"/>
+              </a:rPr>
+              <a:t>1단계 마무리</a:t>
+            </a:r>
+            <a:endParaRPr lang="en-US" sz="1100" dirty="0"/>
+          </a:p>
+        </p:txBody>
+      </p:sp>
+      <p:sp>
+        <p:nvSpPr>
+          <p:cNvPr id="3" name="Text 1"/>
+          <p:cNvSpPr txBox="1"/>
+          <p:nvPr/>
+        </p:nvSpPr>
+        <p:spPr>
+          <a:xfrm>
+            <a:off x="731520" y="1051560"/>
+            <a:ext cx="10332720" cy="1280160"/>
+          </a:xfrm>
+          <a:prstGeom prst="rect">
+            <a:avLst/>
+          </a:prstGeom>
+          <a:noFill/>
+          <a:ln/>
+        </p:spPr>
+        <p:txBody>
+          <a:bodyPr wrap="square" lIns="0" tIns="0" rIns="0" bIns="0" rtlCol="0" anchor="ctr"/>
+          <a:lstStyle/>
+          <a:p>
+            <a:pPr indent="0" marL="0">
+              <a:lnSpc>
+                <a:spcPct val="118000"/>
+              </a:lnSpc>
+              <a:buNone/>
+            </a:pPr>
+            <a:r>
+              <a:rPr lang="en-US" sz="2500" b="1" dirty="0">
+                <a:solidFill>
+                  <a:srgbClr val="0E7C74"/>
+                </a:solidFill>
+                <a:latin typeface="Malgun Gothic" pitchFamily="34" charset="0"/>
+                <a:ea typeface="Malgun Gothic" pitchFamily="34" charset="-122"/>
+                <a:cs typeface="Malgun Gothic" pitchFamily="34" charset="-120"/>
+              </a:rPr>
+              <a:t>주제 · 데이터 · DB 설계 · 데이터 입력</a:t>
+            </a:r>
+            <a:pPr indent="0" marL="0">
+              <a:lnSpc>
+                <a:spcPct val="118000"/>
+              </a:lnSpc>
+              <a:buNone/>
+            </a:pPr>
+            <a:r>
+              <a:rPr lang="en-US" sz="2500" b="1" dirty="0">
+                <a:solidFill>
+                  <a:srgbClr val="17211F"/>
+                </a:solidFill>
+                <a:latin typeface="Malgun Gothic" pitchFamily="34" charset="0"/>
+                <a:ea typeface="Malgun Gothic" pitchFamily="34" charset="-122"/>
+                <a:cs typeface="Malgun Gothic" pitchFamily="34" charset="-120"/>
+              </a:rPr>
+              <a:t>까지</a:t>
+            </a:r>
+            <a:endParaRPr lang="en-US" sz="2500" dirty="0"/>
+          </a:p>
+          <a:p>
+            <a:pPr indent="0" marL="0">
+              <a:lnSpc>
+                <a:spcPct val="118000"/>
+              </a:lnSpc>
+              <a:buNone/>
+            </a:pPr>
+            <a:r>
+              <a:rPr lang="en-US" sz="2500" b="1" dirty="0">
+                <a:solidFill>
+                  <a:srgbClr val="17211F"/>
+                </a:solidFill>
+                <a:latin typeface="Malgun Gothic" pitchFamily="34" charset="0"/>
+                <a:ea typeface="Malgun Gothic" pitchFamily="34" charset="-122"/>
+                <a:cs typeface="Malgun Gothic" pitchFamily="34" charset="-120"/>
+              </a:rPr>
+              <a:t>1단계를 완료했습니다.</a:t>
+            </a:r>
+            <a:endParaRPr lang="en-US" sz="2500" dirty="0"/>
+          </a:p>
+        </p:txBody>
+      </p:sp>
+      <p:sp>
+        <p:nvSpPr>
+          <p:cNvPr id="4" name="Shape 2"/>
+          <p:cNvSpPr/>
+          <p:nvPr/>
+        </p:nvSpPr>
+        <p:spPr>
+          <a:xfrm>
+            <a:off x="731520" y="2788920"/>
+            <a:ext cx="10698480" cy="0"/>
+          </a:xfrm>
+          <a:prstGeom prst="line">
+            <a:avLst/>
+          </a:prstGeom>
+          <a:noFill/>
+          <a:ln w="12700">
+            <a:solidFill>
+              <a:srgbClr val="DBE4E1"/>
+            </a:solidFill>
+            <a:prstDash val="solid"/>
+          </a:ln>
+        </p:spPr>
+      </p:sp>
+      <p:sp>
+        <p:nvSpPr>
+          <p:cNvPr id="5" name="Text 3"/>
+          <p:cNvSpPr txBox="1"/>
+          <p:nvPr/>
+        </p:nvSpPr>
+        <p:spPr>
+          <a:xfrm>
+            <a:off x="731520" y="3017520"/>
+            <a:ext cx="4572000" cy="320040"/>
+          </a:xfrm>
+          <a:prstGeom prst="rect">
+            <a:avLst/>
+          </a:prstGeom>
+          <a:noFill/>
+          <a:ln/>
+        </p:spPr>
+        <p:txBody>
+          <a:bodyPr wrap="square" lIns="0" tIns="0" rIns="0" bIns="0" rtlCol="0" anchor="ctr"/>
+          <a:lstStyle/>
+          <a:p>
+            <a:pPr indent="0" marL="0">
+              <a:buNone/>
+            </a:pPr>
+            <a:r>
+              <a:rPr lang="en-US" sz="1200" b="1" spc="200" kern="0" dirty="0">
+                <a:solidFill>
+                  <a:srgbClr val="0E7C74"/>
+                </a:solidFill>
+                <a:latin typeface="Malgun Gothic" pitchFamily="34" charset="0"/>
+                <a:ea typeface="Malgun Gothic" pitchFamily="34" charset="-122"/>
+                <a:cs typeface="Malgun Gothic" pitchFamily="34" charset="-120"/>
+              </a:rPr>
+              <a:t>역할 분담</a:t>
+            </a:r>
+            <a:endParaRPr lang="en-US" sz="1200" dirty="0"/>
+          </a:p>
+        </p:txBody>
+      </p:sp>
+      <p:sp>
+        <p:nvSpPr>
+          <p:cNvPr id="6" name="Text 4"/>
+          <p:cNvSpPr txBox="1"/>
+          <p:nvPr/>
+        </p:nvSpPr>
+        <p:spPr>
+          <a:xfrm>
+            <a:off x="731520" y="3429000"/>
+            <a:ext cx="3840480" cy="457200"/>
+          </a:xfrm>
+          <a:prstGeom prst="rect">
+            <a:avLst/>
+          </a:prstGeom>
+          <a:noFill/>
+          <a:ln/>
+        </p:spPr>
+        <p:txBody>
+          <a:bodyPr wrap="square" lIns="0" tIns="0" rIns="0" bIns="0" rtlCol="0" anchor="ctr"/>
+          <a:lstStyle/>
+          <a:p>
+            <a:pPr indent="0" marL="0">
+              <a:buNone/>
+            </a:pPr>
+            <a:r>
+              <a:rPr lang="en-US" sz="1400" dirty="0">
+                <a:solidFill>
+                  <a:srgbClr val="17211F"/>
+                </a:solidFill>
+                <a:latin typeface="Malgun Gothic" pitchFamily="34" charset="0"/>
+                <a:ea typeface="Malgun Gothic" pitchFamily="34" charset="-122"/>
+                <a:cs typeface="Malgun Gothic" pitchFamily="34" charset="-120"/>
+              </a:rPr>
+              <a:t>주제·데이터</a:t>
+            </a:r>
+            <a:endParaRPr lang="en-US" sz="1400" dirty="0"/>
+          </a:p>
+        </p:txBody>
+      </p:sp>
+      <p:sp>
+        <p:nvSpPr>
+          <p:cNvPr id="7" name="Text 5"/>
+          <p:cNvSpPr txBox="1"/>
+          <p:nvPr/>
+        </p:nvSpPr>
+        <p:spPr>
+          <a:xfrm>
+            <a:off x="4572000" y="3429000"/>
+            <a:ext cx="1463040" cy="457200"/>
+          </a:xfrm>
+          <a:prstGeom prst="rect">
+            <a:avLst/>
+          </a:prstGeom>
+          <a:noFill/>
+          <a:ln/>
+        </p:spPr>
+        <p:txBody>
+          <a:bodyPr wrap="square" lIns="0" tIns="0" rIns="0" bIns="0" rtlCol="0" anchor="ctr"/>
+          <a:lstStyle/>
+          <a:p>
+            <a:pPr indent="0" marL="0">
+              <a:buNone/>
+            </a:pPr>
+            <a:r>
+              <a:rPr lang="en-US" sz="1400" b="1" dirty="0">
+                <a:solidFill>
+                  <a:srgbClr val="7C8A87"/>
+                </a:solidFill>
+                <a:latin typeface="Malgun Gothic" pitchFamily="34" charset="0"/>
+                <a:ea typeface="Malgun Gothic" pitchFamily="34" charset="-122"/>
+                <a:cs typeface="Malgun Gothic" pitchFamily="34" charset="-120"/>
+              </a:rPr>
+              <a:t>OOO</a:t>
+            </a:r>
+            <a:endParaRPr lang="en-US" sz="1400" dirty="0"/>
+          </a:p>
+        </p:txBody>
+      </p:sp>
+      <p:sp>
+        <p:nvSpPr>
+          <p:cNvPr id="8" name="Shape 6"/>
+          <p:cNvSpPr/>
+          <p:nvPr/>
+        </p:nvSpPr>
+        <p:spPr>
+          <a:xfrm>
+            <a:off x="731520" y="3931920"/>
+            <a:ext cx="5303520" cy="0"/>
+          </a:xfrm>
+          <a:prstGeom prst="line">
+            <a:avLst/>
+          </a:prstGeom>
+          <a:noFill/>
+          <a:ln w="12700">
+            <a:solidFill>
+              <a:srgbClr val="DBE4E1"/>
+            </a:solidFill>
+            <a:prstDash val="solid"/>
+          </a:ln>
+        </p:spPr>
+      </p:sp>
+      <p:sp>
+        <p:nvSpPr>
+          <p:cNvPr id="9" name="Text 7"/>
+          <p:cNvSpPr txBox="1"/>
+          <p:nvPr/>
+        </p:nvSpPr>
+        <p:spPr>
+          <a:xfrm>
+            <a:off x="731520" y="3995928"/>
+            <a:ext cx="3840480" cy="457200"/>
+          </a:xfrm>
+          <a:prstGeom prst="rect">
+            <a:avLst/>
+          </a:prstGeom>
+          <a:noFill/>
+          <a:ln/>
+        </p:spPr>
+        <p:txBody>
+          <a:bodyPr wrap="square" lIns="0" tIns="0" rIns="0" bIns="0" rtlCol="0" anchor="ctr"/>
+          <a:lstStyle/>
+          <a:p>
+            <a:pPr indent="0" marL="0">
+              <a:buNone/>
+            </a:pPr>
+            <a:r>
+              <a:rPr lang="en-US" sz="1400" dirty="0">
+                <a:solidFill>
+                  <a:srgbClr val="17211F"/>
+                </a:solidFill>
+                <a:latin typeface="Malgun Gothic" pitchFamily="34" charset="0"/>
+                <a:ea typeface="Malgun Gothic" pitchFamily="34" charset="-122"/>
+                <a:cs typeface="Malgun Gothic" pitchFamily="34" charset="-120"/>
+              </a:rPr>
+              <a:t>DB 설계·ER</a:t>
+            </a:r>
+            <a:endParaRPr lang="en-US" sz="1400" dirty="0"/>
+          </a:p>
+        </p:txBody>
+      </p:sp>
+      <p:sp>
+        <p:nvSpPr>
+          <p:cNvPr id="10" name="Text 8"/>
+          <p:cNvSpPr txBox="1"/>
+          <p:nvPr/>
+        </p:nvSpPr>
+        <p:spPr>
+          <a:xfrm>
+            <a:off x="4572000" y="3995928"/>
+            <a:ext cx="1463040" cy="457200"/>
+          </a:xfrm>
+          <a:prstGeom prst="rect">
+            <a:avLst/>
+          </a:prstGeom>
+          <a:noFill/>
+          <a:ln/>
+        </p:spPr>
+        <p:txBody>
+          <a:bodyPr wrap="square" lIns="0" tIns="0" rIns="0" bIns="0" rtlCol="0" anchor="ctr"/>
+          <a:lstStyle/>
+          <a:p>
+            <a:pPr indent="0" marL="0">
+              <a:buNone/>
+            </a:pPr>
+            <a:r>
+              <a:rPr lang="en-US" sz="1400" b="1" dirty="0">
+                <a:solidFill>
+                  <a:srgbClr val="7C8A87"/>
+                </a:solidFill>
+                <a:latin typeface="Malgun Gothic" pitchFamily="34" charset="0"/>
+                <a:ea typeface="Malgun Gothic" pitchFamily="34" charset="-122"/>
+                <a:cs typeface="Malgun Gothic" pitchFamily="34" charset="-120"/>
+              </a:rPr>
+              <a:t>OOO</a:t>
+            </a:r>
+            <a:endParaRPr lang="en-US" sz="1400" dirty="0"/>
+          </a:p>
+        </p:txBody>
+      </p:sp>
+      <p:sp>
+        <p:nvSpPr>
+          <p:cNvPr id="11" name="Shape 9"/>
+          <p:cNvSpPr/>
+          <p:nvPr/>
+        </p:nvSpPr>
+        <p:spPr>
+          <a:xfrm>
+            <a:off x="731520" y="4498848"/>
+            <a:ext cx="5303520" cy="0"/>
+          </a:xfrm>
+          <a:prstGeom prst="line">
+            <a:avLst/>
+          </a:prstGeom>
+          <a:noFill/>
+          <a:ln w="12700">
+            <a:solidFill>
+              <a:srgbClr val="DBE4E1"/>
+            </a:solidFill>
+            <a:prstDash val="solid"/>
+          </a:ln>
+        </p:spPr>
+      </p:sp>
+      <p:sp>
+        <p:nvSpPr>
+          <p:cNvPr id="12" name="Text 10"/>
+          <p:cNvSpPr txBox="1"/>
+          <p:nvPr/>
+        </p:nvSpPr>
+        <p:spPr>
+          <a:xfrm>
+            <a:off x="731520" y="4562856"/>
+            <a:ext cx="3840480" cy="457200"/>
+          </a:xfrm>
+          <a:prstGeom prst="rect">
+            <a:avLst/>
+          </a:prstGeom>
+          <a:noFill/>
+          <a:ln/>
+        </p:spPr>
+        <p:txBody>
+          <a:bodyPr wrap="square" lIns="0" tIns="0" rIns="0" bIns="0" rtlCol="0" anchor="ctr"/>
+          <a:lstStyle/>
+          <a:p>
+            <a:pPr indent="0" marL="0">
+              <a:buNone/>
+            </a:pPr>
+            <a:r>
+              <a:rPr lang="en-US" sz="1400" dirty="0">
+                <a:solidFill>
+                  <a:srgbClr val="17211F"/>
+                </a:solidFill>
+                <a:latin typeface="Malgun Gothic" pitchFamily="34" charset="0"/>
+                <a:ea typeface="Malgun Gothic" pitchFamily="34" charset="-122"/>
+                <a:cs typeface="Malgun Gothic" pitchFamily="34" charset="-120"/>
+              </a:rPr>
+              <a:t>DB 구현·입력</a:t>
+            </a:r>
+            <a:endParaRPr lang="en-US" sz="1400" dirty="0"/>
+          </a:p>
+        </p:txBody>
+      </p:sp>
+      <p:sp>
+        <p:nvSpPr>
+          <p:cNvPr id="13" name="Text 11"/>
+          <p:cNvSpPr txBox="1"/>
+          <p:nvPr/>
+        </p:nvSpPr>
+        <p:spPr>
+          <a:xfrm>
+            <a:off x="4572000" y="4562856"/>
+            <a:ext cx="1463040" cy="457200"/>
+          </a:xfrm>
+          <a:prstGeom prst="rect">
+            <a:avLst/>
+          </a:prstGeom>
+          <a:noFill/>
+          <a:ln/>
+        </p:spPr>
+        <p:txBody>
+          <a:bodyPr wrap="square" lIns="0" tIns="0" rIns="0" bIns="0" rtlCol="0" anchor="ctr"/>
+          <a:lstStyle/>
+          <a:p>
+            <a:pPr indent="0" marL="0">
+              <a:buNone/>
+            </a:pPr>
+            <a:r>
+              <a:rPr lang="en-US" sz="1400" b="1" dirty="0">
+                <a:solidFill>
+                  <a:srgbClr val="7C8A87"/>
+                </a:solidFill>
+                <a:latin typeface="Malgun Gothic" pitchFamily="34" charset="0"/>
+                <a:ea typeface="Malgun Gothic" pitchFamily="34" charset="-122"/>
+                <a:cs typeface="Malgun Gothic" pitchFamily="34" charset="-120"/>
+              </a:rPr>
+              <a:t>OOO</a:t>
+            </a:r>
+            <a:endParaRPr lang="en-US" sz="1400" dirty="0"/>
+          </a:p>
+        </p:txBody>
+      </p:sp>
+      <p:sp>
+        <p:nvSpPr>
+          <p:cNvPr id="14" name="Shape 12"/>
+          <p:cNvSpPr/>
+          <p:nvPr/>
+        </p:nvSpPr>
+        <p:spPr>
+          <a:xfrm>
+            <a:off x="731520" y="5065776"/>
+            <a:ext cx="5303520" cy="0"/>
+          </a:xfrm>
+          <a:prstGeom prst="line">
+            <a:avLst/>
+          </a:prstGeom>
+          <a:noFill/>
+          <a:ln w="12700">
+            <a:solidFill>
+              <a:srgbClr val="DBE4E1"/>
+            </a:solidFill>
+            <a:prstDash val="solid"/>
+          </a:ln>
+        </p:spPr>
+      </p:sp>
+      <p:sp>
+        <p:nvSpPr>
+          <p:cNvPr id="15" name="Text 13"/>
+          <p:cNvSpPr txBox="1"/>
+          <p:nvPr/>
+        </p:nvSpPr>
+        <p:spPr>
+          <a:xfrm>
+            <a:off x="731520" y="5129784"/>
+            <a:ext cx="3840480" cy="457200"/>
+          </a:xfrm>
+          <a:prstGeom prst="rect">
+            <a:avLst/>
+          </a:prstGeom>
+          <a:noFill/>
+          <a:ln/>
+        </p:spPr>
+        <p:txBody>
+          <a:bodyPr wrap="square" lIns="0" tIns="0" rIns="0" bIns="0" rtlCol="0" anchor="ctr"/>
+          <a:lstStyle/>
+          <a:p>
+            <a:pPr indent="0" marL="0">
+              <a:buNone/>
+            </a:pPr>
+            <a:r>
+              <a:rPr lang="en-US" sz="1400" dirty="0">
+                <a:solidFill>
+                  <a:srgbClr val="17211F"/>
+                </a:solidFill>
+                <a:latin typeface="Malgun Gothic" pitchFamily="34" charset="0"/>
+                <a:ea typeface="Malgun Gothic" pitchFamily="34" charset="-122"/>
+                <a:cs typeface="Malgun Gothic" pitchFamily="34" charset="-120"/>
+              </a:rPr>
+              <a:t>SQL 분석·발표</a:t>
+            </a:r>
+            <a:endParaRPr lang="en-US" sz="1400" dirty="0"/>
+          </a:p>
+        </p:txBody>
+      </p:sp>
+      <p:sp>
+        <p:nvSpPr>
+          <p:cNvPr id="16" name="Text 14"/>
+          <p:cNvSpPr txBox="1"/>
+          <p:nvPr/>
+        </p:nvSpPr>
+        <p:spPr>
+          <a:xfrm>
+            <a:off x="4572000" y="5129784"/>
+            <a:ext cx="1463040" cy="457200"/>
+          </a:xfrm>
+          <a:prstGeom prst="rect">
+            <a:avLst/>
+          </a:prstGeom>
+          <a:noFill/>
+          <a:ln/>
+        </p:spPr>
+        <p:txBody>
+          <a:bodyPr wrap="square" lIns="0" tIns="0" rIns="0" bIns="0" rtlCol="0" anchor="ctr"/>
+          <a:lstStyle/>
+          <a:p>
+            <a:pPr indent="0" marL="0">
+              <a:buNone/>
+            </a:pPr>
+            <a:r>
+              <a:rPr lang="en-US" sz="1400" b="1" dirty="0">
+                <a:solidFill>
+                  <a:srgbClr val="7C8A87"/>
+                </a:solidFill>
+                <a:latin typeface="Malgun Gothic" pitchFamily="34" charset="0"/>
+                <a:ea typeface="Malgun Gothic" pitchFamily="34" charset="-122"/>
+                <a:cs typeface="Malgun Gothic" pitchFamily="34" charset="-120"/>
+              </a:rPr>
+              <a:t>OOO</a:t>
+            </a:r>
+            <a:endParaRPr lang="en-US" sz="1400" dirty="0"/>
+          </a:p>
+        </p:txBody>
+      </p:sp>
+      <p:sp>
+        <p:nvSpPr>
+          <p:cNvPr id="17" name="Shape 15"/>
+          <p:cNvSpPr/>
+          <p:nvPr/>
+        </p:nvSpPr>
+        <p:spPr>
+          <a:xfrm>
+            <a:off x="6675120" y="3429000"/>
+            <a:ext cx="4754880" cy="2331720"/>
+          </a:xfrm>
+          <a:prstGeom prst="rect">
+            <a:avLst/>
+          </a:prstGeom>
+          <a:solidFill>
+            <a:srgbClr val="EDF1F0"/>
+          </a:solidFill>
+          <a:ln/>
+        </p:spPr>
+      </p:sp>
+      <p:sp>
+        <p:nvSpPr>
+          <p:cNvPr id="18" name="Text 16"/>
+          <p:cNvSpPr txBox="1"/>
+          <p:nvPr/>
+        </p:nvSpPr>
+        <p:spPr>
+          <a:xfrm>
+            <a:off x="6949440" y="3657600"/>
+            <a:ext cx="3657600" cy="320040"/>
+          </a:xfrm>
+          <a:prstGeom prst="rect">
+            <a:avLst/>
+          </a:prstGeom>
+          <a:noFill/>
+          <a:ln/>
+        </p:spPr>
+        <p:txBody>
+          <a:bodyPr wrap="square" lIns="0" tIns="0" rIns="0" bIns="0" rtlCol="0" anchor="ctr"/>
+          <a:lstStyle/>
+          <a:p>
+            <a:pPr indent="0" marL="0">
+              <a:buNone/>
+            </a:pPr>
+            <a:r>
+              <a:rPr lang="en-US" sz="1200" b="1" spc="200" kern="0" dirty="0">
+                <a:solidFill>
+                  <a:srgbClr val="0E7C74"/>
+                </a:solidFill>
+                <a:latin typeface="Malgun Gothic" pitchFamily="34" charset="0"/>
+                <a:ea typeface="Malgun Gothic" pitchFamily="34" charset="-122"/>
+                <a:cs typeface="Malgun Gothic" pitchFamily="34" charset="-120"/>
+              </a:rPr>
+              <a:t>조원 소감</a:t>
+            </a:r>
+            <a:endParaRPr lang="en-US" sz="1200" dirty="0"/>
+          </a:p>
+        </p:txBody>
+      </p:sp>
+      <p:sp>
+        <p:nvSpPr>
+          <p:cNvPr id="19" name="Text 17"/>
+          <p:cNvSpPr txBox="1"/>
+          <p:nvPr/>
+        </p:nvSpPr>
+        <p:spPr>
+          <a:xfrm>
+            <a:off x="6949440" y="4069080"/>
+            <a:ext cx="4206240" cy="457200"/>
+          </a:xfrm>
+          <a:prstGeom prst="rect">
+            <a:avLst/>
+          </a:prstGeom>
+          <a:noFill/>
+          <a:ln/>
+        </p:spPr>
+        <p:txBody>
+          <a:bodyPr wrap="square" lIns="0" tIns="0" rIns="0" bIns="0" rtlCol="0" anchor="ctr"/>
+          <a:lstStyle/>
+          <a:p>
+            <a:pPr indent="0" marL="0">
+              <a:buNone/>
+            </a:pPr>
+            <a:r>
+              <a:rPr lang="en-US" sz="1300" dirty="0">
+                <a:solidFill>
+                  <a:srgbClr val="7C8A87"/>
+                </a:solidFill>
+                <a:latin typeface="Malgun Gothic" pitchFamily="34" charset="0"/>
+                <a:ea typeface="Malgun Gothic" pitchFamily="34" charset="-122"/>
+                <a:cs typeface="Malgun Gothic" pitchFamily="34" charset="-120"/>
+              </a:rPr>
+              <a:t>조원별로 한 줄씩 소감을 작성해 주세요.</a:t>
+            </a:r>
+            <a:endParaRPr lang="en-US" sz="1300" dirty="0"/>
+          </a:p>
+        </p:txBody>
+      </p:sp>
+      <p:sp>
+        <p:nvSpPr>
+          <p:cNvPr id="20" name="Text 18"/>
+          <p:cNvSpPr txBox="1"/>
+          <p:nvPr/>
+        </p:nvSpPr>
+        <p:spPr>
+          <a:xfrm>
+            <a:off x="10332720" y="6382512"/>
+            <a:ext cx="1371600" cy="274320"/>
+          </a:xfrm>
+          <a:prstGeom prst="rect">
+            <a:avLst/>
+          </a:prstGeom>
+          <a:noFill/>
+          <a:ln/>
+        </p:spPr>
+        <p:txBody>
+          <a:bodyPr wrap="square" lIns="0" tIns="0" rIns="0" bIns="0" rtlCol="0" anchor="ctr"/>
+          <a:lstStyle/>
+          <a:p>
+            <a:pPr algn="r" indent="0" marL="0">
+              <a:buNone/>
+            </a:pPr>
+            <a:r>
+              <a:rPr lang="en-US" sz="900" spc="100" kern="0" dirty="0">
+                <a:solidFill>
+                  <a:srgbClr val="7C8A87"/>
+                </a:solidFill>
+                <a:latin typeface="Malgun Gothic" pitchFamily="34" charset="0"/>
+                <a:ea typeface="Malgun Gothic" pitchFamily="34" charset="-122"/>
+                <a:cs typeface="Malgun Gothic" pitchFamily="34" charset="-120"/>
+              </a:rPr>
+              <a:t>10  /  10</a:t>
+            </a:r>
+            <a:endParaRPr lang="en-US" sz="900" dirty="0"/>
+          </a:p>
+        </p:txBody>
+      </p:sp>
+    </p:spTree>
+  </p:cSld>
+  <p:clrMapOvr>
+    <a:masterClrMapping/>
+  </p:clrMapOvr>
+</p:sld>
+</file>
+
 <file path=ppt/slides/slide2.xml><?xml version="1.0" encoding="utf-8"?>
 <p:sld xmlns:a="http://schemas.openxmlformats.org/drawingml/2006/main" xmlns:r="http://schemas.openxmlformats.org/officeDocument/2006/relationships" xmlns:p="http://schemas.openxmlformats.org/presentationml/2006/main">
   <p:cSld name="Slide 2">
@@ -2373,7 +3192,7 @@
                 <a:ea typeface="Malgun Gothic" pitchFamily="34" charset="-122"/>
                 <a:cs typeface="Malgun Gothic" pitchFamily="34" charset="-120"/>
               </a:rPr>
-              <a:t>02  /  09</a:t>
+              <a:t>02  /  10</a:t>
             </a:r>
             <a:endParaRPr lang="en-US" sz="900" dirty="0"/>
           </a:p>
@@ -2981,7 +3800,7 @@
                 <a:ea typeface="Malgun Gothic" pitchFamily="34" charset="-122"/>
                 <a:cs typeface="Malgun Gothic" pitchFamily="34" charset="-120"/>
               </a:rPr>
-              <a:t>03  /  09</a:t>
+              <a:t>03  /  10</a:t>
             </a:r>
             <a:endParaRPr lang="en-US" sz="900" dirty="0"/>
           </a:p>
@@ -3550,7 +4369,7 @@
                 <a:ea typeface="Malgun Gothic" pitchFamily="34" charset="-122"/>
                 <a:cs typeface="Malgun Gothic" pitchFamily="34" charset="-120"/>
               </a:rPr>
-              <a:t>04  /  09</a:t>
+              <a:t>04  /  10</a:t>
             </a:r>
             <a:endParaRPr lang="en-US" sz="900" dirty="0"/>
           </a:p>
@@ -4515,7 +5334,7 @@
                 <a:ea typeface="Malgun Gothic" pitchFamily="34" charset="-122"/>
                 <a:cs typeface="Malgun Gothic" pitchFamily="34" charset="-120"/>
               </a:rPr>
-              <a:t>05  /  09</a:t>
+              <a:t>05  /  10</a:t>
             </a:r>
             <a:endParaRPr lang="en-US" sz="900" dirty="0"/>
           </a:p>
@@ -5224,7 +6043,7 @@
                 <a:ea typeface="Malgun Gothic" pitchFamily="34" charset="-122"/>
                 <a:cs typeface="Malgun Gothic" pitchFamily="34" charset="-120"/>
               </a:rPr>
-              <a:t>06  /  09</a:t>
+              <a:t>06  /  10</a:t>
             </a:r>
             <a:endParaRPr lang="en-US" sz="900" dirty="0"/>
           </a:p>
@@ -6046,7 +6865,7 @@
                 <a:ea typeface="Malgun Gothic" pitchFamily="34" charset="-122"/>
                 <a:cs typeface="Malgun Gothic" pitchFamily="34" charset="-120"/>
               </a:rPr>
-              <a:t>07  /  09</a:t>
+              <a:t>07  /  10</a:t>
             </a:r>
             <a:endParaRPr lang="en-US" sz="900" dirty="0"/>
           </a:p>
@@ -6117,7 +6936,7 @@
                 <a:ea typeface="Malgun Gothic" pitchFamily="34" charset="-122"/>
                 <a:cs typeface="Malgun Gothic" pitchFamily="34" charset="-120"/>
               </a:rPr>
-              <a:t>분석 계획</a:t>
+              <a:t>실행 화면</a:t>
             </a:r>
             <a:endParaRPr lang="en-US" sz="1100" dirty="0"/>
           </a:p>
@@ -6156,7 +6975,7 @@
                 <a:ea typeface="Malgun Gothic" pitchFamily="34" charset="-122"/>
                 <a:cs typeface="Malgun Gothic" pitchFamily="34" charset="-120"/>
               </a:rPr>
-              <a:t>2단계에서 수행할 분석</a:t>
+              <a:t>SQL Developer 구현 증거</a:t>
             </a:r>
             <a:endParaRPr lang="en-US" sz="2700" dirty="0"/>
           </a:p>
@@ -6164,58 +6983,21 @@
       </p:sp>
       <p:sp>
         <p:nvSpPr>
-          <p:cNvPr id="4" name="Text 2"/>
-          <p:cNvSpPr txBox="1"/>
-          <p:nvPr/>
-        </p:nvSpPr>
-        <p:spPr>
-          <a:xfrm>
-            <a:off x="731520" y="1600200"/>
-            <a:ext cx="10332720" cy="457200"/>
-          </a:xfrm>
-          <a:prstGeom prst="rect">
-            <a:avLst/>
-          </a:prstGeom>
-          <a:noFill/>
-          <a:ln/>
-        </p:spPr>
-        <p:txBody>
-          <a:bodyPr wrap="square" lIns="0" tIns="0" rIns="0" bIns="0" rtlCol="0" anchor="ctr"/>
-          <a:lstStyle/>
-          <a:p>
-            <a:pPr indent="0" marL="0">
-              <a:buNone/>
-            </a:pPr>
-            <a:r>
-              <a:rPr lang="en-US" sz="1450" dirty="0">
-                <a:solidFill>
-                  <a:srgbClr val="7C8A87"/>
-                </a:solidFill>
-                <a:latin typeface="Malgun Gothic" pitchFamily="34" charset="0"/>
-                <a:ea typeface="Malgun Gothic" pitchFamily="34" charset="-122"/>
-                <a:cs typeface="Malgun Gothic" pitchFamily="34" charset="-120"/>
-              </a:rPr>
-              <a:t>정규화된 DB를 SQL로 질의해 위험요인을 규명하고, 그 결과를 ANALYSIS_RESULT 테이블에 저장합니다.</a:t>
-            </a:r>
-            <a:endParaRPr lang="en-US" sz="1450" dirty="0"/>
-          </a:p>
-        </p:txBody>
-      </p:sp>
-      <p:sp>
-        <p:nvSpPr>
-          <p:cNvPr id="5" name="Shape 3"/>
+          <p:cNvPr id="4" name="Shape 2"/>
           <p:cNvSpPr/>
           <p:nvPr/>
         </p:nvSpPr>
         <p:spPr>
           <a:xfrm>
-            <a:off x="731520" y="2286000"/>
-            <a:ext cx="10698480" cy="0"/>
-          </a:xfrm>
-          <a:prstGeom prst="line">
-            <a:avLst/>
-          </a:prstGeom>
-          <a:noFill/>
+            <a:off x="704088" y="1847088"/>
+            <a:ext cx="5724144" cy="3712464"/>
+          </a:xfrm>
+          <a:prstGeom prst="rect">
+            <a:avLst/>
+          </a:prstGeom>
+          <a:solidFill>
+            <a:srgbClr val="FFFFFF"/>
+          </a:solidFill>
           <a:ln w="12700">
             <a:solidFill>
               <a:srgbClr val="DBE4E1"/>
@@ -6224,110 +7006,70 @@
           </a:ln>
         </p:spPr>
       </p:sp>
-      <p:sp>
-        <p:nvSpPr>
-          <p:cNvPr id="6" name="Text 4"/>
-          <p:cNvSpPr txBox="1"/>
-          <p:nvPr/>
-        </p:nvSpPr>
-        <p:spPr>
-          <a:xfrm>
-            <a:off x="731520" y="2514600"/>
-            <a:ext cx="822960" cy="777240"/>
-          </a:xfrm>
-          <a:prstGeom prst="rect">
-            <a:avLst/>
-          </a:prstGeom>
-          <a:noFill/>
-          <a:ln/>
-        </p:spPr>
-        <p:txBody>
-          <a:bodyPr wrap="square" lIns="0" tIns="0" rIns="0" bIns="0" rtlCol="0" anchor="ctr"/>
-          <a:lstStyle/>
-          <a:p>
-            <a:pPr indent="0" marL="0">
-              <a:buNone/>
-            </a:pPr>
-            <a:r>
-              <a:rPr lang="en-US" sz="2400" b="1" dirty="0">
-                <a:solidFill>
-                  <a:srgbClr val="EDF1F0"/>
-                </a:solidFill>
-                <a:latin typeface="Malgun Gothic" pitchFamily="34" charset="0"/>
-                <a:ea typeface="Malgun Gothic" pitchFamily="34" charset="-122"/>
-                <a:cs typeface="Malgun Gothic" pitchFamily="34" charset="-120"/>
-              </a:rPr>
-              <a:t>01</a:t>
-            </a:r>
-            <a:endParaRPr lang="en-US" sz="2400" dirty="0"/>
-          </a:p>
-        </p:txBody>
-      </p:sp>
-      <p:sp>
-        <p:nvSpPr>
-          <p:cNvPr id="7" name="Text 5"/>
-          <p:cNvSpPr txBox="1"/>
-          <p:nvPr/>
-        </p:nvSpPr>
-        <p:spPr>
-          <a:xfrm>
-            <a:off x="1691640" y="2514600"/>
-            <a:ext cx="3291840" cy="777240"/>
-          </a:xfrm>
-          <a:prstGeom prst="rect">
-            <a:avLst/>
-          </a:prstGeom>
-          <a:noFill/>
-          <a:ln/>
-        </p:spPr>
-        <p:txBody>
-          <a:bodyPr wrap="square" lIns="0" tIns="0" rIns="0" bIns="0" rtlCol="0" anchor="ctr"/>
-          <a:lstStyle/>
-          <a:p>
-            <a:pPr indent="0" marL="0">
-              <a:buNone/>
-            </a:pPr>
-            <a:r>
-              <a:rPr lang="en-US" sz="1550" b="1" dirty="0">
-                <a:solidFill>
-                  <a:srgbClr val="17211F"/>
-                </a:solidFill>
-                <a:latin typeface="Malgun Gothic" pitchFamily="34" charset="0"/>
-                <a:ea typeface="Malgun Gothic" pitchFamily="34" charset="-122"/>
-                <a:cs typeface="Malgun Gothic" pitchFamily="34" charset="-120"/>
-              </a:rPr>
-              <a:t>기술 통계 분석</a:t>
-            </a:r>
-            <a:endParaRPr lang="en-US" sz="1550" dirty="0"/>
-          </a:p>
-        </p:txBody>
-      </p:sp>
-      <p:sp>
-        <p:nvSpPr>
-          <p:cNvPr id="8" name="Text 6"/>
-          <p:cNvSpPr txBox="1"/>
-          <p:nvPr/>
-        </p:nvSpPr>
-        <p:spPr>
-          <a:xfrm>
-            <a:off x="5074920" y="2514600"/>
-            <a:ext cx="4754880" cy="777240"/>
-          </a:xfrm>
-          <a:prstGeom prst="rect">
-            <a:avLst/>
-          </a:prstGeom>
-          <a:noFill/>
-          <a:ln/>
-        </p:spPr>
-        <p:txBody>
-          <a:bodyPr wrap="square" lIns="0" tIns="0" rIns="0" bIns="0" rtlCol="0" anchor="ctr"/>
-          <a:lstStyle/>
-          <a:p>
-            <a:pPr indent="0" marL="0">
-              <a:buNone/>
-            </a:pPr>
-            <a:r>
-              <a:rPr lang="en-US" sz="1300" dirty="0">
+      <p:pic>
+        <p:nvPicPr>
+          <p:cNvPr id="5" name="Image 0" descr="/home/user/diabetes/evidence_ddl.jpg">    </p:cNvPr>
+          <p:cNvPicPr>
+            <a:picLocks noChangeAspect="1"/>
+          </p:cNvPicPr>
+          <p:nvPr/>
+        </p:nvPicPr>
+        <p:blipFill>
+          <a:blip r:embed="rId1"/>
+          <a:stretch>
+            <a:fillRect/>
+          </a:stretch>
+        </p:blipFill>
+        <p:spPr>
+          <a:xfrm>
+            <a:off x="731520" y="1874520"/>
+            <a:ext cx="5669280" cy="3657600"/>
+          </a:xfrm>
+          <a:prstGeom prst="rect">
+            <a:avLst/>
+          </a:prstGeom>
+        </p:spPr>
+      </p:pic>
+      <p:sp>
+        <p:nvSpPr>
+          <p:cNvPr id="6" name="Text 3"/>
+          <p:cNvSpPr txBox="1"/>
+          <p:nvPr/>
+        </p:nvSpPr>
+        <p:spPr>
+          <a:xfrm>
+            <a:off x="731520" y="5669280"/>
+            <a:ext cx="5669280" cy="320040"/>
+          </a:xfrm>
+          <a:prstGeom prst="rect">
+            <a:avLst/>
+          </a:prstGeom>
+          <a:noFill/>
+          <a:ln/>
+        </p:spPr>
+        <p:txBody>
+          <a:bodyPr wrap="square" lIns="0" tIns="0" rIns="0" bIns="0" rtlCol="0" anchor="ctr"/>
+          <a:lstStyle/>
+          <a:p>
+            <a:pPr indent="0" marL="0">
+              <a:buNone/>
+            </a:pPr>
+            <a:r>
+              <a:rPr lang="en-US" sz="1200" b="1" dirty="0">
+                <a:solidFill>
+                  <a:srgbClr val="0E7C74"/>
+                </a:solidFill>
+                <a:latin typeface="Malgun Gothic" pitchFamily="34" charset="0"/>
+                <a:ea typeface="Malgun Gothic" pitchFamily="34" charset="-122"/>
+                <a:cs typeface="Malgun Gothic" pitchFamily="34" charset="-120"/>
+              </a:rPr>
+              <a:t>DDL 실행   </a:t>
+            </a:r>
+            <a:pPr indent="0" marL="0">
+              <a:buNone/>
+            </a:pPr>
+            <a:r>
+              <a:rPr lang="en-US" sz="1200" dirty="0">
                 <a:solidFill>
                   <a:srgbClr val="7C8A87"/>
                 </a:solidFill>
@@ -6335,66 +7077,29 @@
                 <a:ea typeface="Malgun Gothic" pitchFamily="34" charset="-122"/>
                 <a:cs typeface="Malgun Gothic" pitchFamily="34" charset="-120"/>
               </a:rPr>
-              <a:t>연령·성별·BMI·소득·학력별 당뇨병 비율</a:t>
-            </a:r>
-            <a:endParaRPr lang="en-US" sz="1300" dirty="0"/>
-          </a:p>
-        </p:txBody>
-      </p:sp>
-      <p:sp>
-        <p:nvSpPr>
-          <p:cNvPr id="9" name="Text 7"/>
-          <p:cNvSpPr txBox="1"/>
-          <p:nvPr/>
-        </p:nvSpPr>
-        <p:spPr>
-          <a:xfrm>
-            <a:off x="9875520" y="2514600"/>
-            <a:ext cx="1554480" cy="777240"/>
-          </a:xfrm>
-          <a:prstGeom prst="rect">
-            <a:avLst/>
-          </a:prstGeom>
-          <a:noFill/>
-          <a:ln/>
-        </p:spPr>
-        <p:txBody>
-          <a:bodyPr wrap="square" lIns="0" tIns="0" rIns="0" bIns="0" rtlCol="0" anchor="ctr"/>
-          <a:lstStyle/>
-          <a:p>
-            <a:pPr indent="0" marL="0">
-              <a:buNone/>
-            </a:pPr>
-            <a:r>
-              <a:rPr lang="en-US" sz="1050" dirty="0">
-                <a:solidFill>
-                  <a:srgbClr val="0E7C74"/>
-                </a:solidFill>
-                <a:latin typeface="Malgun Gothic" pitchFamily="34" charset="0"/>
-                <a:ea typeface="Malgun Gothic" pitchFamily="34" charset="-122"/>
-                <a:cs typeface="Malgun Gothic" pitchFamily="34" charset="-120"/>
-              </a:rPr>
-              <a:t>GROUP BY · CASE · AVG</a:t>
-            </a:r>
-            <a:endParaRPr lang="en-US" sz="1050" dirty="0"/>
-          </a:p>
-        </p:txBody>
-      </p:sp>
-      <p:sp>
-        <p:nvSpPr>
-          <p:cNvPr id="10" name="Shape 8"/>
+              <a:t>테이블·시퀀스 생성 완료</a:t>
+            </a:r>
+            <a:endParaRPr lang="en-US" sz="1200" dirty="0"/>
+          </a:p>
+        </p:txBody>
+      </p:sp>
+      <p:sp>
+        <p:nvSpPr>
+          <p:cNvPr id="7" name="Shape 4"/>
           <p:cNvSpPr/>
           <p:nvPr/>
         </p:nvSpPr>
         <p:spPr>
           <a:xfrm>
-            <a:off x="731520" y="3319272"/>
-            <a:ext cx="10698480" cy="0"/>
-          </a:xfrm>
-          <a:prstGeom prst="line">
-            <a:avLst/>
-          </a:prstGeom>
-          <a:noFill/>
+            <a:off x="6647688" y="1847088"/>
+            <a:ext cx="3712464" cy="3712464"/>
+          </a:xfrm>
+          <a:prstGeom prst="rect">
+            <a:avLst/>
+          </a:prstGeom>
+          <a:solidFill>
+            <a:srgbClr val="FFFFFF"/>
+          </a:solidFill>
           <a:ln w="12700">
             <a:solidFill>
               <a:srgbClr val="DBE4E1"/>
@@ -6403,110 +7108,70 @@
           </a:ln>
         </p:spPr>
       </p:sp>
-      <p:sp>
-        <p:nvSpPr>
-          <p:cNvPr id="11" name="Text 9"/>
-          <p:cNvSpPr txBox="1"/>
-          <p:nvPr/>
-        </p:nvSpPr>
-        <p:spPr>
-          <a:xfrm>
-            <a:off x="731520" y="3410712"/>
-            <a:ext cx="822960" cy="777240"/>
-          </a:xfrm>
-          <a:prstGeom prst="rect">
-            <a:avLst/>
-          </a:prstGeom>
-          <a:noFill/>
-          <a:ln/>
-        </p:spPr>
-        <p:txBody>
-          <a:bodyPr wrap="square" lIns="0" tIns="0" rIns="0" bIns="0" rtlCol="0" anchor="ctr"/>
-          <a:lstStyle/>
-          <a:p>
-            <a:pPr indent="0" marL="0">
-              <a:buNone/>
-            </a:pPr>
-            <a:r>
-              <a:rPr lang="en-US" sz="2400" b="1" dirty="0">
-                <a:solidFill>
-                  <a:srgbClr val="EDF1F0"/>
-                </a:solidFill>
-                <a:latin typeface="Malgun Gothic" pitchFamily="34" charset="0"/>
-                <a:ea typeface="Malgun Gothic" pitchFamily="34" charset="-122"/>
-                <a:cs typeface="Malgun Gothic" pitchFamily="34" charset="-120"/>
-              </a:rPr>
-              <a:t>02</a:t>
-            </a:r>
-            <a:endParaRPr lang="en-US" sz="2400" dirty="0"/>
-          </a:p>
-        </p:txBody>
-      </p:sp>
-      <p:sp>
-        <p:nvSpPr>
-          <p:cNvPr id="12" name="Text 10"/>
-          <p:cNvSpPr txBox="1"/>
-          <p:nvPr/>
-        </p:nvSpPr>
-        <p:spPr>
-          <a:xfrm>
-            <a:off x="1691640" y="3410712"/>
-            <a:ext cx="3291840" cy="777240"/>
-          </a:xfrm>
-          <a:prstGeom prst="rect">
-            <a:avLst/>
-          </a:prstGeom>
-          <a:noFill/>
-          <a:ln/>
-        </p:spPr>
-        <p:txBody>
-          <a:bodyPr wrap="square" lIns="0" tIns="0" rIns="0" bIns="0" rtlCol="0" anchor="ctr"/>
-          <a:lstStyle/>
-          <a:p>
-            <a:pPr indent="0" marL="0">
-              <a:buNone/>
-            </a:pPr>
-            <a:r>
-              <a:rPr lang="en-US" sz="1550" b="1" dirty="0">
-                <a:solidFill>
-                  <a:srgbClr val="17211F"/>
-                </a:solidFill>
-                <a:latin typeface="Malgun Gothic" pitchFamily="34" charset="0"/>
-                <a:ea typeface="Malgun Gothic" pitchFamily="34" charset="-122"/>
-                <a:cs typeface="Malgun Gothic" pitchFamily="34" charset="-120"/>
-              </a:rPr>
-              <a:t>조합 · 상호작용</a:t>
-            </a:r>
-            <a:endParaRPr lang="en-US" sz="1550" dirty="0"/>
-          </a:p>
-        </p:txBody>
-      </p:sp>
-      <p:sp>
-        <p:nvSpPr>
-          <p:cNvPr id="13" name="Text 11"/>
-          <p:cNvSpPr txBox="1"/>
-          <p:nvPr/>
-        </p:nvSpPr>
-        <p:spPr>
-          <a:xfrm>
-            <a:off x="5074920" y="3410712"/>
-            <a:ext cx="4754880" cy="777240"/>
-          </a:xfrm>
-          <a:prstGeom prst="rect">
-            <a:avLst/>
-          </a:prstGeom>
-          <a:noFill/>
-          <a:ln/>
-        </p:spPr>
-        <p:txBody>
-          <a:bodyPr wrap="square" lIns="0" tIns="0" rIns="0" bIns="0" rtlCol="0" anchor="ctr"/>
-          <a:lstStyle/>
-          <a:p>
-            <a:pPr indent="0" marL="0">
-              <a:buNone/>
-            </a:pPr>
-            <a:r>
-              <a:rPr lang="en-US" sz="1300" dirty="0">
+      <p:pic>
+        <p:nvPicPr>
+          <p:cNvPr id="8" name="Image 1" descr="/home/user/diabetes/evidence_select.png">    </p:cNvPr>
+          <p:cNvPicPr>
+            <a:picLocks noChangeAspect="1"/>
+          </p:cNvPicPr>
+          <p:nvPr/>
+        </p:nvPicPr>
+        <p:blipFill>
+          <a:blip r:embed="rId2"/>
+          <a:stretch>
+            <a:fillRect/>
+          </a:stretch>
+        </p:blipFill>
+        <p:spPr>
+          <a:xfrm>
+            <a:off x="6675120" y="1874520"/>
+            <a:ext cx="3657600" cy="3657600"/>
+          </a:xfrm>
+          <a:prstGeom prst="rect">
+            <a:avLst/>
+          </a:prstGeom>
+        </p:spPr>
+      </p:pic>
+      <p:sp>
+        <p:nvSpPr>
+          <p:cNvPr id="9" name="Text 5"/>
+          <p:cNvSpPr txBox="1"/>
+          <p:nvPr/>
+        </p:nvSpPr>
+        <p:spPr>
+          <a:xfrm>
+            <a:off x="6675120" y="5669280"/>
+            <a:ext cx="4114800" cy="320040"/>
+          </a:xfrm>
+          <a:prstGeom prst="rect">
+            <a:avLst/>
+          </a:prstGeom>
+          <a:noFill/>
+          <a:ln/>
+        </p:spPr>
+        <p:txBody>
+          <a:bodyPr wrap="square" lIns="0" tIns="0" rIns="0" bIns="0" rtlCol="0" anchor="ctr"/>
+          <a:lstStyle/>
+          <a:p>
+            <a:pPr indent="0" marL="0">
+              <a:buNone/>
+            </a:pPr>
+            <a:r>
+              <a:rPr lang="en-US" sz="1200" b="1" dirty="0">
+                <a:solidFill>
+                  <a:srgbClr val="0E7C74"/>
+                </a:solidFill>
+                <a:latin typeface="Malgun Gothic" pitchFamily="34" charset="0"/>
+                <a:ea typeface="Malgun Gothic" pitchFamily="34" charset="-122"/>
+                <a:cs typeface="Malgun Gothic" pitchFamily="34" charset="-120"/>
+              </a:rPr>
+              <a:t>SELECT 확인   </a:t>
+            </a:r>
+            <a:pPr indent="0" marL="0">
+              <a:buNone/>
+            </a:pPr>
+            <a:r>
+              <a:rPr lang="en-US" sz="1200" dirty="0">
                 <a:solidFill>
                   <a:srgbClr val="7C8A87"/>
                 </a:solidFill>
@@ -6514,443 +7179,7 @@
                 <a:ea typeface="Malgun Gothic" pitchFamily="34" charset="-122"/>
                 <a:cs typeface="Malgun Gothic" pitchFamily="34" charset="-120"/>
               </a:rPr>
-              <a:t>위험요인 개수, 고혈압 × 비만 등 복합 위험</a:t>
-            </a:r>
-            <a:endParaRPr lang="en-US" sz="1300" dirty="0"/>
-          </a:p>
-        </p:txBody>
-      </p:sp>
-      <p:sp>
-        <p:nvSpPr>
-          <p:cNvPr id="14" name="Text 12"/>
-          <p:cNvSpPr txBox="1"/>
-          <p:nvPr/>
-        </p:nvSpPr>
-        <p:spPr>
-          <a:xfrm>
-            <a:off x="9875520" y="3410712"/>
-            <a:ext cx="1554480" cy="777240"/>
-          </a:xfrm>
-          <a:prstGeom prst="rect">
-            <a:avLst/>
-          </a:prstGeom>
-          <a:noFill/>
-          <a:ln/>
-        </p:spPr>
-        <p:txBody>
-          <a:bodyPr wrap="square" lIns="0" tIns="0" rIns="0" bIns="0" rtlCol="0" anchor="ctr"/>
-          <a:lstStyle/>
-          <a:p>
-            <a:pPr indent="0" marL="0">
-              <a:buNone/>
-            </a:pPr>
-            <a:r>
-              <a:rPr lang="en-US" sz="1050" dirty="0">
-                <a:solidFill>
-                  <a:srgbClr val="0E7C74"/>
-                </a:solidFill>
-                <a:latin typeface="Malgun Gothic" pitchFamily="34" charset="0"/>
-                <a:ea typeface="Malgun Gothic" pitchFamily="34" charset="-122"/>
-                <a:cs typeface="Malgun Gothic" pitchFamily="34" charset="-120"/>
-              </a:rPr>
-              <a:t>다중 조건 집계</a:t>
-            </a:r>
-            <a:endParaRPr lang="en-US" sz="1050" dirty="0"/>
-          </a:p>
-        </p:txBody>
-      </p:sp>
-      <p:sp>
-        <p:nvSpPr>
-          <p:cNvPr id="15" name="Shape 13"/>
-          <p:cNvSpPr/>
-          <p:nvPr/>
-        </p:nvSpPr>
-        <p:spPr>
-          <a:xfrm>
-            <a:off x="731520" y="4215384"/>
-            <a:ext cx="10698480" cy="0"/>
-          </a:xfrm>
-          <a:prstGeom prst="line">
-            <a:avLst/>
-          </a:prstGeom>
-          <a:noFill/>
-          <a:ln w="12700">
-            <a:solidFill>
-              <a:srgbClr val="DBE4E1"/>
-            </a:solidFill>
-            <a:prstDash val="solid"/>
-          </a:ln>
-        </p:spPr>
-      </p:sp>
-      <p:sp>
-        <p:nvSpPr>
-          <p:cNvPr id="16" name="Text 14"/>
-          <p:cNvSpPr txBox="1"/>
-          <p:nvPr/>
-        </p:nvSpPr>
-        <p:spPr>
-          <a:xfrm>
-            <a:off x="731520" y="4306824"/>
-            <a:ext cx="822960" cy="777240"/>
-          </a:xfrm>
-          <a:prstGeom prst="rect">
-            <a:avLst/>
-          </a:prstGeom>
-          <a:noFill/>
-          <a:ln/>
-        </p:spPr>
-        <p:txBody>
-          <a:bodyPr wrap="square" lIns="0" tIns="0" rIns="0" bIns="0" rtlCol="0" anchor="ctr"/>
-          <a:lstStyle/>
-          <a:p>
-            <a:pPr indent="0" marL="0">
-              <a:buNone/>
-            </a:pPr>
-            <a:r>
-              <a:rPr lang="en-US" sz="2400" b="1" dirty="0">
-                <a:solidFill>
-                  <a:srgbClr val="EDF1F0"/>
-                </a:solidFill>
-                <a:latin typeface="Malgun Gothic" pitchFamily="34" charset="0"/>
-                <a:ea typeface="Malgun Gothic" pitchFamily="34" charset="-122"/>
-                <a:cs typeface="Malgun Gothic" pitchFamily="34" charset="-120"/>
-              </a:rPr>
-              <a:t>03</a:t>
-            </a:r>
-            <a:endParaRPr lang="en-US" sz="2400" dirty="0"/>
-          </a:p>
-        </p:txBody>
-      </p:sp>
-      <p:sp>
-        <p:nvSpPr>
-          <p:cNvPr id="17" name="Text 15"/>
-          <p:cNvSpPr txBox="1"/>
-          <p:nvPr/>
-        </p:nvSpPr>
-        <p:spPr>
-          <a:xfrm>
-            <a:off x="1691640" y="4306824"/>
-            <a:ext cx="3291840" cy="777240"/>
-          </a:xfrm>
-          <a:prstGeom prst="rect">
-            <a:avLst/>
-          </a:prstGeom>
-          <a:noFill/>
-          <a:ln/>
-        </p:spPr>
-        <p:txBody>
-          <a:bodyPr wrap="square" lIns="0" tIns="0" rIns="0" bIns="0" rtlCol="0" anchor="ctr"/>
-          <a:lstStyle/>
-          <a:p>
-            <a:pPr indent="0" marL="0">
-              <a:buNone/>
-            </a:pPr>
-            <a:r>
-              <a:rPr lang="en-US" sz="1550" b="1" dirty="0">
-                <a:solidFill>
-                  <a:srgbClr val="17211F"/>
-                </a:solidFill>
-                <a:latin typeface="Malgun Gothic" pitchFamily="34" charset="0"/>
-                <a:ea typeface="Malgun Gothic" pitchFamily="34" charset="-122"/>
-                <a:cs typeface="Malgun Gothic" pitchFamily="34" charset="-120"/>
-              </a:rPr>
-              <a:t>통계 검정</a:t>
-            </a:r>
-            <a:endParaRPr lang="en-US" sz="1550" dirty="0"/>
-          </a:p>
-        </p:txBody>
-      </p:sp>
-      <p:sp>
-        <p:nvSpPr>
-          <p:cNvPr id="18" name="Text 16"/>
-          <p:cNvSpPr txBox="1"/>
-          <p:nvPr/>
-        </p:nvSpPr>
-        <p:spPr>
-          <a:xfrm>
-            <a:off x="5074920" y="4306824"/>
-            <a:ext cx="4754880" cy="777240"/>
-          </a:xfrm>
-          <a:prstGeom prst="rect">
-            <a:avLst/>
-          </a:prstGeom>
-          <a:noFill/>
-          <a:ln/>
-        </p:spPr>
-        <p:txBody>
-          <a:bodyPr wrap="square" lIns="0" tIns="0" rIns="0" bIns="0" rtlCol="0" anchor="ctr"/>
-          <a:lstStyle/>
-          <a:p>
-            <a:pPr indent="0" marL="0">
-              <a:buNone/>
-            </a:pPr>
-            <a:r>
-              <a:rPr lang="en-US" sz="1300" dirty="0">
-                <a:solidFill>
-                  <a:srgbClr val="7C8A87"/>
-                </a:solidFill>
-                <a:latin typeface="Malgun Gothic" pitchFamily="34" charset="0"/>
-                <a:ea typeface="Malgun Gothic" pitchFamily="34" charset="-122"/>
-                <a:cs typeface="Malgun Gothic" pitchFamily="34" charset="-120"/>
-              </a:rPr>
-              <a:t>요인별 오즈비(Odds Ratio) · 카이제곱 검정</a:t>
-            </a:r>
-            <a:endParaRPr lang="en-US" sz="1300" dirty="0"/>
-          </a:p>
-        </p:txBody>
-      </p:sp>
-      <p:sp>
-        <p:nvSpPr>
-          <p:cNvPr id="19" name="Text 17"/>
-          <p:cNvSpPr txBox="1"/>
-          <p:nvPr/>
-        </p:nvSpPr>
-        <p:spPr>
-          <a:xfrm>
-            <a:off x="9875520" y="4306824"/>
-            <a:ext cx="1554480" cy="777240"/>
-          </a:xfrm>
-          <a:prstGeom prst="rect">
-            <a:avLst/>
-          </a:prstGeom>
-          <a:noFill/>
-          <a:ln/>
-        </p:spPr>
-        <p:txBody>
-          <a:bodyPr wrap="square" lIns="0" tIns="0" rIns="0" bIns="0" rtlCol="0" anchor="ctr"/>
-          <a:lstStyle/>
-          <a:p>
-            <a:pPr indent="0" marL="0">
-              <a:buNone/>
-            </a:pPr>
-            <a:r>
-              <a:rPr lang="en-US" sz="1050" dirty="0">
-                <a:solidFill>
-                  <a:srgbClr val="0E7C74"/>
-                </a:solidFill>
-                <a:latin typeface="Malgun Gothic" pitchFamily="34" charset="0"/>
-                <a:ea typeface="Malgun Gothic" pitchFamily="34" charset="-122"/>
-                <a:cs typeface="Malgun Gothic" pitchFamily="34" charset="-120"/>
-              </a:rPr>
-              <a:t>이진 데이터에 적합</a:t>
-            </a:r>
-            <a:endParaRPr lang="en-US" sz="1050" dirty="0"/>
-          </a:p>
-        </p:txBody>
-      </p:sp>
-      <p:sp>
-        <p:nvSpPr>
-          <p:cNvPr id="20" name="Shape 18"/>
-          <p:cNvSpPr/>
-          <p:nvPr/>
-        </p:nvSpPr>
-        <p:spPr>
-          <a:xfrm>
-            <a:off x="731520" y="5111496"/>
-            <a:ext cx="10698480" cy="0"/>
-          </a:xfrm>
-          <a:prstGeom prst="line">
-            <a:avLst/>
-          </a:prstGeom>
-          <a:noFill/>
-          <a:ln w="12700">
-            <a:solidFill>
-              <a:srgbClr val="DBE4E1"/>
-            </a:solidFill>
-            <a:prstDash val="solid"/>
-          </a:ln>
-        </p:spPr>
-      </p:sp>
-      <p:sp>
-        <p:nvSpPr>
-          <p:cNvPr id="21" name="Text 19"/>
-          <p:cNvSpPr txBox="1"/>
-          <p:nvPr/>
-        </p:nvSpPr>
-        <p:spPr>
-          <a:xfrm>
-            <a:off x="731520" y="5202936"/>
-            <a:ext cx="822960" cy="777240"/>
-          </a:xfrm>
-          <a:prstGeom prst="rect">
-            <a:avLst/>
-          </a:prstGeom>
-          <a:noFill/>
-          <a:ln/>
-        </p:spPr>
-        <p:txBody>
-          <a:bodyPr wrap="square" lIns="0" tIns="0" rIns="0" bIns="0" rtlCol="0" anchor="ctr"/>
-          <a:lstStyle/>
-          <a:p>
-            <a:pPr indent="0" marL="0">
-              <a:buNone/>
-            </a:pPr>
-            <a:r>
-              <a:rPr lang="en-US" sz="2400" b="1" dirty="0">
-                <a:solidFill>
-                  <a:srgbClr val="EDF1F0"/>
-                </a:solidFill>
-                <a:latin typeface="Malgun Gothic" pitchFamily="34" charset="0"/>
-                <a:ea typeface="Malgun Gothic" pitchFamily="34" charset="-122"/>
-                <a:cs typeface="Malgun Gothic" pitchFamily="34" charset="-120"/>
-              </a:rPr>
-              <a:t>04</a:t>
-            </a:r>
-            <a:endParaRPr lang="en-US" sz="2400" dirty="0"/>
-          </a:p>
-        </p:txBody>
-      </p:sp>
-      <p:sp>
-        <p:nvSpPr>
-          <p:cNvPr id="22" name="Text 20"/>
-          <p:cNvSpPr txBox="1"/>
-          <p:nvPr/>
-        </p:nvSpPr>
-        <p:spPr>
-          <a:xfrm>
-            <a:off x="1691640" y="5202936"/>
-            <a:ext cx="3291840" cy="777240"/>
-          </a:xfrm>
-          <a:prstGeom prst="rect">
-            <a:avLst/>
-          </a:prstGeom>
-          <a:noFill/>
-          <a:ln/>
-        </p:spPr>
-        <p:txBody>
-          <a:bodyPr wrap="square" lIns="0" tIns="0" rIns="0" bIns="0" rtlCol="0" anchor="ctr"/>
-          <a:lstStyle/>
-          <a:p>
-            <a:pPr indent="0" marL="0">
-              <a:buNone/>
-            </a:pPr>
-            <a:r>
-              <a:rPr lang="en-US" sz="1550" b="1" dirty="0">
-                <a:solidFill>
-                  <a:srgbClr val="17211F"/>
-                </a:solidFill>
-                <a:latin typeface="Malgun Gothic" pitchFamily="34" charset="0"/>
-                <a:ea typeface="Malgun Gothic" pitchFamily="34" charset="-122"/>
-                <a:cs typeface="Malgun Gothic" pitchFamily="34" charset="-120"/>
-              </a:rPr>
-              <a:t>예측 모델링</a:t>
-            </a:r>
-            <a:endParaRPr lang="en-US" sz="1550" dirty="0"/>
-          </a:p>
-        </p:txBody>
-      </p:sp>
-      <p:sp>
-        <p:nvSpPr>
-          <p:cNvPr id="23" name="Text 21"/>
-          <p:cNvSpPr txBox="1"/>
-          <p:nvPr/>
-        </p:nvSpPr>
-        <p:spPr>
-          <a:xfrm>
-            <a:off x="5074920" y="5202936"/>
-            <a:ext cx="4754880" cy="777240"/>
-          </a:xfrm>
-          <a:prstGeom prst="rect">
-            <a:avLst/>
-          </a:prstGeom>
-          <a:noFill/>
-          <a:ln/>
-        </p:spPr>
-        <p:txBody>
-          <a:bodyPr wrap="square" lIns="0" tIns="0" rIns="0" bIns="0" rtlCol="0" anchor="ctr"/>
-          <a:lstStyle/>
-          <a:p>
-            <a:pPr indent="0" marL="0">
-              <a:buNone/>
-            </a:pPr>
-            <a:r>
-              <a:rPr lang="en-US" sz="1300" dirty="0">
-                <a:solidFill>
-                  <a:srgbClr val="7C8A87"/>
-                </a:solidFill>
-                <a:latin typeface="Malgun Gothic" pitchFamily="34" charset="0"/>
-                <a:ea typeface="Malgun Gothic" pitchFamily="34" charset="-122"/>
-                <a:cs typeface="Malgun Gothic" pitchFamily="34" charset="-120"/>
-              </a:rPr>
-              <a:t>로지스틱 회귀로 위험요인 기여도 추정</a:t>
-            </a:r>
-            <a:endParaRPr lang="en-US" sz="1300" dirty="0"/>
-          </a:p>
-        </p:txBody>
-      </p:sp>
-      <p:sp>
-        <p:nvSpPr>
-          <p:cNvPr id="24" name="Text 22"/>
-          <p:cNvSpPr txBox="1"/>
-          <p:nvPr/>
-        </p:nvSpPr>
-        <p:spPr>
-          <a:xfrm>
-            <a:off x="9875520" y="5202936"/>
-            <a:ext cx="1554480" cy="777240"/>
-          </a:xfrm>
-          <a:prstGeom prst="rect">
-            <a:avLst/>
-          </a:prstGeom>
-          <a:noFill/>
-          <a:ln/>
-        </p:spPr>
-        <p:txBody>
-          <a:bodyPr wrap="square" lIns="0" tIns="0" rIns="0" bIns="0" rtlCol="0" anchor="ctr"/>
-          <a:lstStyle/>
-          <a:p>
-            <a:pPr indent="0" marL="0">
-              <a:buNone/>
-            </a:pPr>
-            <a:r>
-              <a:rPr lang="en-US" sz="1050" dirty="0">
-                <a:solidFill>
-                  <a:srgbClr val="0E7C74"/>
-                </a:solidFill>
-                <a:latin typeface="Malgun Gothic" pitchFamily="34" charset="0"/>
-                <a:ea typeface="Malgun Gothic" pitchFamily="34" charset="-122"/>
-                <a:cs typeface="Malgun Gothic" pitchFamily="34" charset="-120"/>
-              </a:rPr>
-              <a:t>2 · 3단계 진행</a:t>
-            </a:r>
-            <a:endParaRPr lang="en-US" sz="1050" dirty="0"/>
-          </a:p>
-        </p:txBody>
-      </p:sp>
-      <p:sp>
-        <p:nvSpPr>
-          <p:cNvPr id="25" name="Text 23"/>
-          <p:cNvSpPr txBox="1"/>
-          <p:nvPr/>
-        </p:nvSpPr>
-        <p:spPr>
-          <a:xfrm>
-            <a:off x="731520" y="6172200"/>
-            <a:ext cx="10698480" cy="320040"/>
-          </a:xfrm>
-          <a:prstGeom prst="rect">
-            <a:avLst/>
-          </a:prstGeom>
-          <a:noFill/>
-          <a:ln/>
-        </p:spPr>
-        <p:txBody>
-          <a:bodyPr wrap="square" lIns="0" tIns="0" rIns="0" bIns="0" rtlCol="0" anchor="ctr"/>
-          <a:lstStyle/>
-          <a:p>
-            <a:pPr indent="0" marL="0">
-              <a:buNone/>
-            </a:pPr>
-            <a:r>
-              <a:rPr lang="en-US" sz="1200" i="1" dirty="0">
-                <a:solidFill>
-                  <a:srgbClr val="0E7C74"/>
-                </a:solidFill>
-                <a:latin typeface="Malgun Gothic" pitchFamily="34" charset="0"/>
-                <a:ea typeface="Malgun Gothic" pitchFamily="34" charset="-122"/>
-                <a:cs typeface="Malgun Gothic" pitchFamily="34" charset="-120"/>
-              </a:rPr>
-              <a:t>분석 결과 저장 테이블(ANALYSIS_RESULT)까지 1단계에서 설계 완료 → 2단계에서 채웁니다.</a:t>
+              <a:t>데이터 정상 조회</a:t>
             </a:r>
             <a:endParaRPr lang="en-US" sz="1200" dirty="0"/>
           </a:p>
@@ -6958,7 +7187,7 @@
       </p:sp>
       <p:sp>
         <p:nvSpPr>
-          <p:cNvPr id="26" name="Text 24"/>
+          <p:cNvPr id="10" name="Text 6"/>
           <p:cNvSpPr txBox="1"/>
           <p:nvPr/>
         </p:nvSpPr>
@@ -6989,7 +7218,7 @@
                 <a:ea typeface="Malgun Gothic" pitchFamily="34" charset="-122"/>
                 <a:cs typeface="Malgun Gothic" pitchFamily="34" charset="-120"/>
               </a:rPr>
-              <a:t>08  /  09</a:t>
+              <a:t>08  /  10</a:t>
             </a:r>
             <a:endParaRPr lang="en-US" sz="900" dirty="0"/>
           </a:p>
@@ -7060,7 +7289,7 @@
                 <a:ea typeface="Malgun Gothic" pitchFamily="34" charset="-122"/>
                 <a:cs typeface="Malgun Gothic" pitchFamily="34" charset="-120"/>
               </a:rPr>
-              <a:t>1단계 마무리</a:t>
+              <a:t>분석 계획</a:t>
             </a:r>
             <a:endParaRPr lang="en-US" sz="1100" dirty="0"/>
           </a:p>
@@ -7074,44 +7303,24 @@
         </p:nvSpPr>
         <p:spPr>
           <a:xfrm>
-            <a:off x="731520" y="1051560"/>
-            <a:ext cx="10332720" cy="1280160"/>
-          </a:xfrm>
-          <a:prstGeom prst="rect">
-            <a:avLst/>
-          </a:prstGeom>
-          <a:noFill/>
-          <a:ln/>
-        </p:spPr>
-        <p:txBody>
-          <a:bodyPr wrap="square" lIns="0" tIns="0" rIns="0" bIns="0" rtlCol="0" anchor="ctr"/>
-          <a:lstStyle/>
-          <a:p>
-            <a:pPr indent="0" marL="0">
-              <a:lnSpc>
-                <a:spcPct val="118000"/>
-              </a:lnSpc>
-              <a:buNone/>
-            </a:pPr>
-            <a:r>
-              <a:rPr lang="en-US" sz="2500" b="1" dirty="0">
-                <a:solidFill>
-                  <a:srgbClr val="0E7C74"/>
-                </a:solidFill>
-                <a:latin typeface="Malgun Gothic" pitchFamily="34" charset="0"/>
-                <a:ea typeface="Malgun Gothic" pitchFamily="34" charset="-122"/>
-                <a:cs typeface="Malgun Gothic" pitchFamily="34" charset="-120"/>
-              </a:rPr>
-              <a:t>주제 · 데이터 · DB 설계 · 데이터 입력</a:t>
-            </a:r>
-            <a:pPr indent="0" marL="0">
-              <a:lnSpc>
-                <a:spcPct val="118000"/>
-              </a:lnSpc>
-              <a:buNone/>
-            </a:pPr>
-            <a:r>
-              <a:rPr lang="en-US" sz="2500" b="1" dirty="0">
+            <a:off x="731520" y="868680"/>
+            <a:ext cx="10698480" cy="640080"/>
+          </a:xfrm>
+          <a:prstGeom prst="rect">
+            <a:avLst/>
+          </a:prstGeom>
+          <a:noFill/>
+          <a:ln/>
+        </p:spPr>
+        <p:txBody>
+          <a:bodyPr wrap="square" lIns="0" tIns="0" rIns="0" bIns="0" rtlCol="0" anchor="ctr"/>
+          <a:lstStyle/>
+          <a:p>
+            <a:pPr indent="0" marL="0">
+              <a:buNone/>
+            </a:pPr>
+            <a:r>
+              <a:rPr lang="en-US" sz="2700" b="1" dirty="0">
                 <a:solidFill>
                   <a:srgbClr val="17211F"/>
                 </a:solidFill>
@@ -7119,41 +7328,60 @@
                 <a:ea typeface="Malgun Gothic" pitchFamily="34" charset="-122"/>
                 <a:cs typeface="Malgun Gothic" pitchFamily="34" charset="-120"/>
               </a:rPr>
-              <a:t>까지</a:t>
-            </a:r>
-            <a:endParaRPr lang="en-US" sz="2500" dirty="0"/>
-          </a:p>
-          <a:p>
-            <a:pPr indent="0" marL="0">
-              <a:lnSpc>
-                <a:spcPct val="118000"/>
-              </a:lnSpc>
-              <a:buNone/>
-            </a:pPr>
-            <a:r>
-              <a:rPr lang="en-US" sz="2500" b="1" dirty="0">
-                <a:solidFill>
-                  <a:srgbClr val="17211F"/>
-                </a:solidFill>
-                <a:latin typeface="Malgun Gothic" pitchFamily="34" charset="0"/>
-                <a:ea typeface="Malgun Gothic" pitchFamily="34" charset="-122"/>
-                <a:cs typeface="Malgun Gothic" pitchFamily="34" charset="-120"/>
-              </a:rPr>
-              <a:t>1단계를 완료했습니다.</a:t>
-            </a:r>
-            <a:endParaRPr lang="en-US" sz="2500" dirty="0"/>
-          </a:p>
-        </p:txBody>
-      </p:sp>
-      <p:sp>
-        <p:nvSpPr>
-          <p:cNvPr id="4" name="Shape 2"/>
+              <a:t>2단계에서 수행할 분석</a:t>
+            </a:r>
+            <a:endParaRPr lang="en-US" sz="2700" dirty="0"/>
+          </a:p>
+        </p:txBody>
+      </p:sp>
+      <p:sp>
+        <p:nvSpPr>
+          <p:cNvPr id="4" name="Text 2"/>
+          <p:cNvSpPr txBox="1"/>
+          <p:nvPr/>
+        </p:nvSpPr>
+        <p:spPr>
+          <a:xfrm>
+            <a:off x="731520" y="1600200"/>
+            <a:ext cx="10332720" cy="457200"/>
+          </a:xfrm>
+          <a:prstGeom prst="rect">
+            <a:avLst/>
+          </a:prstGeom>
+          <a:noFill/>
+          <a:ln/>
+        </p:spPr>
+        <p:txBody>
+          <a:bodyPr wrap="square" lIns="0" tIns="0" rIns="0" bIns="0" rtlCol="0" anchor="ctr"/>
+          <a:lstStyle/>
+          <a:p>
+            <a:pPr indent="0" marL="0">
+              <a:buNone/>
+            </a:pPr>
+            <a:r>
+              <a:rPr lang="en-US" sz="1450" dirty="0">
+                <a:solidFill>
+                  <a:srgbClr val="7C8A87"/>
+                </a:solidFill>
+                <a:latin typeface="Malgun Gothic" pitchFamily="34" charset="0"/>
+                <a:ea typeface="Malgun Gothic" pitchFamily="34" charset="-122"/>
+                <a:cs typeface="Malgun Gothic" pitchFamily="34" charset="-120"/>
+              </a:rPr>
+              <a:t>정규화된 DB를 SQL로 질의해 위험요인을 규명하고, 그 결과를 ANALYSIS_RESULT 테이블에 저장합니다.</a:t>
+            </a:r>
+            <a:endParaRPr lang="en-US" sz="1450" dirty="0"/>
+          </a:p>
+        </p:txBody>
+      </p:sp>
+      <p:sp>
+        <p:nvSpPr>
+          <p:cNvPr id="5" name="Shape 3"/>
           <p:cNvSpPr/>
           <p:nvPr/>
         </p:nvSpPr>
         <p:spPr>
           <a:xfrm>
-            <a:off x="731520" y="2788920"/>
+            <a:off x="731520" y="2286000"/>
             <a:ext cx="10698480" cy="0"/>
           </a:xfrm>
           <a:prstGeom prst="line">
@@ -7170,30 +7398,147 @@
       </p:sp>
       <p:sp>
         <p:nvSpPr>
-          <p:cNvPr id="5" name="Text 3"/>
-          <p:cNvSpPr txBox="1"/>
-          <p:nvPr/>
-        </p:nvSpPr>
-        <p:spPr>
-          <a:xfrm>
-            <a:off x="731520" y="3017520"/>
-            <a:ext cx="4572000" cy="320040"/>
-          </a:xfrm>
-          <a:prstGeom prst="rect">
-            <a:avLst/>
-          </a:prstGeom>
-          <a:noFill/>
-          <a:ln/>
-        </p:spPr>
-        <p:txBody>
-          <a:bodyPr wrap="square" lIns="0" tIns="0" rIns="0" bIns="0" rtlCol="0" anchor="ctr"/>
-          <a:lstStyle/>
-          <a:p>
-            <a:pPr indent="0" marL="0">
-              <a:buNone/>
-            </a:pPr>
-            <a:r>
-              <a:rPr lang="en-US" sz="1200" b="1" spc="200" kern="0" dirty="0">
+          <p:cNvPr id="6" name="Text 4"/>
+          <p:cNvSpPr txBox="1"/>
+          <p:nvPr/>
+        </p:nvSpPr>
+        <p:spPr>
+          <a:xfrm>
+            <a:off x="731520" y="2514600"/>
+            <a:ext cx="822960" cy="777240"/>
+          </a:xfrm>
+          <a:prstGeom prst="rect">
+            <a:avLst/>
+          </a:prstGeom>
+          <a:noFill/>
+          <a:ln/>
+        </p:spPr>
+        <p:txBody>
+          <a:bodyPr wrap="square" lIns="0" tIns="0" rIns="0" bIns="0" rtlCol="0" anchor="ctr"/>
+          <a:lstStyle/>
+          <a:p>
+            <a:pPr indent="0" marL="0">
+              <a:buNone/>
+            </a:pPr>
+            <a:r>
+              <a:rPr lang="en-US" sz="2400" b="1" dirty="0">
+                <a:solidFill>
+                  <a:srgbClr val="EDF1F0"/>
+                </a:solidFill>
+                <a:latin typeface="Malgun Gothic" pitchFamily="34" charset="0"/>
+                <a:ea typeface="Malgun Gothic" pitchFamily="34" charset="-122"/>
+                <a:cs typeface="Malgun Gothic" pitchFamily="34" charset="-120"/>
+              </a:rPr>
+              <a:t>01</a:t>
+            </a:r>
+            <a:endParaRPr lang="en-US" sz="2400" dirty="0"/>
+          </a:p>
+        </p:txBody>
+      </p:sp>
+      <p:sp>
+        <p:nvSpPr>
+          <p:cNvPr id="7" name="Text 5"/>
+          <p:cNvSpPr txBox="1"/>
+          <p:nvPr/>
+        </p:nvSpPr>
+        <p:spPr>
+          <a:xfrm>
+            <a:off x="1691640" y="2514600"/>
+            <a:ext cx="3291840" cy="777240"/>
+          </a:xfrm>
+          <a:prstGeom prst="rect">
+            <a:avLst/>
+          </a:prstGeom>
+          <a:noFill/>
+          <a:ln/>
+        </p:spPr>
+        <p:txBody>
+          <a:bodyPr wrap="square" lIns="0" tIns="0" rIns="0" bIns="0" rtlCol="0" anchor="ctr"/>
+          <a:lstStyle/>
+          <a:p>
+            <a:pPr indent="0" marL="0">
+              <a:buNone/>
+            </a:pPr>
+            <a:r>
+              <a:rPr lang="en-US" sz="1550" b="1" dirty="0">
+                <a:solidFill>
+                  <a:srgbClr val="17211F"/>
+                </a:solidFill>
+                <a:latin typeface="Malgun Gothic" pitchFamily="34" charset="0"/>
+                <a:ea typeface="Malgun Gothic" pitchFamily="34" charset="-122"/>
+                <a:cs typeface="Malgun Gothic" pitchFamily="34" charset="-120"/>
+              </a:rPr>
+              <a:t>기술 통계 분석</a:t>
+            </a:r>
+            <a:endParaRPr lang="en-US" sz="1550" dirty="0"/>
+          </a:p>
+        </p:txBody>
+      </p:sp>
+      <p:sp>
+        <p:nvSpPr>
+          <p:cNvPr id="8" name="Text 6"/>
+          <p:cNvSpPr txBox="1"/>
+          <p:nvPr/>
+        </p:nvSpPr>
+        <p:spPr>
+          <a:xfrm>
+            <a:off x="5074920" y="2514600"/>
+            <a:ext cx="4754880" cy="777240"/>
+          </a:xfrm>
+          <a:prstGeom prst="rect">
+            <a:avLst/>
+          </a:prstGeom>
+          <a:noFill/>
+          <a:ln/>
+        </p:spPr>
+        <p:txBody>
+          <a:bodyPr wrap="square" lIns="0" tIns="0" rIns="0" bIns="0" rtlCol="0" anchor="ctr"/>
+          <a:lstStyle/>
+          <a:p>
+            <a:pPr indent="0" marL="0">
+              <a:buNone/>
+            </a:pPr>
+            <a:r>
+              <a:rPr lang="en-US" sz="1300" dirty="0">
+                <a:solidFill>
+                  <a:srgbClr val="7C8A87"/>
+                </a:solidFill>
+                <a:latin typeface="Malgun Gothic" pitchFamily="34" charset="0"/>
+                <a:ea typeface="Malgun Gothic" pitchFamily="34" charset="-122"/>
+                <a:cs typeface="Malgun Gothic" pitchFamily="34" charset="-120"/>
+              </a:rPr>
+              <a:t>연령·성별·BMI·소득·학력별 당뇨병 비율</a:t>
+            </a:r>
+            <a:endParaRPr lang="en-US" sz="1300" dirty="0"/>
+          </a:p>
+        </p:txBody>
+      </p:sp>
+      <p:sp>
+        <p:nvSpPr>
+          <p:cNvPr id="9" name="Text 7"/>
+          <p:cNvSpPr txBox="1"/>
+          <p:nvPr/>
+        </p:nvSpPr>
+        <p:spPr>
+          <a:xfrm>
+            <a:off x="9875520" y="2514600"/>
+            <a:ext cx="1554480" cy="777240"/>
+          </a:xfrm>
+          <a:prstGeom prst="rect">
+            <a:avLst/>
+          </a:prstGeom>
+          <a:noFill/>
+          <a:ln/>
+        </p:spPr>
+        <p:txBody>
+          <a:bodyPr wrap="square" lIns="0" tIns="0" rIns="0" bIns="0" rtlCol="0" anchor="ctr"/>
+          <a:lstStyle/>
+          <a:p>
+            <a:pPr indent="0" marL="0">
+              <a:buNone/>
+            </a:pPr>
+            <a:r>
+              <a:rPr lang="en-US" sz="1050" dirty="0">
                 <a:solidFill>
                   <a:srgbClr val="0E7C74"/>
                 </a:solidFill>
@@ -7201,100 +7546,22 @@
                 <a:ea typeface="Malgun Gothic" pitchFamily="34" charset="-122"/>
                 <a:cs typeface="Malgun Gothic" pitchFamily="34" charset="-120"/>
               </a:rPr>
-              <a:t>역할 분담</a:t>
-            </a:r>
-            <a:endParaRPr lang="en-US" sz="1200" dirty="0"/>
-          </a:p>
-        </p:txBody>
-      </p:sp>
-      <p:sp>
-        <p:nvSpPr>
-          <p:cNvPr id="6" name="Text 4"/>
-          <p:cNvSpPr txBox="1"/>
-          <p:nvPr/>
-        </p:nvSpPr>
-        <p:spPr>
-          <a:xfrm>
-            <a:off x="731520" y="3429000"/>
-            <a:ext cx="3840480" cy="457200"/>
-          </a:xfrm>
-          <a:prstGeom prst="rect">
-            <a:avLst/>
-          </a:prstGeom>
-          <a:noFill/>
-          <a:ln/>
-        </p:spPr>
-        <p:txBody>
-          <a:bodyPr wrap="square" lIns="0" tIns="0" rIns="0" bIns="0" rtlCol="0" anchor="ctr"/>
-          <a:lstStyle/>
-          <a:p>
-            <a:pPr indent="0" marL="0">
-              <a:buNone/>
-            </a:pPr>
-            <a:r>
-              <a:rPr lang="en-US" sz="1400" dirty="0">
-                <a:solidFill>
-                  <a:srgbClr val="17211F"/>
-                </a:solidFill>
-                <a:latin typeface="Malgun Gothic" pitchFamily="34" charset="0"/>
-                <a:ea typeface="Malgun Gothic" pitchFamily="34" charset="-122"/>
-                <a:cs typeface="Malgun Gothic" pitchFamily="34" charset="-120"/>
-              </a:rPr>
-              <a:t>주제·데이터</a:t>
-            </a:r>
-            <a:endParaRPr lang="en-US" sz="1400" dirty="0"/>
-          </a:p>
-        </p:txBody>
-      </p:sp>
-      <p:sp>
-        <p:nvSpPr>
-          <p:cNvPr id="7" name="Text 5"/>
-          <p:cNvSpPr txBox="1"/>
-          <p:nvPr/>
-        </p:nvSpPr>
-        <p:spPr>
-          <a:xfrm>
-            <a:off x="4572000" y="3429000"/>
-            <a:ext cx="1463040" cy="457200"/>
-          </a:xfrm>
-          <a:prstGeom prst="rect">
-            <a:avLst/>
-          </a:prstGeom>
-          <a:noFill/>
-          <a:ln/>
-        </p:spPr>
-        <p:txBody>
-          <a:bodyPr wrap="square" lIns="0" tIns="0" rIns="0" bIns="0" rtlCol="0" anchor="ctr"/>
-          <a:lstStyle/>
-          <a:p>
-            <a:pPr indent="0" marL="0">
-              <a:buNone/>
-            </a:pPr>
-            <a:r>
-              <a:rPr lang="en-US" sz="1400" b="1" dirty="0">
-                <a:solidFill>
-                  <a:srgbClr val="7C8A87"/>
-                </a:solidFill>
-                <a:latin typeface="Malgun Gothic" pitchFamily="34" charset="0"/>
-                <a:ea typeface="Malgun Gothic" pitchFamily="34" charset="-122"/>
-                <a:cs typeface="Malgun Gothic" pitchFamily="34" charset="-120"/>
-              </a:rPr>
-              <a:t>OOO</a:t>
-            </a:r>
-            <a:endParaRPr lang="en-US" sz="1400" dirty="0"/>
-          </a:p>
-        </p:txBody>
-      </p:sp>
-      <p:sp>
-        <p:nvSpPr>
-          <p:cNvPr id="8" name="Shape 6"/>
+              <a:t>GROUP BY · CASE · AVG</a:t>
+            </a:r>
+            <a:endParaRPr lang="en-US" sz="1050" dirty="0"/>
+          </a:p>
+        </p:txBody>
+      </p:sp>
+      <p:sp>
+        <p:nvSpPr>
+          <p:cNvPr id="10" name="Shape 8"/>
           <p:cNvSpPr/>
           <p:nvPr/>
         </p:nvSpPr>
         <p:spPr>
           <a:xfrm>
-            <a:off x="731520" y="3931920"/>
-            <a:ext cx="5303520" cy="0"/>
+            <a:off x="731520" y="3319272"/>
+            <a:ext cx="10698480" cy="0"/>
           </a:xfrm>
           <a:prstGeom prst="line">
             <a:avLst/>
@@ -7310,30 +7577,69 @@
       </p:sp>
       <p:sp>
         <p:nvSpPr>
-          <p:cNvPr id="9" name="Text 7"/>
-          <p:cNvSpPr txBox="1"/>
-          <p:nvPr/>
-        </p:nvSpPr>
-        <p:spPr>
-          <a:xfrm>
-            <a:off x="731520" y="3995928"/>
-            <a:ext cx="3840480" cy="457200"/>
-          </a:xfrm>
-          <a:prstGeom prst="rect">
-            <a:avLst/>
-          </a:prstGeom>
-          <a:noFill/>
-          <a:ln/>
-        </p:spPr>
-        <p:txBody>
-          <a:bodyPr wrap="square" lIns="0" tIns="0" rIns="0" bIns="0" rtlCol="0" anchor="ctr"/>
-          <a:lstStyle/>
-          <a:p>
-            <a:pPr indent="0" marL="0">
-              <a:buNone/>
-            </a:pPr>
-            <a:r>
-              <a:rPr lang="en-US" sz="1400" dirty="0">
+          <p:cNvPr id="11" name="Text 9"/>
+          <p:cNvSpPr txBox="1"/>
+          <p:nvPr/>
+        </p:nvSpPr>
+        <p:spPr>
+          <a:xfrm>
+            <a:off x="731520" y="3410712"/>
+            <a:ext cx="822960" cy="777240"/>
+          </a:xfrm>
+          <a:prstGeom prst="rect">
+            <a:avLst/>
+          </a:prstGeom>
+          <a:noFill/>
+          <a:ln/>
+        </p:spPr>
+        <p:txBody>
+          <a:bodyPr wrap="square" lIns="0" tIns="0" rIns="0" bIns="0" rtlCol="0" anchor="ctr"/>
+          <a:lstStyle/>
+          <a:p>
+            <a:pPr indent="0" marL="0">
+              <a:buNone/>
+            </a:pPr>
+            <a:r>
+              <a:rPr lang="en-US" sz="2400" b="1" dirty="0">
+                <a:solidFill>
+                  <a:srgbClr val="EDF1F0"/>
+                </a:solidFill>
+                <a:latin typeface="Malgun Gothic" pitchFamily="34" charset="0"/>
+                <a:ea typeface="Malgun Gothic" pitchFamily="34" charset="-122"/>
+                <a:cs typeface="Malgun Gothic" pitchFamily="34" charset="-120"/>
+              </a:rPr>
+              <a:t>02</a:t>
+            </a:r>
+            <a:endParaRPr lang="en-US" sz="2400" dirty="0"/>
+          </a:p>
+        </p:txBody>
+      </p:sp>
+      <p:sp>
+        <p:nvSpPr>
+          <p:cNvPr id="12" name="Text 10"/>
+          <p:cNvSpPr txBox="1"/>
+          <p:nvPr/>
+        </p:nvSpPr>
+        <p:spPr>
+          <a:xfrm>
+            <a:off x="1691640" y="3410712"/>
+            <a:ext cx="3291840" cy="777240"/>
+          </a:xfrm>
+          <a:prstGeom prst="rect">
+            <a:avLst/>
+          </a:prstGeom>
+          <a:noFill/>
+          <a:ln/>
+        </p:spPr>
+        <p:txBody>
+          <a:bodyPr wrap="square" lIns="0" tIns="0" rIns="0" bIns="0" rtlCol="0" anchor="ctr"/>
+          <a:lstStyle/>
+          <a:p>
+            <a:pPr indent="0" marL="0">
+              <a:buNone/>
+            </a:pPr>
+            <a:r>
+              <a:rPr lang="en-US" sz="1550" b="1" dirty="0">
                 <a:solidFill>
                   <a:srgbClr val="17211F"/>
                 </a:solidFill>
@@ -7341,38 +7647,38 @@
                 <a:ea typeface="Malgun Gothic" pitchFamily="34" charset="-122"/>
                 <a:cs typeface="Malgun Gothic" pitchFamily="34" charset="-120"/>
               </a:rPr>
-              <a:t>DB 설계·ER</a:t>
-            </a:r>
-            <a:endParaRPr lang="en-US" sz="1400" dirty="0"/>
-          </a:p>
-        </p:txBody>
-      </p:sp>
-      <p:sp>
-        <p:nvSpPr>
-          <p:cNvPr id="10" name="Text 8"/>
-          <p:cNvSpPr txBox="1"/>
-          <p:nvPr/>
-        </p:nvSpPr>
-        <p:spPr>
-          <a:xfrm>
-            <a:off x="4572000" y="3995928"/>
-            <a:ext cx="1463040" cy="457200"/>
-          </a:xfrm>
-          <a:prstGeom prst="rect">
-            <a:avLst/>
-          </a:prstGeom>
-          <a:noFill/>
-          <a:ln/>
-        </p:spPr>
-        <p:txBody>
-          <a:bodyPr wrap="square" lIns="0" tIns="0" rIns="0" bIns="0" rtlCol="0" anchor="ctr"/>
-          <a:lstStyle/>
-          <a:p>
-            <a:pPr indent="0" marL="0">
-              <a:buNone/>
-            </a:pPr>
-            <a:r>
-              <a:rPr lang="en-US" sz="1400" b="1" dirty="0">
+              <a:t>조합 · 상호작용</a:t>
+            </a:r>
+            <a:endParaRPr lang="en-US" sz="1550" dirty="0"/>
+          </a:p>
+        </p:txBody>
+      </p:sp>
+      <p:sp>
+        <p:nvSpPr>
+          <p:cNvPr id="13" name="Text 11"/>
+          <p:cNvSpPr txBox="1"/>
+          <p:nvPr/>
+        </p:nvSpPr>
+        <p:spPr>
+          <a:xfrm>
+            <a:off x="5074920" y="3410712"/>
+            <a:ext cx="4754880" cy="777240"/>
+          </a:xfrm>
+          <a:prstGeom prst="rect">
+            <a:avLst/>
+          </a:prstGeom>
+          <a:noFill/>
+          <a:ln/>
+        </p:spPr>
+        <p:txBody>
+          <a:bodyPr wrap="square" lIns="0" tIns="0" rIns="0" bIns="0" rtlCol="0" anchor="ctr"/>
+          <a:lstStyle/>
+          <a:p>
+            <a:pPr indent="0" marL="0">
+              <a:buNone/>
+            </a:pPr>
+            <a:r>
+              <a:rPr lang="en-US" sz="1300" dirty="0">
                 <a:solidFill>
                   <a:srgbClr val="7C8A87"/>
                 </a:solidFill>
@@ -7380,22 +7686,61 @@
                 <a:ea typeface="Malgun Gothic" pitchFamily="34" charset="-122"/>
                 <a:cs typeface="Malgun Gothic" pitchFamily="34" charset="-120"/>
               </a:rPr>
-              <a:t>OOO</a:t>
-            </a:r>
-            <a:endParaRPr lang="en-US" sz="1400" dirty="0"/>
-          </a:p>
-        </p:txBody>
-      </p:sp>
-      <p:sp>
-        <p:nvSpPr>
-          <p:cNvPr id="11" name="Shape 9"/>
+              <a:t>위험요인 개수, 고혈압 × 비만 등 복합 위험</a:t>
+            </a:r>
+            <a:endParaRPr lang="en-US" sz="1300" dirty="0"/>
+          </a:p>
+        </p:txBody>
+      </p:sp>
+      <p:sp>
+        <p:nvSpPr>
+          <p:cNvPr id="14" name="Text 12"/>
+          <p:cNvSpPr txBox="1"/>
+          <p:nvPr/>
+        </p:nvSpPr>
+        <p:spPr>
+          <a:xfrm>
+            <a:off x="9875520" y="3410712"/>
+            <a:ext cx="1554480" cy="777240"/>
+          </a:xfrm>
+          <a:prstGeom prst="rect">
+            <a:avLst/>
+          </a:prstGeom>
+          <a:noFill/>
+          <a:ln/>
+        </p:spPr>
+        <p:txBody>
+          <a:bodyPr wrap="square" lIns="0" tIns="0" rIns="0" bIns="0" rtlCol="0" anchor="ctr"/>
+          <a:lstStyle/>
+          <a:p>
+            <a:pPr indent="0" marL="0">
+              <a:buNone/>
+            </a:pPr>
+            <a:r>
+              <a:rPr lang="en-US" sz="1050" dirty="0">
+                <a:solidFill>
+                  <a:srgbClr val="0E7C74"/>
+                </a:solidFill>
+                <a:latin typeface="Malgun Gothic" pitchFamily="34" charset="0"/>
+                <a:ea typeface="Malgun Gothic" pitchFamily="34" charset="-122"/>
+                <a:cs typeface="Malgun Gothic" pitchFamily="34" charset="-120"/>
+              </a:rPr>
+              <a:t>다중 조건 집계</a:t>
+            </a:r>
+            <a:endParaRPr lang="en-US" sz="1050" dirty="0"/>
+          </a:p>
+        </p:txBody>
+      </p:sp>
+      <p:sp>
+        <p:nvSpPr>
+          <p:cNvPr id="15" name="Shape 13"/>
           <p:cNvSpPr/>
           <p:nvPr/>
         </p:nvSpPr>
         <p:spPr>
           <a:xfrm>
-            <a:off x="731520" y="4498848"/>
-            <a:ext cx="5303520" cy="0"/>
+            <a:off x="731520" y="4215384"/>
+            <a:ext cx="10698480" cy="0"/>
           </a:xfrm>
           <a:prstGeom prst="line">
             <a:avLst/>
@@ -7411,30 +7756,69 @@
       </p:sp>
       <p:sp>
         <p:nvSpPr>
-          <p:cNvPr id="12" name="Text 10"/>
-          <p:cNvSpPr txBox="1"/>
-          <p:nvPr/>
-        </p:nvSpPr>
-        <p:spPr>
-          <a:xfrm>
-            <a:off x="731520" y="4562856"/>
-            <a:ext cx="3840480" cy="457200"/>
-          </a:xfrm>
-          <a:prstGeom prst="rect">
-            <a:avLst/>
-          </a:prstGeom>
-          <a:noFill/>
-          <a:ln/>
-        </p:spPr>
-        <p:txBody>
-          <a:bodyPr wrap="square" lIns="0" tIns="0" rIns="0" bIns="0" rtlCol="0" anchor="ctr"/>
-          <a:lstStyle/>
-          <a:p>
-            <a:pPr indent="0" marL="0">
-              <a:buNone/>
-            </a:pPr>
-            <a:r>
-              <a:rPr lang="en-US" sz="1400" dirty="0">
+          <p:cNvPr id="16" name="Text 14"/>
+          <p:cNvSpPr txBox="1"/>
+          <p:nvPr/>
+        </p:nvSpPr>
+        <p:spPr>
+          <a:xfrm>
+            <a:off x="731520" y="4306824"/>
+            <a:ext cx="822960" cy="777240"/>
+          </a:xfrm>
+          <a:prstGeom prst="rect">
+            <a:avLst/>
+          </a:prstGeom>
+          <a:noFill/>
+          <a:ln/>
+        </p:spPr>
+        <p:txBody>
+          <a:bodyPr wrap="square" lIns="0" tIns="0" rIns="0" bIns="0" rtlCol="0" anchor="ctr"/>
+          <a:lstStyle/>
+          <a:p>
+            <a:pPr indent="0" marL="0">
+              <a:buNone/>
+            </a:pPr>
+            <a:r>
+              <a:rPr lang="en-US" sz="2400" b="1" dirty="0">
+                <a:solidFill>
+                  <a:srgbClr val="EDF1F0"/>
+                </a:solidFill>
+                <a:latin typeface="Malgun Gothic" pitchFamily="34" charset="0"/>
+                <a:ea typeface="Malgun Gothic" pitchFamily="34" charset="-122"/>
+                <a:cs typeface="Malgun Gothic" pitchFamily="34" charset="-120"/>
+              </a:rPr>
+              <a:t>03</a:t>
+            </a:r>
+            <a:endParaRPr lang="en-US" sz="2400" dirty="0"/>
+          </a:p>
+        </p:txBody>
+      </p:sp>
+      <p:sp>
+        <p:nvSpPr>
+          <p:cNvPr id="17" name="Text 15"/>
+          <p:cNvSpPr txBox="1"/>
+          <p:nvPr/>
+        </p:nvSpPr>
+        <p:spPr>
+          <a:xfrm>
+            <a:off x="1691640" y="4306824"/>
+            <a:ext cx="3291840" cy="777240"/>
+          </a:xfrm>
+          <a:prstGeom prst="rect">
+            <a:avLst/>
+          </a:prstGeom>
+          <a:noFill/>
+          <a:ln/>
+        </p:spPr>
+        <p:txBody>
+          <a:bodyPr wrap="square" lIns="0" tIns="0" rIns="0" bIns="0" rtlCol="0" anchor="ctr"/>
+          <a:lstStyle/>
+          <a:p>
+            <a:pPr indent="0" marL="0">
+              <a:buNone/>
+            </a:pPr>
+            <a:r>
+              <a:rPr lang="en-US" sz="1550" b="1" dirty="0">
                 <a:solidFill>
                   <a:srgbClr val="17211F"/>
                 </a:solidFill>
@@ -7442,38 +7826,38 @@
                 <a:ea typeface="Malgun Gothic" pitchFamily="34" charset="-122"/>
                 <a:cs typeface="Malgun Gothic" pitchFamily="34" charset="-120"/>
               </a:rPr>
-              <a:t>DB 구현·입력</a:t>
-            </a:r>
-            <a:endParaRPr lang="en-US" sz="1400" dirty="0"/>
-          </a:p>
-        </p:txBody>
-      </p:sp>
-      <p:sp>
-        <p:nvSpPr>
-          <p:cNvPr id="13" name="Text 11"/>
-          <p:cNvSpPr txBox="1"/>
-          <p:nvPr/>
-        </p:nvSpPr>
-        <p:spPr>
-          <a:xfrm>
-            <a:off x="4572000" y="4562856"/>
-            <a:ext cx="1463040" cy="457200"/>
-          </a:xfrm>
-          <a:prstGeom prst="rect">
-            <a:avLst/>
-          </a:prstGeom>
-          <a:noFill/>
-          <a:ln/>
-        </p:spPr>
-        <p:txBody>
-          <a:bodyPr wrap="square" lIns="0" tIns="0" rIns="0" bIns="0" rtlCol="0" anchor="ctr"/>
-          <a:lstStyle/>
-          <a:p>
-            <a:pPr indent="0" marL="0">
-              <a:buNone/>
-            </a:pPr>
-            <a:r>
-              <a:rPr lang="en-US" sz="1400" b="1" dirty="0">
+              <a:t>통계 검정</a:t>
+            </a:r>
+            <a:endParaRPr lang="en-US" sz="1550" dirty="0"/>
+          </a:p>
+        </p:txBody>
+      </p:sp>
+      <p:sp>
+        <p:nvSpPr>
+          <p:cNvPr id="18" name="Text 16"/>
+          <p:cNvSpPr txBox="1"/>
+          <p:nvPr/>
+        </p:nvSpPr>
+        <p:spPr>
+          <a:xfrm>
+            <a:off x="5074920" y="4306824"/>
+            <a:ext cx="4754880" cy="777240"/>
+          </a:xfrm>
+          <a:prstGeom prst="rect">
+            <a:avLst/>
+          </a:prstGeom>
+          <a:noFill/>
+          <a:ln/>
+        </p:spPr>
+        <p:txBody>
+          <a:bodyPr wrap="square" lIns="0" tIns="0" rIns="0" bIns="0" rtlCol="0" anchor="ctr"/>
+          <a:lstStyle/>
+          <a:p>
+            <a:pPr indent="0" marL="0">
+              <a:buNone/>
+            </a:pPr>
+            <a:r>
+              <a:rPr lang="en-US" sz="1300" dirty="0">
                 <a:solidFill>
                   <a:srgbClr val="7C8A87"/>
                 </a:solidFill>
@@ -7481,22 +7865,61 @@
                 <a:ea typeface="Malgun Gothic" pitchFamily="34" charset="-122"/>
                 <a:cs typeface="Malgun Gothic" pitchFamily="34" charset="-120"/>
               </a:rPr>
-              <a:t>OOO</a:t>
-            </a:r>
-            <a:endParaRPr lang="en-US" sz="1400" dirty="0"/>
-          </a:p>
-        </p:txBody>
-      </p:sp>
-      <p:sp>
-        <p:nvSpPr>
-          <p:cNvPr id="14" name="Shape 12"/>
+              <a:t>요인별 오즈비(Odds Ratio) · 카이제곱 검정</a:t>
+            </a:r>
+            <a:endParaRPr lang="en-US" sz="1300" dirty="0"/>
+          </a:p>
+        </p:txBody>
+      </p:sp>
+      <p:sp>
+        <p:nvSpPr>
+          <p:cNvPr id="19" name="Text 17"/>
+          <p:cNvSpPr txBox="1"/>
+          <p:nvPr/>
+        </p:nvSpPr>
+        <p:spPr>
+          <a:xfrm>
+            <a:off x="9875520" y="4306824"/>
+            <a:ext cx="1554480" cy="777240"/>
+          </a:xfrm>
+          <a:prstGeom prst="rect">
+            <a:avLst/>
+          </a:prstGeom>
+          <a:noFill/>
+          <a:ln/>
+        </p:spPr>
+        <p:txBody>
+          <a:bodyPr wrap="square" lIns="0" tIns="0" rIns="0" bIns="0" rtlCol="0" anchor="ctr"/>
+          <a:lstStyle/>
+          <a:p>
+            <a:pPr indent="0" marL="0">
+              <a:buNone/>
+            </a:pPr>
+            <a:r>
+              <a:rPr lang="en-US" sz="1050" dirty="0">
+                <a:solidFill>
+                  <a:srgbClr val="0E7C74"/>
+                </a:solidFill>
+                <a:latin typeface="Malgun Gothic" pitchFamily="34" charset="0"/>
+                <a:ea typeface="Malgun Gothic" pitchFamily="34" charset="-122"/>
+                <a:cs typeface="Malgun Gothic" pitchFamily="34" charset="-120"/>
+              </a:rPr>
+              <a:t>이진 데이터에 적합</a:t>
+            </a:r>
+            <a:endParaRPr lang="en-US" sz="1050" dirty="0"/>
+          </a:p>
+        </p:txBody>
+      </p:sp>
+      <p:sp>
+        <p:nvSpPr>
+          <p:cNvPr id="20" name="Shape 18"/>
           <p:cNvSpPr/>
           <p:nvPr/>
         </p:nvSpPr>
         <p:spPr>
           <a:xfrm>
-            <a:off x="731520" y="5065776"/>
-            <a:ext cx="5303520" cy="0"/>
+            <a:off x="731520" y="5111496"/>
+            <a:ext cx="10698480" cy="0"/>
           </a:xfrm>
           <a:prstGeom prst="line">
             <a:avLst/>
@@ -7512,30 +7935,69 @@
       </p:sp>
       <p:sp>
         <p:nvSpPr>
-          <p:cNvPr id="15" name="Text 13"/>
-          <p:cNvSpPr txBox="1"/>
-          <p:nvPr/>
-        </p:nvSpPr>
-        <p:spPr>
-          <a:xfrm>
-            <a:off x="731520" y="5129784"/>
-            <a:ext cx="3840480" cy="457200"/>
-          </a:xfrm>
-          <a:prstGeom prst="rect">
-            <a:avLst/>
-          </a:prstGeom>
-          <a:noFill/>
-          <a:ln/>
-        </p:spPr>
-        <p:txBody>
-          <a:bodyPr wrap="square" lIns="0" tIns="0" rIns="0" bIns="0" rtlCol="0" anchor="ctr"/>
-          <a:lstStyle/>
-          <a:p>
-            <a:pPr indent="0" marL="0">
-              <a:buNone/>
-            </a:pPr>
-            <a:r>
-              <a:rPr lang="en-US" sz="1400" dirty="0">
+          <p:cNvPr id="21" name="Text 19"/>
+          <p:cNvSpPr txBox="1"/>
+          <p:nvPr/>
+        </p:nvSpPr>
+        <p:spPr>
+          <a:xfrm>
+            <a:off x="731520" y="5202936"/>
+            <a:ext cx="822960" cy="777240"/>
+          </a:xfrm>
+          <a:prstGeom prst="rect">
+            <a:avLst/>
+          </a:prstGeom>
+          <a:noFill/>
+          <a:ln/>
+        </p:spPr>
+        <p:txBody>
+          <a:bodyPr wrap="square" lIns="0" tIns="0" rIns="0" bIns="0" rtlCol="0" anchor="ctr"/>
+          <a:lstStyle/>
+          <a:p>
+            <a:pPr indent="0" marL="0">
+              <a:buNone/>
+            </a:pPr>
+            <a:r>
+              <a:rPr lang="en-US" sz="2400" b="1" dirty="0">
+                <a:solidFill>
+                  <a:srgbClr val="EDF1F0"/>
+                </a:solidFill>
+                <a:latin typeface="Malgun Gothic" pitchFamily="34" charset="0"/>
+                <a:ea typeface="Malgun Gothic" pitchFamily="34" charset="-122"/>
+                <a:cs typeface="Malgun Gothic" pitchFamily="34" charset="-120"/>
+              </a:rPr>
+              <a:t>04</a:t>
+            </a:r>
+            <a:endParaRPr lang="en-US" sz="2400" dirty="0"/>
+          </a:p>
+        </p:txBody>
+      </p:sp>
+      <p:sp>
+        <p:nvSpPr>
+          <p:cNvPr id="22" name="Text 20"/>
+          <p:cNvSpPr txBox="1"/>
+          <p:nvPr/>
+        </p:nvSpPr>
+        <p:spPr>
+          <a:xfrm>
+            <a:off x="1691640" y="5202936"/>
+            <a:ext cx="3291840" cy="777240"/>
+          </a:xfrm>
+          <a:prstGeom prst="rect">
+            <a:avLst/>
+          </a:prstGeom>
+          <a:noFill/>
+          <a:ln/>
+        </p:spPr>
+        <p:txBody>
+          <a:bodyPr wrap="square" lIns="0" tIns="0" rIns="0" bIns="0" rtlCol="0" anchor="ctr"/>
+          <a:lstStyle/>
+          <a:p>
+            <a:pPr indent="0" marL="0">
+              <a:buNone/>
+            </a:pPr>
+            <a:r>
+              <a:rPr lang="en-US" sz="1550" b="1" dirty="0">
                 <a:solidFill>
                   <a:srgbClr val="17211F"/>
                 </a:solidFill>
@@ -7543,38 +8005,38 @@
                 <a:ea typeface="Malgun Gothic" pitchFamily="34" charset="-122"/>
                 <a:cs typeface="Malgun Gothic" pitchFamily="34" charset="-120"/>
               </a:rPr>
-              <a:t>SQL 분석·발표</a:t>
-            </a:r>
-            <a:endParaRPr lang="en-US" sz="1400" dirty="0"/>
-          </a:p>
-        </p:txBody>
-      </p:sp>
-      <p:sp>
-        <p:nvSpPr>
-          <p:cNvPr id="16" name="Text 14"/>
-          <p:cNvSpPr txBox="1"/>
-          <p:nvPr/>
-        </p:nvSpPr>
-        <p:spPr>
-          <a:xfrm>
-            <a:off x="4572000" y="5129784"/>
-            <a:ext cx="1463040" cy="457200"/>
-          </a:xfrm>
-          <a:prstGeom prst="rect">
-            <a:avLst/>
-          </a:prstGeom>
-          <a:noFill/>
-          <a:ln/>
-        </p:spPr>
-        <p:txBody>
-          <a:bodyPr wrap="square" lIns="0" tIns="0" rIns="0" bIns="0" rtlCol="0" anchor="ctr"/>
-          <a:lstStyle/>
-          <a:p>
-            <a:pPr indent="0" marL="0">
-              <a:buNone/>
-            </a:pPr>
-            <a:r>
-              <a:rPr lang="en-US" sz="1400" b="1" dirty="0">
+              <a:t>예측 모델링</a:t>
+            </a:r>
+            <a:endParaRPr lang="en-US" sz="1550" dirty="0"/>
+          </a:p>
+        </p:txBody>
+      </p:sp>
+      <p:sp>
+        <p:nvSpPr>
+          <p:cNvPr id="23" name="Text 21"/>
+          <p:cNvSpPr txBox="1"/>
+          <p:nvPr/>
+        </p:nvSpPr>
+        <p:spPr>
+          <a:xfrm>
+            <a:off x="5074920" y="5202936"/>
+            <a:ext cx="4754880" cy="777240"/>
+          </a:xfrm>
+          <a:prstGeom prst="rect">
+            <a:avLst/>
+          </a:prstGeom>
+          <a:noFill/>
+          <a:ln/>
+        </p:spPr>
+        <p:txBody>
+          <a:bodyPr wrap="square" lIns="0" tIns="0" rIns="0" bIns="0" rtlCol="0" anchor="ctr"/>
+          <a:lstStyle/>
+          <a:p>
+            <a:pPr indent="0" marL="0">
+              <a:buNone/>
+            </a:pPr>
+            <a:r>
+              <a:rPr lang="en-US" sz="1300" dirty="0">
                 <a:solidFill>
                   <a:srgbClr val="7C8A87"/>
                 </a:solidFill>
@@ -7582,58 +8044,38 @@
                 <a:ea typeface="Malgun Gothic" pitchFamily="34" charset="-122"/>
                 <a:cs typeface="Malgun Gothic" pitchFamily="34" charset="-120"/>
               </a:rPr>
-              <a:t>OOO</a:t>
-            </a:r>
-            <a:endParaRPr lang="en-US" sz="1400" dirty="0"/>
-          </a:p>
-        </p:txBody>
-      </p:sp>
-      <p:sp>
-        <p:nvSpPr>
-          <p:cNvPr id="17" name="Shape 15"/>
-          <p:cNvSpPr/>
-          <p:nvPr/>
-        </p:nvSpPr>
-        <p:spPr>
-          <a:xfrm>
-            <a:off x="6675120" y="3429000"/>
-            <a:ext cx="4754880" cy="2331720"/>
-          </a:xfrm>
-          <a:prstGeom prst="rect">
-            <a:avLst/>
-          </a:prstGeom>
-          <a:solidFill>
-            <a:srgbClr val="EDF1F0"/>
-          </a:solidFill>
-          <a:ln/>
-        </p:spPr>
-      </p:sp>
-      <p:sp>
-        <p:nvSpPr>
-          <p:cNvPr id="18" name="Text 16"/>
-          <p:cNvSpPr txBox="1"/>
-          <p:nvPr/>
-        </p:nvSpPr>
-        <p:spPr>
-          <a:xfrm>
-            <a:off x="6949440" y="3657600"/>
-            <a:ext cx="3657600" cy="320040"/>
-          </a:xfrm>
-          <a:prstGeom prst="rect">
-            <a:avLst/>
-          </a:prstGeom>
-          <a:noFill/>
-          <a:ln/>
-        </p:spPr>
-        <p:txBody>
-          <a:bodyPr wrap="square" lIns="0" tIns="0" rIns="0" bIns="0" rtlCol="0" anchor="ctr"/>
-          <a:lstStyle/>
-          <a:p>
-            <a:pPr indent="0" marL="0">
-              <a:buNone/>
-            </a:pPr>
-            <a:r>
-              <a:rPr lang="en-US" sz="1200" b="1" spc="200" kern="0" dirty="0">
+              <a:t>로지스틱 회귀로 위험요인 기여도 추정</a:t>
+            </a:r>
+            <a:endParaRPr lang="en-US" sz="1300" dirty="0"/>
+          </a:p>
+        </p:txBody>
+      </p:sp>
+      <p:sp>
+        <p:nvSpPr>
+          <p:cNvPr id="24" name="Text 22"/>
+          <p:cNvSpPr txBox="1"/>
+          <p:nvPr/>
+        </p:nvSpPr>
+        <p:spPr>
+          <a:xfrm>
+            <a:off x="9875520" y="5202936"/>
+            <a:ext cx="1554480" cy="777240"/>
+          </a:xfrm>
+          <a:prstGeom prst="rect">
+            <a:avLst/>
+          </a:prstGeom>
+          <a:noFill/>
+          <a:ln/>
+        </p:spPr>
+        <p:txBody>
+          <a:bodyPr wrap="square" lIns="0" tIns="0" rIns="0" bIns="0" rtlCol="0" anchor="ctr"/>
+          <a:lstStyle/>
+          <a:p>
+            <a:pPr indent="0" marL="0">
+              <a:buNone/>
+            </a:pPr>
+            <a:r>
+              <a:rPr lang="en-US" sz="1050" dirty="0">
                 <a:solidFill>
                   <a:srgbClr val="0E7C74"/>
                 </a:solidFill>
@@ -7641,7 +8083,46 @@
                 <a:ea typeface="Malgun Gothic" pitchFamily="34" charset="-122"/>
                 <a:cs typeface="Malgun Gothic" pitchFamily="34" charset="-120"/>
               </a:rPr>
-              <a:t>조원 소감</a:t>
+              <a:t>2 · 3단계 진행</a:t>
+            </a:r>
+            <a:endParaRPr lang="en-US" sz="1050" dirty="0"/>
+          </a:p>
+        </p:txBody>
+      </p:sp>
+      <p:sp>
+        <p:nvSpPr>
+          <p:cNvPr id="25" name="Text 23"/>
+          <p:cNvSpPr txBox="1"/>
+          <p:nvPr/>
+        </p:nvSpPr>
+        <p:spPr>
+          <a:xfrm>
+            <a:off x="731520" y="6172200"/>
+            <a:ext cx="10698480" cy="320040"/>
+          </a:xfrm>
+          <a:prstGeom prst="rect">
+            <a:avLst/>
+          </a:prstGeom>
+          <a:noFill/>
+          <a:ln/>
+        </p:spPr>
+        <p:txBody>
+          <a:bodyPr wrap="square" lIns="0" tIns="0" rIns="0" bIns="0" rtlCol="0" anchor="ctr"/>
+          <a:lstStyle/>
+          <a:p>
+            <a:pPr indent="0" marL="0">
+              <a:buNone/>
+            </a:pPr>
+            <a:r>
+              <a:rPr lang="en-US" sz="1200" i="1" dirty="0">
+                <a:solidFill>
+                  <a:srgbClr val="0E7C74"/>
+                </a:solidFill>
+                <a:latin typeface="Malgun Gothic" pitchFamily="34" charset="0"/>
+                <a:ea typeface="Malgun Gothic" pitchFamily="34" charset="-122"/>
+                <a:cs typeface="Malgun Gothic" pitchFamily="34" charset="-120"/>
+              </a:rPr>
+              <a:t>분석 결과 저장 테이블(ANALYSIS_RESULT)까지 1단계에서 설계 완료 → 2단계에서 채웁니다.</a:t>
             </a:r>
             <a:endParaRPr lang="en-US" sz="1200" dirty="0"/>
           </a:p>
@@ -7649,46 +8130,7 @@
       </p:sp>
       <p:sp>
         <p:nvSpPr>
-          <p:cNvPr id="19" name="Text 17"/>
-          <p:cNvSpPr txBox="1"/>
-          <p:nvPr/>
-        </p:nvSpPr>
-        <p:spPr>
-          <a:xfrm>
-            <a:off x="6949440" y="4069080"/>
-            <a:ext cx="4206240" cy="457200"/>
-          </a:xfrm>
-          <a:prstGeom prst="rect">
-            <a:avLst/>
-          </a:prstGeom>
-          <a:noFill/>
-          <a:ln/>
-        </p:spPr>
-        <p:txBody>
-          <a:bodyPr wrap="square" lIns="0" tIns="0" rIns="0" bIns="0" rtlCol="0" anchor="ctr"/>
-          <a:lstStyle/>
-          <a:p>
-            <a:pPr indent="0" marL="0">
-              <a:buNone/>
-            </a:pPr>
-            <a:r>
-              <a:rPr lang="en-US" sz="1300" dirty="0">
-                <a:solidFill>
-                  <a:srgbClr val="7C8A87"/>
-                </a:solidFill>
-                <a:latin typeface="Malgun Gothic" pitchFamily="34" charset="0"/>
-                <a:ea typeface="Malgun Gothic" pitchFamily="34" charset="-122"/>
-                <a:cs typeface="Malgun Gothic" pitchFamily="34" charset="-120"/>
-              </a:rPr>
-              <a:t>조원별로 한 줄씩 소감을 작성해 주세요.</a:t>
-            </a:r>
-            <a:endParaRPr lang="en-US" sz="1300" dirty="0"/>
-          </a:p>
-        </p:txBody>
-      </p:sp>
-      <p:sp>
-        <p:nvSpPr>
-          <p:cNvPr id="20" name="Text 18"/>
+          <p:cNvPr id="26" name="Text 24"/>
           <p:cNvSpPr txBox="1"/>
           <p:nvPr/>
         </p:nvSpPr>
@@ -7719,7 +8161,7 @@
                 <a:ea typeface="Malgun Gothic" pitchFamily="34" charset="-122"/>
                 <a:cs typeface="Malgun Gothic" pitchFamily="34" charset="-120"/>
               </a:rPr>
-              <a:t>09  /  09</a:t>
+              <a:t>09  /  10</a:t>
             </a:r>
             <a:endParaRPr lang="en-US" sz="900" dirty="0"/>
           </a:p>

</xml_diff>

<commit_message>
Swap evidence slide to DDL + JOIN screenshots (better Stage 1 proof)
Use two landscape SQL Developer screenshots: table/sequence creation and a
4-table JOIN result, replacing the analysis_result select.

Co-Authored-By: Claude Opus 4.8 <noreply@anthropic.com>
Claude-Session: https://claude.ai/code/session_01A4Eo5QUsuZLdygCXtGqGtG
</commit_message>
<xml_diff>
--- a/diabetes_project_stage1.pptx
+++ b/diabetes_project_stage1.pptx
@@ -6989,8 +6989,8 @@
         </p:nvSpPr>
         <p:spPr>
           <a:xfrm>
-            <a:off x="704088" y="1847088"/>
-            <a:ext cx="5724144" cy="3712464"/>
+            <a:off x="704088" y="1938528"/>
+            <a:ext cx="5312664" cy="3465576"/>
           </a:xfrm>
           <a:prstGeom prst="rect">
             <a:avLst/>
@@ -7022,8 +7022,8 @@
         </p:blipFill>
         <p:spPr>
           <a:xfrm>
-            <a:off x="731520" y="1874520"/>
-            <a:ext cx="5669280" cy="3657600"/>
+            <a:off x="731520" y="1965960"/>
+            <a:ext cx="5257800" cy="3410712"/>
           </a:xfrm>
           <a:prstGeom prst="rect">
             <a:avLst/>
@@ -7038,8 +7038,8 @@
         </p:nvSpPr>
         <p:spPr>
           <a:xfrm>
-            <a:off x="731520" y="5669280"/>
-            <a:ext cx="5669280" cy="320040"/>
+            <a:off x="731520" y="5532120"/>
+            <a:ext cx="5257800" cy="320040"/>
           </a:xfrm>
           <a:prstGeom prst="rect">
             <a:avLst/>
@@ -7091,8 +7091,8 @@
         </p:nvSpPr>
         <p:spPr>
           <a:xfrm>
-            <a:off x="6647688" y="1847088"/>
-            <a:ext cx="3712464" cy="3712464"/>
+            <a:off x="6144768" y="1938528"/>
+            <a:ext cx="5312664" cy="3465576"/>
           </a:xfrm>
           <a:prstGeom prst="rect">
             <a:avLst/>
@@ -7110,7 +7110,7 @@
       </p:sp>
       <p:pic>
         <p:nvPicPr>
-          <p:cNvPr id="8" name="Image 1" descr="/home/user/diabetes/evidence_select.png">    </p:cNvPr>
+          <p:cNvPr id="8" name="Image 1" descr="/home/user/diabetes/evidence_join.jpg">    </p:cNvPr>
           <p:cNvPicPr>
             <a:picLocks noChangeAspect="1"/>
           </p:cNvPicPr>
@@ -7124,8 +7124,8 @@
         </p:blipFill>
         <p:spPr>
           <a:xfrm>
-            <a:off x="6675120" y="1874520"/>
-            <a:ext cx="3657600" cy="3657600"/>
+            <a:off x="6172200" y="1965960"/>
+            <a:ext cx="5257800" cy="3410712"/>
           </a:xfrm>
           <a:prstGeom prst="rect">
             <a:avLst/>
@@ -7140,8 +7140,8 @@
         </p:nvSpPr>
         <p:spPr>
           <a:xfrm>
-            <a:off x="6675120" y="5669280"/>
-            <a:ext cx="4114800" cy="320040"/>
+            <a:off x="6172200" y="5532120"/>
+            <a:ext cx="5257800" cy="320040"/>
           </a:xfrm>
           <a:prstGeom prst="rect">
             <a:avLst/>
@@ -7165,7 +7165,7 @@
                 <a:ea typeface="Malgun Gothic" pitchFamily="34" charset="-122"/>
                 <a:cs typeface="Malgun Gothic" pitchFamily="34" charset="-120"/>
               </a:rPr>
-              <a:t>SELECT 확인   </a:t>
+              <a:t>JOIN 조회   </a:t>
             </a:r>
             <a:pPr indent="0" marL="0">
               <a:buNone/>
@@ -7179,7 +7179,7 @@
                 <a:ea typeface="Malgun Gothic" pitchFamily="34" charset="-122"/>
                 <a:cs typeface="Malgun Gothic" pitchFamily="34" charset="-120"/>
               </a:rPr>
-              <a:t>데이터 정상 조회</a:t>
+              <a:t>4개 테이블 연결 · 정상 조회</a:t>
             </a:r>
             <a:endParaRPr lang="en-US" sz="1200" dirty="0"/>
           </a:p>

</xml_diff>

<commit_message>
Use corrected row-count verification screenshot as evidence (all tables 236,378)
Co-Authored-By: Claude Opus 4.8 <noreply@anthropic.com>
Claude-Session: https://claude.ai/code/session_01A4Eo5QUsuZLdygCXtGqGtG
</commit_message>
<xml_diff>
--- a/diabetes_project_stage1.pptx
+++ b/diabetes_project_stage1.pptx
@@ -7110,7 +7110,7 @@
       </p:sp>
       <p:pic>
         <p:nvPicPr>
-          <p:cNvPr id="8" name="Image 1" descr="/home/user/diabetes/evidence_join.jpg">    </p:cNvPr>
+          <p:cNvPr id="8" name="Image 1" descr="/home/user/diabetes/evidence_verify.jpg">    </p:cNvPr>
           <p:cNvPicPr>
             <a:picLocks noChangeAspect="1"/>
           </p:cNvPicPr>
@@ -7165,7 +7165,7 @@
                 <a:ea typeface="Malgun Gothic" pitchFamily="34" charset="-122"/>
                 <a:cs typeface="Malgun Gothic" pitchFamily="34" charset="-120"/>
               </a:rPr>
-              <a:t>JOIN 조회   </a:t>
+              <a:t>행 수 검증   </a:t>
             </a:r>
             <a:pPr indent="0" marL="0">
               <a:buNone/>
@@ -7179,7 +7179,7 @@
                 <a:ea typeface="Malgun Gothic" pitchFamily="34" charset="-122"/>
                 <a:cs typeface="Malgun Gothic" pitchFamily="34" charset="-120"/>
               </a:rPr>
-              <a:t>4개 테이블 연결 · 정상 조회</a:t>
+              <a:t>4개 테이블 모두 236,378건</a:t>
             </a:r>
             <a:endParaRPr lang="en-US" sz="1200" dirty="0"/>
           </a:p>

</xml_diff>